<commit_message>
hata: araç fiyatları ve bağlantıları düzeltildi
</commit_message>
<xml_diff>
--- a/sunum/sunum.pptx
+++ b/sunum/sunum.pptx
@@ -129,14 +129,14 @@
   <p:extLst>
     <p:ext uri="{521415D9-36F7-43E2-AB2F-B90AF26B5E84}">
       <p14:sectionLst xmlns:p14="http://schemas.microsoft.com/office/powerpoint/2010/main">
-        <p14:section name="Giriş" id="{ec32e6c3-6e6d-cedd-6ae4-856b272e48ff}">
+        <p14:section name="Giriş" id="{13b6ccfd-38a4-d2ab-5623-3702edba8c80}">
           <p14:sldIdLst>
             <p14:sldId id="256"/>
             <p14:sldId id="257"/>
             <p14:sldId id="258"/>
           </p14:sldIdLst>
         </p14:section>
-        <p14:section name="01 · CV ve ATS" id="{27d994cd-2208-4c31-d4ba-291f73ec76d3}">
+        <p14:section name="01 · CV ve ATS" id="{31cbec3b-33d8-ec12-7ffa-4a44f29710d2}">
           <p14:sldIdLst>
             <p14:sldId id="259"/>
             <p14:sldId id="260"/>
@@ -145,7 +145,7 @@
             <p14:sldId id="263"/>
           </p14:sldIdLst>
         </p14:section>
-        <p14:section name="02 · CV'yi Kod Gibi Yönetmek" id="{cd05fade-53d8-28e7-56dd-90ea74ae4ce1}">
+        <p14:section name="02 · CV'yi Kod Gibi Yönetmek" id="{3c68e7b6-954c-223d-7562-4e761220a7be}">
           <p14:sldIdLst>
             <p14:sldId id="264"/>
             <p14:sldId id="265"/>
@@ -155,21 +155,21 @@
             <p14:sldId id="269"/>
           </p14:sldIdLst>
         </p14:section>
-        <p14:section name="03 · İlan Bulma" id="{3f119dd2-9e1b-7546-f544-63bbf3977a42}">
+        <p14:section name="03 · İlan Bulma" id="{8bcba2fa-1c24-f860-db9a-800fe55fec54}">
           <p14:sldIdLst>
             <p14:sldId id="270"/>
             <p14:sldId id="271"/>
             <p14:sldId id="272"/>
           </p14:sldIdLst>
         </p14:section>
-        <p14:section name="04 · Araç Haritası" id="{801acefa-fcb4-91b0-5f12-d732fbdf18fe}">
+        <p14:section name="04 · Araç Haritası" id="{4c7f75d4-c93f-dfb7-d769-c295cab2e23b}">
           <p14:sldIdLst>
             <p14:sldId id="273"/>
             <p14:sldId id="274"/>
             <p14:sldId id="275"/>
           </p14:sldIdLst>
         </p14:section>
-        <p14:section name="Kapanış" id="{37cc9ad7-8ab9-bbe2-0a78-cc4c1c848e8c}">
+        <p14:section name="Kapanış" id="{3f3b95fc-87aa-a03a-d6d8-765f933240a6}">
           <p14:sldIdLst>
             <p14:sldId id="276"/>
             <p14:sldId id="277"/>
@@ -12594,7 +12594,7 @@
                             <a:schemeClr val="tx1"/>
                           </a:solidFill>
                         </a:rPr>
-                        <a:t>Teal+ 29 $/ay</a:t>
+                        <a:t>Teal+ 29 $/30 gün</a:t>
                       </a:r>
                       <a:endParaRPr lang="en-US" sz="1600" dirty="0"/>
                     </a:p>
@@ -12718,7 +12718,7 @@
                             <a:schemeClr val="tx1"/>
                           </a:solidFill>
                         </a:rPr>
-                        <a:t>Kayıtta 5 tarama</a:t>
+                        <a:t>Ayda 5 tarama</a:t>
                       </a:r>
                       <a:endParaRPr lang="en-US" sz="1600" dirty="0"/>
                     </a:p>
@@ -13088,7 +13088,7 @@
                             <a:schemeClr val="tx1"/>
                           </a:solidFill>
                         </a:rPr>
-                        <a:t>Temel şablonlar</a:t>
+                        <a:t>4 temel CV şablonu</a:t>
                       </a:r>
                       <a:endParaRPr lang="en-US" sz="1600" dirty="0"/>
                     </a:p>
@@ -13149,7 +13149,7 @@
                             <a:schemeClr val="tx1"/>
                           </a:solidFill>
                         </a:rPr>
-                        <a:t>8 $/ay (yıllık)</a:t>
+                        <a:t>19 $/ay veya yıllık 54 $</a:t>
                       </a:r>
                       <a:endParaRPr lang="en-US" sz="1600" dirty="0"/>
                     </a:p>
@@ -13273,7 +13273,7 @@
                             <a:schemeClr val="tx1"/>
                           </a:solidFill>
                         </a:rPr>
-                        <a:t>İş takibi</a:t>
+                        <a:t>100 ilana kadar takip</a:t>
                       </a:r>
                       <a:endParaRPr lang="en-US" sz="1600" dirty="0"/>
                     </a:p>

</xml_diff>

<commit_message>
özellik: yaratmak fiilini güncelle
</commit_message>
<xml_diff>
--- a/sunum/sunum.pptx
+++ b/sunum/sunum.pptx
@@ -129,14 +129,14 @@
   <p:extLst>
     <p:ext uri="{521415D9-36F7-43E2-AB2F-B90AF26B5E84}">
       <p14:sectionLst xmlns:p14="http://schemas.microsoft.com/office/powerpoint/2010/main">
-        <p14:section name="Giriş" id="{13b6ccfd-38a4-d2ab-5623-3702edba8c80}">
+        <p14:section name="Giriş" id="{ee9b3bca-2b03-d076-d714-be39e5f7ee1d}">
           <p14:sldIdLst>
             <p14:sldId id="256"/>
             <p14:sldId id="257"/>
             <p14:sldId id="258"/>
           </p14:sldIdLst>
         </p14:section>
-        <p14:section name="01 · CV ve ATS" id="{31cbec3b-33d8-ec12-7ffa-4a44f29710d2}">
+        <p14:section name="01 · CV ve ATS" id="{2009220d-faf7-8c73-2ce1-d87b7f1a6569}">
           <p14:sldIdLst>
             <p14:sldId id="259"/>
             <p14:sldId id="260"/>
@@ -145,7 +145,7 @@
             <p14:sldId id="263"/>
           </p14:sldIdLst>
         </p14:section>
-        <p14:section name="02 · CV'yi Kod Gibi Yönetmek" id="{3c68e7b6-954c-223d-7562-4e761220a7be}">
+        <p14:section name="02 · CV'yi Kod Gibi Yönetmek" id="{f6208505-112c-57c5-0eb7-87276fe58fb8}">
           <p14:sldIdLst>
             <p14:sldId id="264"/>
             <p14:sldId id="265"/>
@@ -155,21 +155,21 @@
             <p14:sldId id="269"/>
           </p14:sldIdLst>
         </p14:section>
-        <p14:section name="03 · İlan Bulma" id="{8bcba2fa-1c24-f860-db9a-800fe55fec54}">
+        <p14:section name="03 · İlan Bulma" id="{90646348-341a-a340-fb1a-81df035fc787}">
           <p14:sldIdLst>
             <p14:sldId id="270"/>
             <p14:sldId id="271"/>
             <p14:sldId id="272"/>
           </p14:sldIdLst>
         </p14:section>
-        <p14:section name="04 · Araç Haritası" id="{4c7f75d4-c93f-dfb7-d769-c295cab2e23b}">
+        <p14:section name="04 · Araç Haritası" id="{3e728ace-ff7b-3eb0-bbeb-a6e8cb7aef1a}">
           <p14:sldIdLst>
             <p14:sldId id="273"/>
             <p14:sldId id="274"/>
             <p14:sldId id="275"/>
           </p14:sldIdLst>
         </p14:section>
-        <p14:section name="Kapanış" id="{3f3b95fc-87aa-a03a-d6d8-765f933240a6}">
+        <p14:section name="Kapanış" id="{ac3a448e-ed97-e703-1155-d2c89a135680}">
           <p14:sldIdLst>
             <p14:sldId id="276"/>
             <p14:sldId id="277"/>
@@ -580,7 +580,7 @@
           <a:p>
             <a:r>
               <a:rPr lang="en-US" dirty="0"/>
-              <a:t>Hoş geldiniz. Ben Muhammed Kayra Bulut; YTÜ Yıldız Teknopark'ta BT Yöneticisiyim, öncesinde TÜBİTAK BİLGEM'de yazılım mühendisiydim. Bu söyleşide yapay zekânın iş arama sürecinin üç adımında nasıl kullanılabileceğini konuşacağız: CV hazırlamak, CV'leri yönetmek ve ilan bulmak. Anlatacaklarımın önemli bir kısmı kendi iş arama sürecimde kurduğum gerçek bir sisteme dayanıyor.</a:t>
+              <a:t>Hoş geldiniz. Ben Muhammed Kayra Bulut; YTÜ Yıldız Teknopark'ta BT Yöneticisiyim, öncesinde TÜBİTAK BİLGEM'de yazılım mühendisiydim. Bu söyleşide yapay zekânın iş arama sürecinin üç adımında nasıl kullanılabileceğini konuşacağız: CV hazırlamak, CV'leri yönetmek ve ilan bulmak. Genel bir çerçeve anlatacağım; her adımda kendi iş arama sürecimde kurduğum sistemi örnek olarak göstereceğim.</a:t>
             </a:r>
             <a:endParaRPr lang="en-US" dirty="0"/>
           </a:p>
@@ -668,7 +668,7 @@
           <a:p>
             <a:r>
               <a:rPr lang="en-US" dirty="0"/>
-              <a:t>Akış soldan sağa. Tüm bilgiler info klasöründeki YAML dosyalarında. Buradan dört alan CV'si ve ilana özel paketler türetiliyor. LaTeX kaynakları Docker içinde derleniyor ve ATS uyumlu PDF çıkıyor. Her şey Git'te sürümleniyor.</a:t>
+              <a:t>Genel akış soldan sağa. Tüm bilgiler tek bir kaynak dosyada durur. Alan CV'leri ve ilana özel CV'ler bu kaynaktan türetilir. Derleme adımı ATS uyumlu PDF oluşturur. Her şey Git'te sürümlenir. Kutuların altındaki yollar kendi depomdaki karşılıkları: info klasöründeki YAML dosyaları, genel_cvler, ilana_ozel_cvler ve Docker içinde LaTeX derleyen build.sh. Alttaki sayılar bu yapının bende nasıl büyüdüğünü gösteriyor.</a:t>
             </a:r>
             <a:endParaRPr lang="en-US" dirty="0"/>
           </a:p>
@@ -756,7 +756,7 @@
           <a:p>
             <a:r>
               <a:rPr lang="en-US" dirty="0"/>
-              <a:t>Her proje tek bir YAML kaydı. Türkçe ve İngilizce aynı kayıtta duruyor, böylece iki dil birbirinden kopamıyor. Tarih aralığını ajan reponun ilk ve son commit'inden hesaplıyor. Kategori ve etiketler hangi alan CV'sine gireceğini belirliyor.</a:t>
+              <a:t>İlke şu: her bilgi tek bir yerde durur, CV'ler bu kaynaktan türetilir. Kaynak YAML ya da JSON olabilir. Soldaki örnek kendi depomdaki projects.yml dosyasından. Her proje tek bir kayıt; Türkçe ve İngilizce aynı kayıtta duruyor, böylece iki dil birbirinden kopamıyor. Tarih aralığını eylemci reponun ilk ve son commit'inden hesaplıyor. Etiketler hangi alan CV'sine gireceğini belirliyor.</a:t>
             </a:r>
             <a:endParaRPr lang="en-US" dirty="0"/>
           </a:p>
@@ -844,7 +844,7 @@
           <a:p>
             <a:r>
               <a:rPr lang="en-US" dirty="0"/>
-              <a:t>AGENTS.md ve RULES.md dosyaları ajanın anayasası. Burada beş kural görüyorsunuz. En önemlisi: ajan hiçbir veriyi onayım olmadan değiştirmiyor ve gerçek olmayan bilgi yazmıyor. Bu dosyalar ajandan bağımsız; Claude Code, Codex ve Gemini aynı dosyayı okuyabiliyor.</a:t>
+              <a:t>Eylemciye her seferinde aynı şeyi söylemek yerine kuralları bir dosyaya yazın. Burada genel kurallar var. En önemlisi: eylemci hiçbir veriyi onayınız olmadan değiştirmez ve gerçek olmayan bilgi yazmaz. Kendi depomda bu kurallar AGENTS.md ve RULES.md dosyalarında duruyor; Claude Code, Codex ve Gemini aynı dosyayı okuyabiliyor.</a:t>
             </a:r>
             <a:endParaRPr lang="en-US" dirty="0"/>
           </a:p>
@@ -932,7 +932,7 @@
           <a:p>
             <a:r>
               <a:rPr lang="en-US" dirty="0"/>
-              <a:t>Ajana bu cümlelerden birini yazmam yeterli. Örneğin 'hesapları senkronize et' dediğimde betik GitHub, Hugging Face, Medium, ORCID ve LinkedIn verisini çekiyor; ajan yeni projeleri tespit edip her biri için tek tek onay istiyor.</a:t>
+              <a:t>Sık tekrarlanan her iş tanımlı bir iş akışına dönüşmeli ve tek cümleyle başlatılabilmeli. Böylece eylemci her seferinde aynı adımları aynı sırayla izler. Sağda kendi depomdaki karşılıkları var. Örneğin 'hesapları senkronize et' dediğimde betik GitHub, Hugging Face, Medium, ORCID ve LinkedIn verisini çekiyor; eylemci yeni projeleri tespit edip her biri için tek tek onay istiyor.</a:t>
             </a:r>
             <a:endParaRPr lang="en-US" dirty="0"/>
           </a:p>
@@ -1020,7 +1020,7 @@
           <a:p>
             <a:r>
               <a:rPr lang="en-US" dirty="0"/>
-              <a:t>Her başvuru için bir klasör açılıyor. IS_ILANI.md ilanın tam ham metnini tutuyor; ilan yayından kalksa bile neye başvurduğumu biliyorum. ILAN_NOTLARI.md eşleşme analizini ve tek bir öncelikli CV önerisini içeriyor. Anzera örneğinde mevcut LLM CV'si yeterliydi, yeni CV üretilmedi.</a:t>
+              <a:t>Her başvuru için ilanın metni, eşleşme notu ve gönderilen CV bir arada saklanmalı. İlan yayından kalksa bile neye başvurduğunuzu bilirsiniz. Uygun ve güncel bir CV varsa yenisini oluşturmayın; yoksa ilana özel CV'yi kaynaktan türetin. Sağda bunun kendi depomdaki karşılığı var: her başvuru için bir ilan paketi. IS_ILANI.md ilanın tam ham metnini, ILAN_NOTLARI.md eşleşme analizini ve tek bir öncelikli CV önerisini tutuyor. Örneğin Anzera'nın AI Engineer ilanında mevcut LLM CV'si yeterliydi, yeni CV oluşturulmadı.</a:t>
             </a:r>
             <a:endParaRPr lang="en-US" dirty="0"/>
           </a:p>
@@ -1196,7 +1196,7 @@
           <a:p>
             <a:r>
               <a:rPr lang="en-US" dirty="0"/>
-              <a:t>Zaman en değerli kaynak. Kapalı ilana ya da daha önce başvurduğunuz ilana zaman harcamayın. Ajanım önce ilanın aktif olup olmadığına, sonra depoda veya LinkedIn'de 'Applied' etiketi olup olmadığına bakıyor. İlan metnini LinkedIn'in herkese açık endpoint'inden curl ile çekiyor. Bunu düşük hacimde ve kişisel kullanım için yapın.</a:t>
+              <a:t>Zaman en değerli kaynak. Kapalı ilana ya da daha önce başvurduğunuz ilana zaman harcamayın. Eylemcim önce ilanın aktif olup olmadığına, sonra depoda veya LinkedIn'de 'Applied' etiketi olup olmadığına bakıyor. İlan metnini LinkedIn'in herkese açık endpoint'inden curl ile çekiyor. Bunu düşük hacimde ve kişisel kullanım için yapın.</a:t>
             </a:r>
             <a:endParaRPr lang="en-US" dirty="0"/>
           </a:p>
@@ -1372,7 +1372,7 @@
           <a:p>
             <a:r>
               <a:rPr lang="en-US" dirty="0"/>
-              <a:t>Hepsi ücretsiz ve açık kaynak. Üstteki beşi CV aracı: Reactive Resume tarayıcıda çalışan bir editör, RenderCV YAML'dan PDF üretiyor, OpenResume'un ayrıştırıcısı ATS testi için çok kullanışlı. Alttaki üçü iş arama ajanı: career-ops ve ai-job-search Claude Code gibi CLI ajanlarıyla çalışıyor, benim sistemime çok benzer. ApplyPilot otomatik başvuru yapıyor; dikkatli kullanın, platform koşullarını ihlal edebilir.</a:t>
+              <a:t>Hepsi ücretsiz ve açık kaynak. Üstteki beşi CV aracı: Reactive Resume tarayıcıda çalışan bir editör, RenderCV YAML'dan PDF üretiyor, OpenResume'un ayrıştırıcısı ATS testi için çok kullanışlı. Alttaki üçü iş arama eylemcisi: career-ops ve ai-job-search Claude Code gibi CLI eylemcileriyle çalışıyor, benim sistemime çok benzer. ApplyPilot otomatik başvuru yapıyor; dikkatli kullanın, platform koşullarını ihlal edebilir.</a:t>
             </a:r>
             <a:endParaRPr lang="en-US" dirty="0"/>
           </a:p>
@@ -1548,7 +1548,7 @@
           <a:p>
             <a:r>
               <a:rPr lang="en-US" dirty="0"/>
-              <a:t>Dört bölümümüz var. Önce temeller: ATS nedir, iyi madde nasıl yazılır. Sonra kendi sistemim: CV'yi kod gibi yönetmek. Ardından ilan bulma ve son olarak araç haritası.</a:t>
+              <a:t>Dört bölümümüz var. Önce temeller: ATS nedir, iyi madde nasıl yazılır. Sonra CV'yi kod gibi yönetmenin genel çerçevesi; örnek olarak kendi sistemimi göstereceğim. Ardından ilan bulma ve son olarak araç haritası.</a:t>
             </a:r>
             <a:endParaRPr lang="en-US" dirty="0"/>
           </a:p>
@@ -1724,7 +1724,7 @@
           <a:p>
             <a:r>
               <a:rPr lang="en-US" dirty="0"/>
-              <a:t>Yapay zekâ güçlü ama dört riski var. Birincisi halüsinasyon: model olmayan bir deneyimi ya da sayıyı ekleyebilir. İkincisi kişisel veri: telefon, adres, kimlik bilgisini bulut modellere yüklemeyin. Üçüncüsü toplu otomatik başvuru: hesabınız kısıtlanabilir. Dördüncüsü yapay zekâ kokan metin. Son karar ve son kontrol her zaman sizde.</a:t>
+              <a:t>Yapay zekâ güçlü ama dört riski var. Birincisi uydurma: model olmayan bir deneyimi ya da sayıyı ekleyebilir. İkincisi kişisel veri: telefon, adres, kimlik bilgisini bulut modellere yüklemeyin. Üçüncüsü toplu otomatik başvuru: hesabınız kısıtlanabilir. Dördüncüsü yapay zekâ kokan metin. Son karar ve son kontrol her zaman sizde.</a:t>
             </a:r>
             <a:endParaRPr lang="en-US" dirty="0"/>
           </a:p>
@@ -2164,7 +2164,7 @@
           <a:p>
             <a:r>
               <a:rPr lang="en-US" dirty="0"/>
-              <a:t>Solda yapılacaklar, sağda yapılmayacaklar. Tek sütun ve metni seçilebilen PDF ATS için en güvenli düzen. İlandaki terimleri birebir kullanın: ilan 'PostgreSQL' diyorsa siz de 'PostgreSQL' yazın. Sağdaki liste kendi CV depomdaki RULES.md dosyasından geliyor; ajan da aynı dosyayı okuyor. Son madde kritik: LLM'ler gerçek olmayan bilgi üretmeye yatkın.</a:t>
+              <a:t>Solda yapılacaklar, sağda yapılmayacaklar. Tek sütun ve metni seçilebilen PDF ATS için en güvenli düzen. İlandaki terimleri birebir kullanın: ilan 'PostgreSQL' diyorsa siz de 'PostgreSQL' yazın. Son madde kritik: LLM'ler gerçek olmayan bilgi üretmeye yatkın.</a:t>
             </a:r>
             <a:endParaRPr lang="en-US" dirty="0"/>
           </a:p>
@@ -2516,7 +2516,7 @@
           <a:p>
             <a:r>
               <a:rPr lang="en-US" dirty="0"/>
-              <a:t>Ben dört alanda iş arıyorum: Java, LLM, makine öğrenmesi ve MLOps. İki dil var. Üstüne ilana özel sürümler eklenince onlarca dosya oluşuyor. Bunu elle yönetmek mümkün değil; yazılım mühendisliğinin bildiğimiz araçlarını kullandım.</a:t>
+              <a:t>Birden fazla alanda ve iki dilde iş arayan herkes bu sorunla karşılaşır. Örneğin ben dört alanda iş arıyorum: Java, LLM, makine öğrenmesi ve MLOps. İki dil var. Üstüne ilana özel sürümler eklenince onlarca dosya oluşuyor. Bunu elle yönetmek mümkün değil; çözüm yazılım mühendisliğinin bildiğimiz araçlarında.</a:t>
             </a:r>
             <a:endParaRPr lang="en-US" dirty="0"/>
           </a:p>
@@ -2614,7 +2614,7 @@
       </p:grpSpPr>
       <p:pic>
         <p:nvPicPr>
-          <p:cNvPr id="2" name="Image 0" descr="/tmp/claude-1000/-home-kayra-Desktop-github-repolarim-kurslar/6b167384-22ac-40e1-8a64-b99aeff95692/scratchpad/deck/img/yildiz.png">    </p:cNvPr>
+          <p:cNvPr id="2" name="Image 0" descr="/tmp/claude-1000/-home-kayra-Desktop-github-repolarim-kurslar/7c51a3db-9362-42b2-874a-4dd707c7318f/scratchpad/deck/img/yildiz.png">    </p:cNvPr>
           <p:cNvPicPr>
             <a:picLocks noChangeAspect="1"/>
           </p:cNvPicPr>
@@ -2640,7 +2640,7 @@
       </p:pic>
       <p:pic>
         <p:nvPicPr>
-          <p:cNvPr id="3" name="Image 1" descr="/tmp/claude-1000/-home-kayra-Desktop-github-repolarim-kurslar/6b167384-22ac-40e1-8a64-b99aeff95692/scratchpad/deck/img/logo_beyaz.png">    </p:cNvPr>
+          <p:cNvPr id="3" name="Image 1" descr="/tmp/claude-1000/-home-kayra-Desktop-github-repolarim-kurslar/7c51a3db-9362-42b2-874a-4dd707c7318f/scratchpad/deck/img/logo_beyaz.png">    </p:cNvPr>
           <p:cNvPicPr>
             <a:picLocks noChangeAspect="1"/>
           </p:cNvPicPr>
@@ -2813,7 +2813,7 @@
       </p:grpSpPr>
       <p:pic>
         <p:nvPicPr>
-          <p:cNvPr id="2" name="Image 0" descr="/tmp/claude-1000/-home-kayra-Desktop-github-repolarim-kurslar/6b167384-22ac-40e1-8a64-b99aeff95692/scratchpad/deck/img/logo_renkli.png">    </p:cNvPr>
+          <p:cNvPr id="2" name="Image 0" descr="/tmp/claude-1000/-home-kayra-Desktop-github-repolarim-kurslar/7c51a3db-9362-42b2-874a-4dd707c7318f/scratchpad/deck/img/logo_renkli.png">    </p:cNvPr>
           <p:cNvPicPr>
             <a:picLocks noChangeAspect="1"/>
           </p:cNvPicPr>
@@ -3030,7 +3030,7 @@
       </p:grpSpPr>
       <p:pic>
         <p:nvPicPr>
-          <p:cNvPr id="2" name="Image 0" descr="/tmp/claude-1000/-home-kayra-Desktop-github-repolarim-kurslar/6b167384-22ac-40e1-8a64-b99aeff95692/scratchpad/deck/img/yildiz.png">    </p:cNvPr>
+          <p:cNvPr id="2" name="Image 0" descr="/tmp/claude-1000/-home-kayra-Desktop-github-repolarim-kurslar/7c51a3db-9362-42b2-874a-4dd707c7318f/scratchpad/deck/img/yildiz.png">    </p:cNvPr>
           <p:cNvPicPr>
             <a:picLocks noChangeAspect="1"/>
           </p:cNvPicPr>
@@ -3056,7 +3056,7 @@
       </p:pic>
       <p:pic>
         <p:nvPicPr>
-          <p:cNvPr id="3" name="Image 1" descr="/tmp/claude-1000/-home-kayra-Desktop-github-repolarim-kurslar/6b167384-22ac-40e1-8a64-b99aeff95692/scratchpad/deck/img/logo_beyaz.png">    </p:cNvPr>
+          <p:cNvPr id="3" name="Image 1" descr="/tmp/claude-1000/-home-kayra-Desktop-github-repolarim-kurslar/7c51a3db-9362-42b2-874a-4dd707c7318f/scratchpad/deck/img/logo_beyaz.png">    </p:cNvPr>
           <p:cNvPicPr>
             <a:picLocks noChangeAspect="1"/>
           </p:cNvPicPr>
@@ -3790,13 +3790,49 @@
       </p:sp>
       <p:sp>
         <p:nvSpPr>
-          <p:cNvPr id="5" name="kart"/>
+          <p:cNvPr id="5" name="Text 2"/>
+          <p:cNvSpPr txBox="1"/>
+          <p:nvPr/>
+        </p:nvSpPr>
+        <p:spPr>
+          <a:xfrm>
+            <a:off x="548640" y="1600200"/>
+            <a:ext cx="11094415" cy="274320"/>
+          </a:xfrm>
+          <a:prstGeom prst="rect">
+            <a:avLst/>
+          </a:prstGeom>
+          <a:noFill/>
+          <a:ln/>
+        </p:spPr>
+        <p:txBody>
+          <a:bodyPr wrap="square" lIns="0" tIns="0" rIns="0" bIns="0" rtlCol="0" anchor="ctr"/>
+          <a:lstStyle/>
+          <a:p>
+            <a:pPr indent="0" marL="0">
+              <a:buNone/>
+            </a:pPr>
+            <a:r>
+              <a:rPr lang="en-US" sz="1200" b="1" spc="200" kern="0" dirty="0">
+                <a:solidFill>
+                  <a:schemeClr val="accent3"/>
+                </a:solidFill>
+              </a:rPr>
+              <a:t>GENEL AKIŞ · ALTTA KENDİ DEPOMDAKİ KARŞILIĞI</a:t>
+            </a:r>
+            <a:endParaRPr lang="en-US" sz="1200" dirty="0"/>
+          </a:p>
+        </p:txBody>
+      </p:sp>
+      <p:sp>
+        <p:nvSpPr>
+          <p:cNvPr id="6" name="kart"/>
           <p:cNvSpPr/>
           <p:nvPr/>
         </p:nvSpPr>
         <p:spPr>
           <a:xfrm>
-            <a:off x="548640" y="1783080"/>
+            <a:off x="548640" y="1965960"/>
             <a:ext cx="1883664" cy="1417320"/>
           </a:xfrm>
           <a:prstGeom prst="roundRect">
@@ -3812,13 +3848,13 @@
       </p:sp>
       <p:sp>
         <p:nvSpPr>
-          <p:cNvPr id="6" name="Text 3"/>
+          <p:cNvPr id="7" name="Text 4"/>
           <p:cNvSpPr txBox="1"/>
           <p:nvPr/>
         </p:nvSpPr>
         <p:spPr>
           <a:xfrm>
-            <a:off x="658368" y="1783080"/>
+            <a:off x="658368" y="1965960"/>
             <a:ext cx="1664208" cy="1417320"/>
           </a:xfrm>
           <a:prstGeom prst="rect">
@@ -3833,14 +3869,48 @@
           <a:p>
             <a:pPr algn="ctr" indent="0" marL="0">
               <a:spcAft>
-                <a:spcPts val="400"/>
+                <a:spcPts val="600"/>
               </a:spcAft>
               <a:buNone/>
             </a:pPr>
             <a:r>
-              <a:rPr lang="en-US" sz="1200" b="1" dirty="0">
+              <a:rPr lang="en-US" sz="1600" b="1" dirty="0">
                 <a:solidFill>
                   <a:schemeClr val="tx2"/>
+                </a:solidFill>
+              </a:rPr>
+              <a:t>Tek kaynak</a:t>
+            </a:r>
+            <a:endParaRPr lang="en-US" sz="1600" dirty="0"/>
+          </a:p>
+          <a:p>
+            <a:pPr algn="ctr" indent="0" marL="0">
+              <a:spcAft>
+                <a:spcPts val="600"/>
+              </a:spcAft>
+              <a:buNone/>
+            </a:pPr>
+            <a:r>
+              <a:rPr lang="en-US" sz="1300" dirty="0">
+                <a:solidFill>
+                  <a:schemeClr val="tx1"/>
+                </a:solidFill>
+              </a:rPr>
+              <a:t>YAML veya JSON</a:t>
+            </a:r>
+            <a:endParaRPr lang="en-US" sz="1600" dirty="0"/>
+          </a:p>
+          <a:p>
+            <a:pPr algn="ctr" indent="0" marL="0">
+              <a:spcAft>
+                <a:spcPts val="600"/>
+              </a:spcAft>
+              <a:buNone/>
+            </a:pPr>
+            <a:r>
+              <a:rPr lang="en-US" sz="1100" dirty="0">
+                <a:solidFill>
+                  <a:schemeClr val="accent3"/>
                 </a:solidFill>
                 <a:latin typeface="Courier New" pitchFamily="34" charset="0"/>
                 <a:ea typeface="Courier New" pitchFamily="34" charset="-122"/>
@@ -3848,30 +3918,13 @@
               </a:rPr>
               <a:t>info/*.yml</a:t>
             </a:r>
-            <a:endParaRPr lang="en-US" sz="1200" dirty="0"/>
-          </a:p>
-          <a:p>
-            <a:pPr algn="ctr" indent="0" marL="0">
-              <a:spcAft>
-                <a:spcPts val="400"/>
-              </a:spcAft>
-              <a:buNone/>
-            </a:pPr>
-            <a:r>
-              <a:rPr lang="en-US" sz="1300" dirty="0">
-                <a:solidFill>
-                  <a:schemeClr val="tx1"/>
-                </a:solidFill>
-              </a:rPr>
-              <a:t>Tek doğruluk kaynağı</a:t>
-            </a:r>
-            <a:endParaRPr lang="en-US" sz="1200" dirty="0"/>
+            <a:endParaRPr lang="en-US" sz="1600" dirty="0"/>
           </a:p>
         </p:txBody>
       </p:sp>
       <p:pic>
         <p:nvPicPr>
-          <p:cNvPr id="7" name="Image 0" descr="preencoded.png">    </p:cNvPr>
+          <p:cNvPr id="8" name="Image 0" descr="preencoded.png">    </p:cNvPr>
           <p:cNvPicPr>
             <a:picLocks noChangeAspect="1"/>
           </p:cNvPicPr>
@@ -3885,7 +3938,7 @@
         </p:blipFill>
         <p:spPr>
           <a:xfrm>
-            <a:off x="2522944" y="2377440"/>
+            <a:off x="2522944" y="2560320"/>
             <a:ext cx="237744" cy="237744"/>
           </a:xfrm>
           <a:prstGeom prst="rect">
@@ -3895,13 +3948,13 @@
       </p:pic>
       <p:sp>
         <p:nvSpPr>
-          <p:cNvPr id="8" name="kart"/>
+          <p:cNvPr id="9" name="kart"/>
           <p:cNvSpPr/>
           <p:nvPr/>
         </p:nvSpPr>
         <p:spPr>
           <a:xfrm>
-            <a:off x="2851328" y="1783080"/>
+            <a:off x="2851328" y="1965960"/>
             <a:ext cx="1883664" cy="1417320"/>
           </a:xfrm>
           <a:prstGeom prst="roundRect">
@@ -3917,13 +3970,13 @@
       </p:sp>
       <p:sp>
         <p:nvSpPr>
-          <p:cNvPr id="9" name="Text 5"/>
+          <p:cNvPr id="10" name="Text 6"/>
           <p:cNvSpPr txBox="1"/>
           <p:nvPr/>
         </p:nvSpPr>
         <p:spPr>
           <a:xfrm>
-            <a:off x="2961056" y="1783080"/>
+            <a:off x="2961056" y="1965960"/>
             <a:ext cx="1664208" cy="1417320"/>
           </a:xfrm>
           <a:prstGeom prst="rect">
@@ -3938,14 +3991,48 @@
           <a:p>
             <a:pPr algn="ctr" indent="0" marL="0">
               <a:spcAft>
-                <a:spcPts val="400"/>
+                <a:spcPts val="600"/>
               </a:spcAft>
               <a:buNone/>
             </a:pPr>
             <a:r>
-              <a:rPr lang="en-US" sz="1200" b="1" dirty="0">
+              <a:rPr lang="en-US" sz="1600" b="1" dirty="0">
                 <a:solidFill>
                   <a:schemeClr val="tx2"/>
+                </a:solidFill>
+              </a:rPr>
+              <a:t>Alan CV'leri</a:t>
+            </a:r>
+            <a:endParaRPr lang="en-US" sz="1600" dirty="0"/>
+          </a:p>
+          <a:p>
+            <a:pPr algn="ctr" indent="0" marL="0">
+              <a:spcAft>
+                <a:spcPts val="600"/>
+              </a:spcAft>
+              <a:buNone/>
+            </a:pPr>
+            <a:r>
+              <a:rPr lang="en-US" sz="1300" dirty="0">
+                <a:solidFill>
+                  <a:schemeClr val="tx1"/>
+                </a:solidFill>
+              </a:rPr>
+              <a:t>Hedef role göre</a:t>
+            </a:r>
+            <a:endParaRPr lang="en-US" sz="1600" dirty="0"/>
+          </a:p>
+          <a:p>
+            <a:pPr algn="ctr" indent="0" marL="0">
+              <a:spcAft>
+                <a:spcPts val="600"/>
+              </a:spcAft>
+              <a:buNone/>
+            </a:pPr>
+            <a:r>
+              <a:rPr lang="en-US" sz="1100" dirty="0">
+                <a:solidFill>
+                  <a:schemeClr val="accent3"/>
                 </a:solidFill>
                 <a:latin typeface="Courier New" pitchFamily="34" charset="0"/>
                 <a:ea typeface="Courier New" pitchFamily="34" charset="-122"/>
@@ -3953,30 +4040,13 @@
               </a:rPr>
               <a:t>genel_cvler/</a:t>
             </a:r>
-            <a:endParaRPr lang="en-US" sz="1200" dirty="0"/>
-          </a:p>
-          <a:p>
-            <a:pPr algn="ctr" indent="0" marL="0">
-              <a:spcAft>
-                <a:spcPts val="400"/>
-              </a:spcAft>
-              <a:buNone/>
-            </a:pPr>
-            <a:r>
-              <a:rPr lang="en-US" sz="1300" dirty="0">
-                <a:solidFill>
-                  <a:schemeClr val="tx1"/>
-                </a:solidFill>
-              </a:rPr>
-              <a:t>java · llm · ml · mlops</a:t>
-            </a:r>
-            <a:endParaRPr lang="en-US" sz="1200" dirty="0"/>
+            <a:endParaRPr lang="en-US" sz="1600" dirty="0"/>
           </a:p>
         </p:txBody>
       </p:sp>
       <p:pic>
         <p:nvPicPr>
-          <p:cNvPr id="10" name="Image 1" descr="preencoded.png">    </p:cNvPr>
+          <p:cNvPr id="11" name="Image 1" descr="preencoded.png">    </p:cNvPr>
           <p:cNvPicPr>
             <a:picLocks noChangeAspect="1"/>
           </p:cNvPicPr>
@@ -3990,7 +4060,7 @@
         </p:blipFill>
         <p:spPr>
           <a:xfrm>
-            <a:off x="4825632" y="2377440"/>
+            <a:off x="4825632" y="2560320"/>
             <a:ext cx="237744" cy="237744"/>
           </a:xfrm>
           <a:prstGeom prst="rect">
@@ -4000,13 +4070,13 @@
       </p:pic>
       <p:sp>
         <p:nvSpPr>
-          <p:cNvPr id="11" name="kart"/>
+          <p:cNvPr id="12" name="kart"/>
           <p:cNvSpPr/>
           <p:nvPr/>
         </p:nvSpPr>
         <p:spPr>
           <a:xfrm>
-            <a:off x="5154016" y="1783080"/>
+            <a:off x="5154016" y="1965960"/>
             <a:ext cx="1883664" cy="1417320"/>
           </a:xfrm>
           <a:prstGeom prst="roundRect">
@@ -4022,13 +4092,13 @@
       </p:sp>
       <p:sp>
         <p:nvSpPr>
-          <p:cNvPr id="12" name="Text 7"/>
+          <p:cNvPr id="13" name="Text 8"/>
           <p:cNvSpPr txBox="1"/>
           <p:nvPr/>
         </p:nvSpPr>
         <p:spPr>
           <a:xfrm>
-            <a:off x="5263744" y="1783080"/>
+            <a:off x="5263744" y="1965960"/>
             <a:ext cx="1664208" cy="1417320"/>
           </a:xfrm>
           <a:prstGeom prst="rect">
@@ -4043,14 +4113,48 @@
           <a:p>
             <a:pPr algn="ctr" indent="0" marL="0">
               <a:spcAft>
-                <a:spcPts val="400"/>
+                <a:spcPts val="600"/>
               </a:spcAft>
               <a:buNone/>
             </a:pPr>
             <a:r>
-              <a:rPr lang="en-US" sz="1200" b="1" dirty="0">
+              <a:rPr lang="en-US" sz="1600" b="1" dirty="0">
                 <a:solidFill>
                   <a:schemeClr val="tx2"/>
+                </a:solidFill>
+              </a:rPr>
+              <a:t>İlana özel CV'ler</a:t>
+            </a:r>
+            <a:endParaRPr lang="en-US" sz="1600" dirty="0"/>
+          </a:p>
+          <a:p>
+            <a:pPr algn="ctr" indent="0" marL="0">
+              <a:spcAft>
+                <a:spcPts val="600"/>
+              </a:spcAft>
+              <a:buNone/>
+            </a:pPr>
+            <a:r>
+              <a:rPr lang="en-US" sz="1300" dirty="0">
+                <a:solidFill>
+                  <a:schemeClr val="tx1"/>
+                </a:solidFill>
+              </a:rPr>
+              <a:t>Gerektiğinde</a:t>
+            </a:r>
+            <a:endParaRPr lang="en-US" sz="1600" dirty="0"/>
+          </a:p>
+          <a:p>
+            <a:pPr algn="ctr" indent="0" marL="0">
+              <a:spcAft>
+                <a:spcPts val="600"/>
+              </a:spcAft>
+              <a:buNone/>
+            </a:pPr>
+            <a:r>
+              <a:rPr lang="en-US" sz="1100" dirty="0">
+                <a:solidFill>
+                  <a:schemeClr val="accent3"/>
                 </a:solidFill>
                 <a:latin typeface="Courier New" pitchFamily="34" charset="0"/>
                 <a:ea typeface="Courier New" pitchFamily="34" charset="-122"/>
@@ -4058,30 +4162,13 @@
               </a:rPr>
               <a:t>ilana_ozel_cvler/</a:t>
             </a:r>
-            <a:endParaRPr lang="en-US" sz="1200" dirty="0"/>
-          </a:p>
-          <a:p>
-            <a:pPr algn="ctr" indent="0" marL="0">
-              <a:spcAft>
-                <a:spcPts val="400"/>
-              </a:spcAft>
-              <a:buNone/>
-            </a:pPr>
-            <a:r>
-              <a:rPr lang="en-US" sz="1300" dirty="0">
-                <a:solidFill>
-                  <a:schemeClr val="tx1"/>
-                </a:solidFill>
-              </a:rPr>
-              <a:t>şirket_pozisyon paketleri</a:t>
-            </a:r>
-            <a:endParaRPr lang="en-US" sz="1200" dirty="0"/>
+            <a:endParaRPr lang="en-US" sz="1600" dirty="0"/>
           </a:p>
         </p:txBody>
       </p:sp>
       <p:pic>
         <p:nvPicPr>
-          <p:cNvPr id="13" name="Image 2" descr="preencoded.png">    </p:cNvPr>
+          <p:cNvPr id="14" name="Image 2" descr="preencoded.png">    </p:cNvPr>
           <p:cNvPicPr>
             <a:picLocks noChangeAspect="1"/>
           </p:cNvPicPr>
@@ -4095,7 +4182,7 @@
         </p:blipFill>
         <p:spPr>
           <a:xfrm>
-            <a:off x="7128320" y="2377440"/>
+            <a:off x="7128320" y="2560320"/>
             <a:ext cx="237744" cy="237744"/>
           </a:xfrm>
           <a:prstGeom prst="rect">
@@ -4105,13 +4192,13 @@
       </p:pic>
       <p:sp>
         <p:nvSpPr>
-          <p:cNvPr id="14" name="kart"/>
+          <p:cNvPr id="15" name="kart"/>
           <p:cNvSpPr/>
           <p:nvPr/>
         </p:nvSpPr>
         <p:spPr>
           <a:xfrm>
-            <a:off x="7456703" y="1783080"/>
+            <a:off x="7456703" y="1965960"/>
             <a:ext cx="1883664" cy="1417320"/>
           </a:xfrm>
           <a:prstGeom prst="roundRect">
@@ -4127,13 +4214,13 @@
       </p:sp>
       <p:sp>
         <p:nvSpPr>
-          <p:cNvPr id="15" name="Text 9"/>
+          <p:cNvPr id="16" name="Text 10"/>
           <p:cNvSpPr txBox="1"/>
           <p:nvPr/>
         </p:nvSpPr>
         <p:spPr>
           <a:xfrm>
-            <a:off x="7566431" y="1783080"/>
+            <a:off x="7566431" y="1965960"/>
             <a:ext cx="1664208" cy="1417320"/>
           </a:xfrm>
           <a:prstGeom prst="rect">
@@ -4148,14 +4235,48 @@
           <a:p>
             <a:pPr algn="ctr" indent="0" marL="0">
               <a:spcAft>
-                <a:spcPts val="400"/>
+                <a:spcPts val="600"/>
               </a:spcAft>
               <a:buNone/>
             </a:pPr>
             <a:r>
-              <a:rPr lang="en-US" sz="1200" b="1" dirty="0">
+              <a:rPr lang="en-US" sz="1600" b="1" dirty="0">
                 <a:solidFill>
                   <a:schemeClr val="tx2"/>
+                </a:solidFill>
+              </a:rPr>
+              <a:t>Derleme</a:t>
+            </a:r>
+            <a:endParaRPr lang="en-US" sz="1600" dirty="0"/>
+          </a:p>
+          <a:p>
+            <a:pPr algn="ctr" indent="0" marL="0">
+              <a:spcAft>
+                <a:spcPts val="600"/>
+              </a:spcAft>
+              <a:buNone/>
+            </a:pPr>
+            <a:r>
+              <a:rPr lang="en-US" sz="1300" dirty="0">
+                <a:solidFill>
+                  <a:schemeClr val="tx1"/>
+                </a:solidFill>
+              </a:rPr>
+              <a:t>LaTeX, RenderCV</a:t>
+            </a:r>
+            <a:endParaRPr lang="en-US" sz="1600" dirty="0"/>
+          </a:p>
+          <a:p>
+            <a:pPr algn="ctr" indent="0" marL="0">
+              <a:spcAft>
+                <a:spcPts val="600"/>
+              </a:spcAft>
+              <a:buNone/>
+            </a:pPr>
+            <a:r>
+              <a:rPr lang="en-US" sz="1100" dirty="0">
+                <a:solidFill>
+                  <a:schemeClr val="accent3"/>
                 </a:solidFill>
                 <a:latin typeface="Courier New" pitchFamily="34" charset="0"/>
                 <a:ea typeface="Courier New" pitchFamily="34" charset="-122"/>
@@ -4163,30 +4284,13 @@
               </a:rPr>
               <a:t>build.sh</a:t>
             </a:r>
-            <a:endParaRPr lang="en-US" sz="1200" dirty="0"/>
-          </a:p>
-          <a:p>
-            <a:pPr algn="ctr" indent="0" marL="0">
-              <a:spcAft>
-                <a:spcPts val="400"/>
-              </a:spcAft>
-              <a:buNone/>
-            </a:pPr>
-            <a:r>
-              <a:rPr lang="en-US" sz="1300" dirty="0">
-                <a:solidFill>
-                  <a:schemeClr val="tx1"/>
-                </a:solidFill>
-              </a:rPr>
-              <a:t>LaTeX + Docker pdflatex</a:t>
-            </a:r>
-            <a:endParaRPr lang="en-US" sz="1200" dirty="0"/>
+            <a:endParaRPr lang="en-US" sz="1600" dirty="0"/>
           </a:p>
         </p:txBody>
       </p:sp>
       <p:pic>
         <p:nvPicPr>
-          <p:cNvPr id="16" name="Image 3" descr="preencoded.png">    </p:cNvPr>
+          <p:cNvPr id="17" name="Image 3" descr="preencoded.png">    </p:cNvPr>
           <p:cNvPicPr>
             <a:picLocks noChangeAspect="1"/>
           </p:cNvPicPr>
@@ -4200,7 +4304,7 @@
         </p:blipFill>
         <p:spPr>
           <a:xfrm>
-            <a:off x="9431007" y="2377440"/>
+            <a:off x="9431007" y="2560320"/>
             <a:ext cx="237744" cy="237744"/>
           </a:xfrm>
           <a:prstGeom prst="rect">
@@ -4210,13 +4314,13 @@
       </p:pic>
       <p:sp>
         <p:nvSpPr>
-          <p:cNvPr id="17" name="kart"/>
+          <p:cNvPr id="18" name="kart"/>
           <p:cNvSpPr/>
           <p:nvPr/>
         </p:nvSpPr>
         <p:spPr>
           <a:xfrm>
-            <a:off x="9759391" y="1783080"/>
+            <a:off x="9759391" y="1965960"/>
             <a:ext cx="1883664" cy="1417320"/>
           </a:xfrm>
           <a:prstGeom prst="roundRect">
@@ -4232,13 +4336,13 @@
       </p:sp>
       <p:sp>
         <p:nvSpPr>
-          <p:cNvPr id="18" name="Text 11"/>
+          <p:cNvPr id="19" name="Text 12"/>
           <p:cNvSpPr txBox="1"/>
           <p:nvPr/>
         </p:nvSpPr>
         <p:spPr>
           <a:xfrm>
-            <a:off x="9869119" y="1783080"/>
+            <a:off x="9869119" y="1965960"/>
             <a:ext cx="1664208" cy="1417320"/>
           </a:xfrm>
           <a:prstGeom prst="rect">
@@ -4253,14 +4357,48 @@
           <a:p>
             <a:pPr algn="ctr" indent="0" marL="0">
               <a:spcAft>
-                <a:spcPts val="400"/>
+                <a:spcPts val="600"/>
               </a:spcAft>
               <a:buNone/>
             </a:pPr>
             <a:r>
-              <a:rPr lang="en-US" sz="1200" b="1" dirty="0">
+              <a:rPr lang="en-US" sz="1600" b="1" dirty="0">
                 <a:solidFill>
                   <a:schemeClr val="bg1"/>
+                </a:solidFill>
+              </a:rPr>
+              <a:t>ATS uyumlu PDF</a:t>
+            </a:r>
+            <a:endParaRPr lang="en-US" sz="1600" dirty="0"/>
+          </a:p>
+          <a:p>
+            <a:pPr algn="ctr" indent="0" marL="0">
+              <a:spcAft>
+                <a:spcPts val="600"/>
+              </a:spcAft>
+              <a:buNone/>
+            </a:pPr>
+            <a:r>
+              <a:rPr lang="en-US" sz="1300" dirty="0">
+                <a:solidFill>
+                  <a:schemeClr val="bg2"/>
+                </a:solidFill>
+              </a:rPr>
+              <a:t>Türkçe ve İngilizce</a:t>
+            </a:r>
+            <a:endParaRPr lang="en-US" sz="1600" dirty="0"/>
+          </a:p>
+          <a:p>
+            <a:pPr algn="ctr" indent="0" marL="0">
+              <a:spcAft>
+                <a:spcPts val="600"/>
+              </a:spcAft>
+              <a:buNone/>
+            </a:pPr>
+            <a:r>
+              <a:rPr lang="en-US" sz="1100" dirty="0">
+                <a:solidFill>
+                  <a:schemeClr val="accent2"/>
                 </a:solidFill>
                 <a:latin typeface="Courier New" pitchFamily="34" charset="0"/>
                 <a:ea typeface="Courier New" pitchFamily="34" charset="-122"/>
@@ -4268,36 +4406,19 @@
               </a:rPr>
               <a:t>TR / EN PDF</a:t>
             </a:r>
-            <a:endParaRPr lang="en-US" sz="1200" dirty="0"/>
-          </a:p>
-          <a:p>
-            <a:pPr algn="ctr" indent="0" marL="0">
-              <a:spcAft>
-                <a:spcPts val="400"/>
-              </a:spcAft>
-              <a:buNone/>
-            </a:pPr>
-            <a:r>
-              <a:rPr lang="en-US" sz="1300" dirty="0">
-                <a:solidFill>
-                  <a:schemeClr val="bg2"/>
-                </a:solidFill>
-              </a:rPr>
-              <a:t>ATS uyumlu çıktı</a:t>
-            </a:r>
-            <a:endParaRPr lang="en-US" sz="1200" dirty="0"/>
-          </a:p>
-        </p:txBody>
-      </p:sp>
-      <p:sp>
-        <p:nvSpPr>
-          <p:cNvPr id="19" name="kart"/>
+            <a:endParaRPr lang="en-US" sz="1600" dirty="0"/>
+          </a:p>
+        </p:txBody>
+      </p:sp>
+      <p:sp>
+        <p:nvSpPr>
+          <p:cNvPr id="20" name="kart"/>
           <p:cNvSpPr/>
           <p:nvPr/>
         </p:nvSpPr>
         <p:spPr>
           <a:xfrm>
-            <a:off x="548640" y="3429000"/>
+            <a:off x="548640" y="3611880"/>
             <a:ext cx="11094415" cy="548640"/>
           </a:xfrm>
           <a:prstGeom prst="roundRect">
@@ -4315,50 +4436,14 @@
       </p:sp>
       <p:sp>
         <p:nvSpPr>
-          <p:cNvPr id="20" name="Text 13"/>
-          <p:cNvSpPr txBox="1"/>
-          <p:nvPr/>
-        </p:nvSpPr>
-        <p:spPr>
-          <a:xfrm>
-            <a:off x="548640" y="3429000"/>
-            <a:ext cx="11094415" cy="548640"/>
-          </a:xfrm>
-          <a:prstGeom prst="rect">
-            <a:avLst/>
-          </a:prstGeom>
-          <a:noFill/>
-          <a:ln/>
-        </p:spPr>
-        <p:txBody>
-          <a:bodyPr wrap="square" lIns="0" tIns="0" rIns="0" bIns="0" rtlCol="0" anchor="ctr"/>
-          <a:lstStyle/>
-          <a:p>
-            <a:pPr algn="ctr" indent="0" marL="0">
-              <a:buNone/>
-            </a:pPr>
-            <a:r>
-              <a:rPr lang="en-US" sz="1600" b="1" dirty="0">
-                <a:solidFill>
-                  <a:schemeClr val="tx2"/>
-                </a:solidFill>
-              </a:rPr>
-              <a:t>Git ile sürümlenir · AGENTS.md ve RULES.md kurallarıyla ajan yönetir</a:t>
-            </a:r>
-            <a:endParaRPr lang="en-US" sz="1600" dirty="0"/>
-          </a:p>
-        </p:txBody>
-      </p:sp>
-      <p:sp>
-        <p:nvSpPr>
           <p:cNvPr id="21" name="Text 14"/>
           <p:cNvSpPr txBox="1"/>
           <p:nvPr/>
         </p:nvSpPr>
         <p:spPr>
           <a:xfrm>
-            <a:off x="548640" y="4297680"/>
-            <a:ext cx="2773604" cy="1463040"/>
+            <a:off x="548640" y="3611880"/>
+            <a:ext cx="11094415" cy="548640"/>
           </a:xfrm>
           <a:prstGeom prst="rect">
             <a:avLst/>
@@ -4367,6 +4452,78 @@
           <a:ln/>
         </p:spPr>
         <p:txBody>
+          <a:bodyPr wrap="square" lIns="0" tIns="0" rIns="0" bIns="0" rtlCol="0" anchor="ctr"/>
+          <a:lstStyle/>
+          <a:p>
+            <a:pPr algn="ctr" indent="0" marL="0">
+              <a:buNone/>
+            </a:pPr>
+            <a:r>
+              <a:rPr lang="en-US" sz="1600" b="1" dirty="0">
+                <a:solidFill>
+                  <a:schemeClr val="tx2"/>
+                </a:solidFill>
+              </a:rPr>
+              <a:t>Git ile sürümlenir · Kurallar eylemcilere dosyada verilir</a:t>
+            </a:r>
+            <a:endParaRPr lang="en-US" sz="1600" dirty="0"/>
+          </a:p>
+        </p:txBody>
+      </p:sp>
+      <p:sp>
+        <p:nvSpPr>
+          <p:cNvPr id="22" name="Text 15"/>
+          <p:cNvSpPr txBox="1"/>
+          <p:nvPr/>
+        </p:nvSpPr>
+        <p:spPr>
+          <a:xfrm>
+            <a:off x="548640" y="4389120"/>
+            <a:ext cx="5486400" cy="274320"/>
+          </a:xfrm>
+          <a:prstGeom prst="rect">
+            <a:avLst/>
+          </a:prstGeom>
+          <a:noFill/>
+          <a:ln/>
+        </p:spPr>
+        <p:txBody>
+          <a:bodyPr wrap="square" lIns="0" tIns="0" rIns="0" bIns="0" rtlCol="0" anchor="ctr"/>
+          <a:lstStyle/>
+          <a:p>
+            <a:pPr indent="0" marL="0">
+              <a:buNone/>
+            </a:pPr>
+            <a:r>
+              <a:rPr lang="en-US" sz="1200" b="1" spc="200" kern="0" dirty="0">
+                <a:solidFill>
+                  <a:schemeClr val="accent3"/>
+                </a:solidFill>
+              </a:rPr>
+              <a:t>ÖRNEK UYGULAMA · KENDİ CV DEPOM</a:t>
+            </a:r>
+            <a:endParaRPr lang="en-US" sz="1200" dirty="0"/>
+          </a:p>
+        </p:txBody>
+      </p:sp>
+      <p:sp>
+        <p:nvSpPr>
+          <p:cNvPr id="23" name="Text 16"/>
+          <p:cNvSpPr txBox="1"/>
+          <p:nvPr/>
+        </p:nvSpPr>
+        <p:spPr>
+          <a:xfrm>
+            <a:off x="548640" y="4709160"/>
+            <a:ext cx="2773604" cy="1280160"/>
+          </a:xfrm>
+          <a:prstGeom prst="rect">
+            <a:avLst/>
+          </a:prstGeom>
+          <a:noFill/>
+          <a:ln/>
+        </p:spPr>
+        <p:txBody>
           <a:bodyPr wrap="square" lIns="0" tIns="0" rIns="0" bIns="0" rtlCol="0" anchor="t"/>
           <a:lstStyle/>
           <a:p>
@@ -4374,7 +4531,7 @@
               <a:buNone/>
             </a:pPr>
             <a:r>
-              <a:rPr lang="en-US" sz="4800" b="1" dirty="0">
+              <a:rPr lang="en-US" sz="4400" b="1" dirty="0">
                 <a:solidFill>
                   <a:schemeClr val="accent3"/>
                 </a:solidFill>
@@ -4384,7 +4541,7 @@
               </a:rPr>
               <a:t>71</a:t>
             </a:r>
-            <a:endParaRPr lang="en-US" sz="4800" dirty="0"/>
+            <a:endParaRPr lang="en-US" sz="4400" dirty="0"/>
           </a:p>
           <a:p>
             <a:pPr algn="ctr" indent="0" marL="0">
@@ -4398,20 +4555,20 @@
               </a:rPr>
               <a:t>proje kaydı</a:t>
             </a:r>
-            <a:endParaRPr lang="en-US" sz="4800" dirty="0"/>
-          </a:p>
-        </p:txBody>
-      </p:sp>
-      <p:sp>
-        <p:nvSpPr>
-          <p:cNvPr id="22" name="Text 15"/>
+            <a:endParaRPr lang="en-US" sz="4400" dirty="0"/>
+          </a:p>
+        </p:txBody>
+      </p:sp>
+      <p:sp>
+        <p:nvSpPr>
+          <p:cNvPr id="24" name="Text 17"/>
           <p:cNvSpPr txBox="1"/>
           <p:nvPr/>
         </p:nvSpPr>
         <p:spPr>
           <a:xfrm>
-            <a:off x="3322244" y="4297680"/>
-            <a:ext cx="2773604" cy="1463040"/>
+            <a:off x="3322244" y="4709160"/>
+            <a:ext cx="2773604" cy="1280160"/>
           </a:xfrm>
           <a:prstGeom prst="rect">
             <a:avLst/>
@@ -4427,7 +4584,7 @@
               <a:buNone/>
             </a:pPr>
             <a:r>
-              <a:rPr lang="en-US" sz="4800" b="1" dirty="0">
+              <a:rPr lang="en-US" sz="4400" b="1" dirty="0">
                 <a:solidFill>
                   <a:schemeClr val="accent3"/>
                 </a:solidFill>
@@ -4437,7 +4594,7 @@
               </a:rPr>
               <a:t>4</a:t>
             </a:r>
-            <a:endParaRPr lang="en-US" sz="4800" dirty="0"/>
+            <a:endParaRPr lang="en-US" sz="4400" dirty="0"/>
           </a:p>
           <a:p>
             <a:pPr algn="ctr" indent="0" marL="0">
@@ -4451,20 +4608,20 @@
               </a:rPr>
               <a:t>alan CV'si</a:t>
             </a:r>
-            <a:endParaRPr lang="en-US" sz="4800" dirty="0"/>
-          </a:p>
-        </p:txBody>
-      </p:sp>
-      <p:sp>
-        <p:nvSpPr>
-          <p:cNvPr id="23" name="Text 16"/>
+            <a:endParaRPr lang="en-US" sz="4400" dirty="0"/>
+          </a:p>
+        </p:txBody>
+      </p:sp>
+      <p:sp>
+        <p:nvSpPr>
+          <p:cNvPr id="25" name="Text 18"/>
           <p:cNvSpPr txBox="1"/>
           <p:nvPr/>
         </p:nvSpPr>
         <p:spPr>
           <a:xfrm>
-            <a:off x="6095848" y="4297680"/>
-            <a:ext cx="2773604" cy="1463040"/>
+            <a:off x="6095848" y="4709160"/>
+            <a:ext cx="2773604" cy="1280160"/>
           </a:xfrm>
           <a:prstGeom prst="rect">
             <a:avLst/>
@@ -4480,7 +4637,7 @@
               <a:buNone/>
             </a:pPr>
             <a:r>
-              <a:rPr lang="en-US" sz="4800" b="1" dirty="0">
+              <a:rPr lang="en-US" sz="4400" b="1" dirty="0">
                 <a:solidFill>
                   <a:schemeClr val="accent3"/>
                 </a:solidFill>
@@ -4490,7 +4647,7 @@
               </a:rPr>
               <a:t>64</a:t>
             </a:r>
-            <a:endParaRPr lang="en-US" sz="4800" dirty="0"/>
+            <a:endParaRPr lang="en-US" sz="4400" dirty="0"/>
           </a:p>
           <a:p>
             <a:pPr algn="ctr" indent="0" marL="0">
@@ -4504,20 +4661,20 @@
               </a:rPr>
               <a:t>ilan paketi</a:t>
             </a:r>
-            <a:endParaRPr lang="en-US" sz="4800" dirty="0"/>
-          </a:p>
-        </p:txBody>
-      </p:sp>
-      <p:sp>
-        <p:nvSpPr>
-          <p:cNvPr id="24" name="Text 17"/>
+            <a:endParaRPr lang="en-US" sz="4400" dirty="0"/>
+          </a:p>
+        </p:txBody>
+      </p:sp>
+      <p:sp>
+        <p:nvSpPr>
+          <p:cNvPr id="26" name="Text 19"/>
           <p:cNvSpPr txBox="1"/>
           <p:nvPr/>
         </p:nvSpPr>
         <p:spPr>
           <a:xfrm>
-            <a:off x="8869451" y="4297680"/>
-            <a:ext cx="2773604" cy="1463040"/>
+            <a:off x="8869451" y="4709160"/>
+            <a:ext cx="2773604" cy="1280160"/>
           </a:xfrm>
           <a:prstGeom prst="rect">
             <a:avLst/>
@@ -4533,7 +4690,7 @@
               <a:buNone/>
             </a:pPr>
             <a:r>
-              <a:rPr lang="en-US" sz="4800" b="1" dirty="0">
+              <a:rPr lang="en-US" sz="4400" b="1" dirty="0">
                 <a:solidFill>
                   <a:schemeClr val="accent3"/>
                 </a:solidFill>
@@ -4543,7 +4700,7 @@
               </a:rPr>
               <a:t>76</a:t>
             </a:r>
-            <a:endParaRPr lang="en-US" sz="4800" dirty="0"/>
+            <a:endParaRPr lang="en-US" sz="4400" dirty="0"/>
           </a:p>
           <a:p>
             <a:pPr algn="ctr" indent="0" marL="0">
@@ -4557,7 +4714,7 @@
               </a:rPr>
               <a:t>commit</a:t>
             </a:r>
-            <a:endParaRPr lang="en-US" sz="4800" dirty="0"/>
+            <a:endParaRPr lang="en-US" sz="4400" dirty="0"/>
           </a:p>
         </p:txBody>
       </p:sp>
@@ -4701,7 +4858,7 @@
                   <a:schemeClr val="tx2"/>
                 </a:solidFill>
               </a:rPr>
-              <a:t>Tek Doğruluk Kaynağı: projects.yml</a:t>
+              <a:t>Tek Doğruluk Kaynağı Olmalı</a:t>
             </a:r>
             <a:endParaRPr lang="en-US" sz="3400" dirty="0"/>
           </a:p>
@@ -4709,18 +4866,68 @@
       </p:sp>
       <p:sp>
         <p:nvSpPr>
-          <p:cNvPr id="5" name="kod-kutusu"/>
+          <p:cNvPr id="5" name="Text 2"/>
+          <p:cNvSpPr txBox="1"/>
+          <p:nvPr/>
+        </p:nvSpPr>
+        <p:spPr>
+          <a:xfrm>
+            <a:off x="548640" y="1600200"/>
+            <a:ext cx="6400800" cy="274320"/>
+          </a:xfrm>
+          <a:prstGeom prst="rect">
+            <a:avLst/>
+          </a:prstGeom>
+          <a:noFill/>
+          <a:ln/>
+        </p:spPr>
+        <p:txBody>
+          <a:bodyPr wrap="square" lIns="0" tIns="0" rIns="0" bIns="0" rtlCol="0" anchor="ctr"/>
+          <a:lstStyle/>
+          <a:p>
+            <a:pPr indent="0" marL="0">
+              <a:buNone/>
+            </a:pPr>
+            <a:r>
+              <a:rPr lang="en-US" sz="1200" b="1" spc="200" kern="0" dirty="0">
+                <a:solidFill>
+                  <a:schemeClr val="accent3"/>
+                </a:solidFill>
+              </a:rPr>
+              <a:t>ÖRNEK ·</a:t>
+            </a:r>
+            <a:pPr indent="0" marL="0">
+              <a:buNone/>
+            </a:pPr>
+            <a:r>
+              <a:rPr lang="en-US" sz="1200" b="1" dirty="0">
+                <a:solidFill>
+                  <a:schemeClr val="accent3"/>
+                </a:solidFill>
+                <a:latin typeface="Courier New" pitchFamily="34" charset="0"/>
+                <a:ea typeface="Courier New" pitchFamily="34" charset="-122"/>
+                <a:cs typeface="Courier New" pitchFamily="34" charset="-120"/>
+              </a:rPr>
+              <a:t> info/projects.yml</a:t>
+            </a:r>
+            <a:endParaRPr lang="en-US" sz="1200" dirty="0"/>
+          </a:p>
+        </p:txBody>
+      </p:sp>
+      <p:sp>
+        <p:nvSpPr>
+          <p:cNvPr id="6" name="kod-kutusu"/>
           <p:cNvSpPr/>
           <p:nvPr/>
         </p:nvSpPr>
         <p:spPr>
           <a:xfrm>
-            <a:off x="548640" y="1691640"/>
-            <a:ext cx="6675120" cy="3749040"/>
+            <a:off x="548640" y="1965960"/>
+            <a:ext cx="6400800" cy="3246120"/>
           </a:xfrm>
           <a:prstGeom prst="roundRect">
             <a:avLst>
-              <a:gd name="adj" fmla="val 1951"/>
+              <a:gd name="adj" fmla="val 2254"/>
             </a:avLst>
           </a:prstGeom>
           <a:solidFill>
@@ -4731,14 +4938,14 @@
       </p:sp>
       <p:sp>
         <p:nvSpPr>
-          <p:cNvPr id="6" name="Text 3"/>
+          <p:cNvPr id="7" name="Text 4"/>
           <p:cNvSpPr txBox="1"/>
           <p:nvPr/>
         </p:nvSpPr>
         <p:spPr>
           <a:xfrm>
-            <a:off x="822960" y="1920240"/>
-            <a:ext cx="6126480" cy="3291840"/>
+            <a:off x="822960" y="2194560"/>
+            <a:ext cx="5852160" cy="2788920"/>
           </a:xfrm>
           <a:prstGeom prst="rect">
             <a:avLst/>
@@ -4813,7 +5020,7 @@
                 <a:ea typeface="Courier New" pitchFamily="34" charset="-122"/>
                 <a:cs typeface="Courier New" pitchFamily="34" charset="-120"/>
               </a:rPr>
-              <a:t>    tr: Ajan Dinamik Bellek</a:t>
+              <a:t>    tr: Eylemci Dinamik Bellek</a:t>
             </a:r>
             <a:endParaRPr lang="en-US" sz="1500" dirty="0"/>
           </a:p>
@@ -4940,13 +5147,13 @@
       </p:sp>
       <p:sp>
         <p:nvSpPr>
-          <p:cNvPr id="7" name="ikon-daire"/>
+          <p:cNvPr id="8" name="ikon-daire"/>
           <p:cNvSpPr/>
           <p:nvPr/>
         </p:nvSpPr>
         <p:spPr>
           <a:xfrm>
-            <a:off x="7589520" y="1874520"/>
+            <a:off x="7315200" y="2011680"/>
             <a:ext cx="566928" cy="566928"/>
           </a:xfrm>
           <a:prstGeom prst="ellipse">
@@ -4960,7 +5167,7 @@
       </p:sp>
       <p:pic>
         <p:nvPicPr>
-          <p:cNvPr id="8" name="ikon" descr="preencoded.png">    </p:cNvPr>
+          <p:cNvPr id="9" name="ikon" descr="preencoded.png">    </p:cNvPr>
           <p:cNvPicPr>
             <a:picLocks noChangeAspect="1"/>
           </p:cNvPicPr>
@@ -4974,7 +5181,7 @@
         </p:blipFill>
         <p:spPr>
           <a:xfrm>
-            <a:off x="7731252" y="2016252"/>
+            <a:off x="7456932" y="2153412"/>
             <a:ext cx="283464" cy="283464"/>
           </a:xfrm>
           <a:prstGeom prst="rect">
@@ -4984,14 +5191,14 @@
       </p:pic>
       <p:sp>
         <p:nvSpPr>
-          <p:cNvPr id="9" name="Text 5"/>
+          <p:cNvPr id="10" name="Text 6"/>
           <p:cNvSpPr txBox="1"/>
           <p:nvPr/>
         </p:nvSpPr>
         <p:spPr>
           <a:xfrm>
-            <a:off x="8385048" y="1828800"/>
-            <a:ext cx="3258007" cy="1097280"/>
+            <a:off x="8110728" y="1965960"/>
+            <a:ext cx="3532327" cy="777240"/>
           </a:xfrm>
           <a:prstGeom prst="rect">
             <a:avLst/>
@@ -5015,7 +5222,7 @@
                   <a:schemeClr val="tx2"/>
                 </a:solidFill>
               </a:rPr>
-              <a:t>İki dil tek kayıtta</a:t>
+              <a:t>Her bilgi tek yerde</a:t>
             </a:r>
             <a:endParaRPr lang="en-US" sz="1800" dirty="0"/>
           </a:p>
@@ -5032,7 +5239,7 @@
                   <a:schemeClr val="tx1"/>
                 </a:solidFill>
               </a:rPr>
-              <a:t>TR ve EN birbirinden kopmaz</a:t>
+              <a:t>CV'ler kopyalanmaz, kaynaktan türetilir</a:t>
             </a:r>
             <a:endParaRPr lang="en-US" sz="1800" dirty="0"/>
           </a:p>
@@ -5040,13 +5247,13 @@
       </p:sp>
       <p:sp>
         <p:nvSpPr>
-          <p:cNvPr id="10" name="ikon-daire"/>
+          <p:cNvPr id="11" name="ikon-daire"/>
           <p:cNvSpPr/>
           <p:nvPr/>
         </p:nvSpPr>
         <p:spPr>
           <a:xfrm>
-            <a:off x="7589520" y="3246120"/>
+            <a:off x="7315200" y="2852928"/>
             <a:ext cx="566928" cy="566928"/>
           </a:xfrm>
           <a:prstGeom prst="ellipse">
@@ -5060,7 +5267,7 @@
       </p:sp>
       <p:pic>
         <p:nvPicPr>
-          <p:cNvPr id="11" name="ikon" descr="preencoded.png">    </p:cNvPr>
+          <p:cNvPr id="12" name="ikon" descr="preencoded.png">    </p:cNvPr>
           <p:cNvPicPr>
             <a:picLocks noChangeAspect="1"/>
           </p:cNvPicPr>
@@ -5074,7 +5281,7 @@
         </p:blipFill>
         <p:spPr>
           <a:xfrm>
-            <a:off x="7731252" y="3387852"/>
+            <a:off x="7456932" y="2994660"/>
             <a:ext cx="283464" cy="283464"/>
           </a:xfrm>
           <a:prstGeom prst="rect">
@@ -5084,14 +5291,14 @@
       </p:pic>
       <p:sp>
         <p:nvSpPr>
-          <p:cNvPr id="12" name="Text 7"/>
+          <p:cNvPr id="13" name="Text 8"/>
           <p:cNvSpPr txBox="1"/>
           <p:nvPr/>
         </p:nvSpPr>
         <p:spPr>
           <a:xfrm>
-            <a:off x="8385048" y="3200400"/>
-            <a:ext cx="3258007" cy="1097280"/>
+            <a:off x="8110728" y="2807208"/>
+            <a:ext cx="3532327" cy="777240"/>
           </a:xfrm>
           <a:prstGeom prst="rect">
             <a:avLst/>
@@ -5115,7 +5322,7 @@
                   <a:schemeClr val="tx2"/>
                 </a:solidFill>
               </a:rPr>
-              <a:t>Tarih = commit aralığı</a:t>
+              <a:t>İki dil tek kayıtta</a:t>
             </a:r>
             <a:endParaRPr lang="en-US" sz="1800" dirty="0"/>
           </a:p>
@@ -5132,7 +5339,7 @@
                   <a:schemeClr val="tx1"/>
                 </a:solidFill>
               </a:rPr>
-              <a:t>Reponun ilk ve son commit'i</a:t>
+              <a:t>TR ve EN birbirinden kopmaz</a:t>
             </a:r>
             <a:endParaRPr lang="en-US" sz="1800" dirty="0"/>
           </a:p>
@@ -5140,13 +5347,13 @@
       </p:sp>
       <p:sp>
         <p:nvSpPr>
-          <p:cNvPr id="13" name="ikon-daire"/>
+          <p:cNvPr id="14" name="ikon-daire"/>
           <p:cNvSpPr/>
           <p:nvPr/>
         </p:nvSpPr>
         <p:spPr>
           <a:xfrm>
-            <a:off x="7589520" y="4617720"/>
+            <a:off x="7315200" y="3694176"/>
             <a:ext cx="566928" cy="566928"/>
           </a:xfrm>
           <a:prstGeom prst="ellipse">
@@ -5160,7 +5367,7 @@
       </p:sp>
       <p:pic>
         <p:nvPicPr>
-          <p:cNvPr id="14" name="ikon" descr="preencoded.png">    </p:cNvPr>
+          <p:cNvPr id="15" name="ikon" descr="preencoded.png">    </p:cNvPr>
           <p:cNvPicPr>
             <a:picLocks noChangeAspect="1"/>
           </p:cNvPicPr>
@@ -5174,7 +5381,7 @@
         </p:blipFill>
         <p:spPr>
           <a:xfrm>
-            <a:off x="7731252" y="4759452"/>
+            <a:off x="7456932" y="3835908"/>
             <a:ext cx="283464" cy="283464"/>
           </a:xfrm>
           <a:prstGeom prst="rect">
@@ -5184,14 +5391,14 @@
       </p:pic>
       <p:sp>
         <p:nvSpPr>
-          <p:cNvPr id="15" name="Text 9"/>
+          <p:cNvPr id="16" name="Text 10"/>
           <p:cNvSpPr txBox="1"/>
           <p:nvPr/>
         </p:nvSpPr>
         <p:spPr>
           <a:xfrm>
-            <a:off x="8385048" y="4572000"/>
-            <a:ext cx="3258007" cy="1097280"/>
+            <a:off x="8110728" y="3648456"/>
+            <a:ext cx="3532327" cy="777240"/>
           </a:xfrm>
           <a:prstGeom prst="rect">
             <a:avLst/>
@@ -5232,7 +5439,107 @@
                   <a:schemeClr val="tx1"/>
                 </a:solidFill>
               </a:rPr>
-              <a:t>Hangi alan CV'sine gireceğini belirler</a:t>
+              <a:t>Kaydın hangi CV'ye gireceğini belirler</a:t>
+            </a:r>
+            <a:endParaRPr lang="en-US" sz="1800" dirty="0"/>
+          </a:p>
+        </p:txBody>
+      </p:sp>
+      <p:sp>
+        <p:nvSpPr>
+          <p:cNvPr id="17" name="ikon-daire"/>
+          <p:cNvSpPr/>
+          <p:nvPr/>
+        </p:nvSpPr>
+        <p:spPr>
+          <a:xfrm>
+            <a:off x="7315200" y="4535424"/>
+            <a:ext cx="566928" cy="566928"/>
+          </a:xfrm>
+          <a:prstGeom prst="ellipse">
+            <a:avLst/>
+          </a:prstGeom>
+          <a:solidFill>
+            <a:schemeClr val="accent1"/>
+          </a:solidFill>
+          <a:ln/>
+        </p:spPr>
+      </p:sp>
+      <p:pic>
+        <p:nvPicPr>
+          <p:cNvPr id="18" name="ikon" descr="preencoded.png">    </p:cNvPr>
+          <p:cNvPicPr>
+            <a:picLocks noChangeAspect="1"/>
+          </p:cNvPicPr>
+          <p:nvPr/>
+        </p:nvPicPr>
+        <p:blipFill>
+          <a:blip r:embed="rId4"/>
+          <a:stretch>
+            <a:fillRect/>
+          </a:stretch>
+        </p:blipFill>
+        <p:spPr>
+          <a:xfrm>
+            <a:off x="7456932" y="4677156"/>
+            <a:ext cx="283464" cy="283464"/>
+          </a:xfrm>
+          <a:prstGeom prst="rect">
+            <a:avLst/>
+          </a:prstGeom>
+        </p:spPr>
+      </p:pic>
+      <p:sp>
+        <p:nvSpPr>
+          <p:cNvPr id="19" name="Text 12"/>
+          <p:cNvSpPr txBox="1"/>
+          <p:nvPr/>
+        </p:nvSpPr>
+        <p:spPr>
+          <a:xfrm>
+            <a:off x="8110728" y="4489704"/>
+            <a:ext cx="3532327" cy="777240"/>
+          </a:xfrm>
+          <a:prstGeom prst="rect">
+            <a:avLst/>
+          </a:prstGeom>
+          <a:noFill/>
+          <a:ln/>
+        </p:spPr>
+        <p:txBody>
+          <a:bodyPr wrap="square" lIns="0" tIns="0" rIns="0" bIns="0" rtlCol="0" anchor="t"/>
+          <a:lstStyle/>
+          <a:p>
+            <a:pPr indent="0" marL="0">
+              <a:spcAft>
+                <a:spcPts val="200"/>
+              </a:spcAft>
+              <a:buNone/>
+            </a:pPr>
+            <a:r>
+              <a:rPr lang="en-US" sz="1800" b="1" dirty="0">
+                <a:solidFill>
+                  <a:schemeClr val="tx2"/>
+                </a:solidFill>
+              </a:rPr>
+              <a:t>Tarih kanıttan gelir</a:t>
+            </a:r>
+            <a:endParaRPr lang="en-US" sz="1800" dirty="0"/>
+          </a:p>
+          <a:p>
+            <a:pPr indent="0" marL="0">
+              <a:spcAft>
+                <a:spcPts val="200"/>
+              </a:spcAft>
+              <a:buNone/>
+            </a:pPr>
+            <a:r>
+              <a:rPr lang="en-US" sz="1500" dirty="0">
+                <a:solidFill>
+                  <a:schemeClr val="tx1"/>
+                </a:solidFill>
+              </a:rPr>
+              <a:t>Örn. reponun ilk ve son commit'i</a:t>
             </a:r>
             <a:endParaRPr lang="en-US" sz="1800" dirty="0"/>
           </a:p>
@@ -5378,7 +5685,7 @@
                   <a:schemeClr val="tx2"/>
                 </a:solidFill>
               </a:rPr>
-              <a:t>Ajan Kuralları Dosyada Yaşar</a:t>
+              <a:t>Eylemcilere Kurallar Verilmeli</a:t>
             </a:r>
             <a:endParaRPr lang="en-US" sz="3400" dirty="0"/>
           </a:p>
@@ -5393,11 +5700,11 @@
         <p:spPr>
           <a:xfrm>
             <a:off x="548640" y="1691640"/>
-            <a:ext cx="3515258" cy="2011680"/>
+            <a:ext cx="3515258" cy="1737360"/>
           </a:xfrm>
           <a:prstGeom prst="roundRect">
             <a:avLst>
-              <a:gd name="adj" fmla="val 3636"/>
+              <a:gd name="adj" fmla="val 4211"/>
             </a:avLst>
           </a:prstGeom>
           <a:solidFill>
@@ -5414,8 +5721,8 @@
         </p:nvSpPr>
         <p:spPr>
           <a:xfrm>
-            <a:off x="822960" y="1965960"/>
-            <a:ext cx="548640" cy="548640"/>
+            <a:off x="822960" y="1920240"/>
+            <a:ext cx="502920" cy="502920"/>
           </a:xfrm>
           <a:prstGeom prst="ellipse">
             <a:avLst/>
@@ -5442,8 +5749,8 @@
         </p:blipFill>
         <p:spPr>
           <a:xfrm>
-            <a:off x="960120" y="2103120"/>
-            <a:ext cx="274320" cy="274320"/>
+            <a:off x="948690" y="2045970"/>
+            <a:ext cx="251460" cy="251460"/>
           </a:xfrm>
           <a:prstGeom prst="rect">
             <a:avLst/>
@@ -5458,8 +5765,8 @@
         </p:nvSpPr>
         <p:spPr>
           <a:xfrm>
-            <a:off x="822960" y="2606040"/>
-            <a:ext cx="2966618" cy="1005840"/>
+            <a:off x="822960" y="2532888"/>
+            <a:ext cx="2966618" cy="822960"/>
           </a:xfrm>
           <a:prstGeom prst="rect">
             <a:avLst/>
@@ -5483,7 +5790,7 @@
                   <a:schemeClr val="tx2"/>
                 </a:solidFill>
               </a:rPr>
-              <a:t>TR + EN eşzamanlı</a:t>
+              <a:t>Diller eşzamanlı</a:t>
             </a:r>
             <a:endParaRPr lang="en-US" sz="1800" dirty="0"/>
           </a:p>
@@ -5500,7 +5807,7 @@
                   <a:schemeClr val="tx1"/>
                 </a:solidFill>
               </a:rPr>
-              <a:t>Her değişiklik iki dile anlamca eşit yansır</a:t>
+              <a:t>Her değişiklik tüm dillere anlamca eşit yansır</a:t>
             </a:r>
             <a:endParaRPr lang="en-US" sz="1800" dirty="0"/>
           </a:p>
@@ -5515,11 +5822,11 @@
         <p:spPr>
           <a:xfrm>
             <a:off x="4338218" y="1691640"/>
-            <a:ext cx="3515258" cy="2011680"/>
+            <a:ext cx="3515258" cy="1737360"/>
           </a:xfrm>
           <a:prstGeom prst="roundRect">
             <a:avLst>
-              <a:gd name="adj" fmla="val 3636"/>
+              <a:gd name="adj" fmla="val 4211"/>
             </a:avLst>
           </a:prstGeom>
           <a:solidFill>
@@ -5536,8 +5843,8 @@
         </p:nvSpPr>
         <p:spPr>
           <a:xfrm>
-            <a:off x="4612538" y="1965960"/>
-            <a:ext cx="548640" cy="548640"/>
+            <a:off x="4612538" y="1920240"/>
+            <a:ext cx="502920" cy="502920"/>
           </a:xfrm>
           <a:prstGeom prst="ellipse">
             <a:avLst/>
@@ -5564,8 +5871,8 @@
         </p:blipFill>
         <p:spPr>
           <a:xfrm>
-            <a:off x="4749698" y="2103120"/>
-            <a:ext cx="274320" cy="274320"/>
+            <a:off x="4738268" y="2045970"/>
+            <a:ext cx="251460" cy="251460"/>
           </a:xfrm>
           <a:prstGeom prst="rect">
             <a:avLst/>
@@ -5580,8 +5887,8 @@
         </p:nvSpPr>
         <p:spPr>
           <a:xfrm>
-            <a:off x="4612538" y="2606040"/>
-            <a:ext cx="2966618" cy="1005840"/>
+            <a:off x="4612538" y="2532888"/>
+            <a:ext cx="2966618" cy="822960"/>
           </a:xfrm>
           <a:prstGeom prst="rect">
             <a:avLst/>
@@ -5605,7 +5912,7 @@
                   <a:schemeClr val="tx2"/>
                 </a:solidFill>
               </a:rPr>
-              <a:t>Sıfır halüsinasyon</a:t>
+              <a:t>Sıfır uydurma</a:t>
             </a:r>
             <a:endParaRPr lang="en-US" sz="1800" dirty="0"/>
           </a:p>
@@ -5622,7 +5929,7 @@
                   <a:schemeClr val="tx1"/>
                 </a:solidFill>
               </a:rPr>
-              <a:t>Gerçek olmayan bilgi yok; ilan canlı doğrulanır</a:t>
+              <a:t>Gerçek olmayan bilgi yazılmaz; ilan canlı doğrulanır</a:t>
             </a:r>
             <a:endParaRPr lang="en-US" sz="1800" dirty="0"/>
           </a:p>
@@ -5637,11 +5944,11 @@
         <p:spPr>
           <a:xfrm>
             <a:off x="8127797" y="1691640"/>
-            <a:ext cx="3515258" cy="2011680"/>
+            <a:ext cx="3515258" cy="1737360"/>
           </a:xfrm>
           <a:prstGeom prst="roundRect">
             <a:avLst>
-              <a:gd name="adj" fmla="val 3636"/>
+              <a:gd name="adj" fmla="val 4211"/>
             </a:avLst>
           </a:prstGeom>
           <a:solidFill>
@@ -5658,8 +5965,8 @@
         </p:nvSpPr>
         <p:spPr>
           <a:xfrm>
-            <a:off x="8402117" y="1965960"/>
-            <a:ext cx="548640" cy="548640"/>
+            <a:off x="8402117" y="1920240"/>
+            <a:ext cx="502920" cy="502920"/>
           </a:xfrm>
           <a:prstGeom prst="ellipse">
             <a:avLst/>
@@ -5686,8 +5993,8 @@
         </p:blipFill>
         <p:spPr>
           <a:xfrm>
-            <a:off x="8539277" y="2103120"/>
-            <a:ext cx="274320" cy="274320"/>
+            <a:off x="8527847" y="2045970"/>
+            <a:ext cx="251460" cy="251460"/>
           </a:xfrm>
           <a:prstGeom prst="rect">
             <a:avLst/>
@@ -5702,8 +6009,8 @@
         </p:nvSpPr>
         <p:spPr>
           <a:xfrm>
-            <a:off x="8402117" y="2606040"/>
-            <a:ext cx="2966618" cy="1005840"/>
+            <a:off x="8402117" y="2532888"/>
+            <a:ext cx="2966618" cy="822960"/>
           </a:xfrm>
           <a:prstGeom prst="rect">
             <a:avLst/>
@@ -5744,7 +6051,7 @@
                   <a:schemeClr val="tx1"/>
                 </a:solidFill>
               </a:rPr>
-              <a:t>"Şu anki veri" ile "gerçek veri" kıyaslanır</a:t>
+              <a:t>Eylemci farkı gösterir, insan onaylar</a:t>
             </a:r>
             <a:endParaRPr lang="en-US" sz="1800" dirty="0"/>
           </a:p>
@@ -5758,12 +6065,12 @@
         </p:nvSpPr>
         <p:spPr>
           <a:xfrm>
-            <a:off x="548640" y="3977640"/>
-            <a:ext cx="3515258" cy="2011680"/>
+            <a:off x="548640" y="3611880"/>
+            <a:ext cx="3515258" cy="1737360"/>
           </a:xfrm>
           <a:prstGeom prst="roundRect">
             <a:avLst>
-              <a:gd name="adj" fmla="val 3636"/>
+              <a:gd name="adj" fmla="val 4211"/>
             </a:avLst>
           </a:prstGeom>
           <a:solidFill>
@@ -5780,8 +6087,8 @@
         </p:nvSpPr>
         <p:spPr>
           <a:xfrm>
-            <a:off x="822960" y="4251960"/>
-            <a:ext cx="548640" cy="548640"/>
+            <a:off x="822960" y="3840480"/>
+            <a:ext cx="502920" cy="502920"/>
           </a:xfrm>
           <a:prstGeom prst="ellipse">
             <a:avLst/>
@@ -5808,8 +6115,8 @@
         </p:blipFill>
         <p:spPr>
           <a:xfrm>
-            <a:off x="960120" y="4389120"/>
-            <a:ext cx="274320" cy="274320"/>
+            <a:off x="948690" y="3966210"/>
+            <a:ext cx="251460" cy="251460"/>
           </a:xfrm>
           <a:prstGeom prst="rect">
             <a:avLst/>
@@ -5824,8 +6131,8 @@
         </p:nvSpPr>
         <p:spPr>
           <a:xfrm>
-            <a:off x="822960" y="4892040"/>
-            <a:ext cx="2966618" cy="1005840"/>
+            <a:off x="822960" y="4453128"/>
+            <a:ext cx="2966618" cy="822960"/>
           </a:xfrm>
           <a:prstGeom prst="rect">
             <a:avLst/>
@@ -5849,7 +6156,7 @@
                   <a:schemeClr val="tx2"/>
                 </a:solidFill>
               </a:rPr>
-              <a:t>Snapshot koruması</a:t>
+              <a:t>Başvuru anı korunur</a:t>
             </a:r>
             <a:endParaRPr lang="en-US" sz="1800" dirty="0"/>
           </a:p>
@@ -5866,7 +6173,7 @@
                   <a:schemeClr val="tx1"/>
                 </a:solidFill>
               </a:rPr>
-              <a:t>Başvurulan paket geriye dönük değişmez</a:t>
+              <a:t>Gönderilen CV sonradan değiştirilmez</a:t>
             </a:r>
             <a:endParaRPr lang="en-US" sz="1800" dirty="0"/>
           </a:p>
@@ -5880,12 +6187,12 @@
         </p:nvSpPr>
         <p:spPr>
           <a:xfrm>
-            <a:off x="4338218" y="3977640"/>
-            <a:ext cx="3515258" cy="2011680"/>
+            <a:off x="4338218" y="3611880"/>
+            <a:ext cx="3515258" cy="1737360"/>
           </a:xfrm>
           <a:prstGeom prst="roundRect">
             <a:avLst>
-              <a:gd name="adj" fmla="val 3636"/>
+              <a:gd name="adj" fmla="val 4211"/>
             </a:avLst>
           </a:prstGeom>
           <a:solidFill>
@@ -5902,8 +6209,8 @@
         </p:nvSpPr>
         <p:spPr>
           <a:xfrm>
-            <a:off x="4612538" y="4251960"/>
-            <a:ext cx="548640" cy="548640"/>
+            <a:off x="4612538" y="3840480"/>
+            <a:ext cx="502920" cy="502920"/>
           </a:xfrm>
           <a:prstGeom prst="ellipse">
             <a:avLst/>
@@ -5930,8 +6237,8 @@
         </p:blipFill>
         <p:spPr>
           <a:xfrm>
-            <a:off x="4749698" y="4389120"/>
-            <a:ext cx="274320" cy="274320"/>
+            <a:off x="4738268" y="3966210"/>
+            <a:ext cx="251460" cy="251460"/>
           </a:xfrm>
           <a:prstGeom prst="rect">
             <a:avLst/>
@@ -5946,8 +6253,8 @@
         </p:nvSpPr>
         <p:spPr>
           <a:xfrm>
-            <a:off x="4612538" y="4892040"/>
-            <a:ext cx="2966618" cy="1005840"/>
+            <a:off x="4612538" y="4453128"/>
+            <a:ext cx="2966618" cy="822960"/>
           </a:xfrm>
           <a:prstGeom prst="rect">
             <a:avLst/>
@@ -5988,7 +6295,7 @@
                   <a:schemeClr val="tx1"/>
                 </a:solidFill>
               </a:rPr>
-              <a:t>Taşma uyarısı yok, sayfa sayfa görsel kontrol, ATS metin çıkarımı</a:t>
+              <a:t>Taşma kontrolü, sayfa sayfa görsel kontrol, ATS metin çıkarımı</a:t>
             </a:r>
             <a:endParaRPr lang="en-US" sz="1800" dirty="0"/>
           </a:p>
@@ -6002,12 +6309,12 @@
         </p:nvSpPr>
         <p:spPr>
           <a:xfrm>
-            <a:off x="8127797" y="3977640"/>
-            <a:ext cx="3515258" cy="2011680"/>
+            <a:off x="8127797" y="3611880"/>
+            <a:ext cx="3515258" cy="1737360"/>
           </a:xfrm>
           <a:prstGeom prst="roundRect">
             <a:avLst>
-              <a:gd name="adj" fmla="val 3636"/>
+              <a:gd name="adj" fmla="val 4211"/>
             </a:avLst>
           </a:prstGeom>
           <a:solidFill>
@@ -6024,8 +6331,8 @@
         </p:nvSpPr>
         <p:spPr>
           <a:xfrm>
-            <a:off x="8402117" y="4251960"/>
-            <a:ext cx="548640" cy="548640"/>
+            <a:off x="8402117" y="3840480"/>
+            <a:ext cx="502920" cy="502920"/>
           </a:xfrm>
           <a:prstGeom prst="ellipse">
             <a:avLst/>
@@ -6052,8 +6359,8 @@
         </p:blipFill>
         <p:spPr>
           <a:xfrm>
-            <a:off x="8539277" y="4389120"/>
-            <a:ext cx="274320" cy="274320"/>
+            <a:off x="8527847" y="3966210"/>
+            <a:ext cx="251460" cy="251460"/>
           </a:xfrm>
           <a:prstGeom prst="rect">
             <a:avLst/>
@@ -6068,8 +6375,8 @@
         </p:nvSpPr>
         <p:spPr>
           <a:xfrm>
-            <a:off x="8402117" y="4892040"/>
-            <a:ext cx="2966618" cy="1005840"/>
+            <a:off x="8402117" y="4453128"/>
+            <a:ext cx="2966618" cy="822960"/>
           </a:xfrm>
           <a:prstGeom prst="rect">
             <a:avLst/>
@@ -6093,7 +6400,7 @@
                   <a:schemeClr val="bg1"/>
                 </a:solidFill>
               </a:rPr>
-              <a:t>Ajandan bağımsız</a:t>
+              <a:t>Kurallar dosyada</a:t>
             </a:r>
             <a:endParaRPr lang="en-US" sz="1800" dirty="0"/>
           </a:p>
@@ -6110,9 +6417,80 @@
                   <a:schemeClr val="bg2"/>
                 </a:solidFill>
               </a:rPr>
-              <a:t>AGENTS.md'yi Claude Code, Codex ve Gemini okur</a:t>
+              <a:t>Düz metin; hangi eylemci olursa olsun aynı dosyayı okur</a:t>
             </a:r>
             <a:endParaRPr lang="en-US" sz="1800" dirty="0"/>
+          </a:p>
+        </p:txBody>
+      </p:sp>
+      <p:sp>
+        <p:nvSpPr>
+          <p:cNvPr id="29" name="ornek-uygulama"/>
+          <p:cNvSpPr/>
+          <p:nvPr/>
+        </p:nvSpPr>
+        <p:spPr>
+          <a:xfrm>
+            <a:off x="548640" y="5532120"/>
+            <a:ext cx="11094415" cy="548640"/>
+          </a:xfrm>
+          <a:prstGeom prst="roundRect">
+            <a:avLst>
+              <a:gd name="adj" fmla="val 13333"/>
+            </a:avLst>
+          </a:prstGeom>
+          <a:solidFill>
+            <a:schemeClr val="accent2">
+              <a:alpha val="18000"/>
+            </a:schemeClr>
+          </a:solidFill>
+          <a:ln/>
+        </p:spPr>
+      </p:sp>
+      <p:sp>
+        <p:nvSpPr>
+          <p:cNvPr id="30" name="Text 21"/>
+          <p:cNvSpPr txBox="1"/>
+          <p:nvPr/>
+        </p:nvSpPr>
+        <p:spPr>
+          <a:xfrm>
+            <a:off x="868680" y="5532120"/>
+            <a:ext cx="10454335" cy="548640"/>
+          </a:xfrm>
+          <a:prstGeom prst="rect">
+            <a:avLst/>
+          </a:prstGeom>
+          <a:noFill/>
+          <a:ln/>
+        </p:spPr>
+        <p:txBody>
+          <a:bodyPr wrap="square" lIns="0" tIns="0" rIns="0" bIns="0" rtlCol="0" anchor="ctr"/>
+          <a:lstStyle/>
+          <a:p>
+            <a:pPr indent="0" marL="0">
+              <a:buNone/>
+            </a:pPr>
+            <a:r>
+              <a:rPr lang="en-US" sz="1200" b="1" spc="200" kern="0" dirty="0">
+                <a:solidFill>
+                  <a:schemeClr val="accent3"/>
+                </a:solidFill>
+              </a:rPr>
+              <a:t>ÖRNEK UYGULAMA   </a:t>
+            </a:r>
+            <a:pPr indent="0" marL="0">
+              <a:buNone/>
+            </a:pPr>
+            <a:r>
+              <a:rPr lang="en-US" sz="1500" dirty="0">
+                <a:solidFill>
+                  <a:schemeClr val="tx2"/>
+                </a:solidFill>
+              </a:rPr>
+              <a:t>AGENTS.md ve RULES.md dosyaları; Claude Code, Codex ve Gemini aynı dosyayı okur</a:t>
+            </a:r>
+            <a:endParaRPr lang="en-US" sz="1200" dirty="0"/>
           </a:p>
         </p:txBody>
       </p:sp>
@@ -6264,14 +6642,160 @@
       </p:sp>
       <p:sp>
         <p:nvSpPr>
-          <p:cNvPr id="5" name="komut"/>
+          <p:cNvPr id="5" name="Text 2"/>
+          <p:cNvSpPr txBox="1"/>
+          <p:nvPr/>
+        </p:nvSpPr>
+        <p:spPr>
+          <a:xfrm>
+            <a:off x="548640" y="1600200"/>
+            <a:ext cx="5486400" cy="274320"/>
+          </a:xfrm>
+          <a:prstGeom prst="rect">
+            <a:avLst/>
+          </a:prstGeom>
+          <a:noFill/>
+          <a:ln/>
+        </p:spPr>
+        <p:txBody>
+          <a:bodyPr wrap="square" lIns="0" tIns="0" rIns="0" bIns="0" rtlCol="0" anchor="ctr"/>
+          <a:lstStyle/>
+          <a:p>
+            <a:pPr indent="0" marL="0">
+              <a:buNone/>
+            </a:pPr>
+            <a:r>
+              <a:rPr lang="en-US" sz="1200" b="1" spc="200" kern="0" dirty="0">
+                <a:solidFill>
+                  <a:schemeClr val="accent3"/>
+                </a:solidFill>
+              </a:rPr>
+              <a:t>İŞ AKIŞI</a:t>
+            </a:r>
+            <a:endParaRPr lang="en-US" sz="1200" dirty="0"/>
+          </a:p>
+        </p:txBody>
+      </p:sp>
+      <p:sp>
+        <p:nvSpPr>
+          <p:cNvPr id="6" name="Text 3"/>
+          <p:cNvSpPr txBox="1"/>
+          <p:nvPr/>
+        </p:nvSpPr>
+        <p:spPr>
+          <a:xfrm>
+            <a:off x="7726680" y="1600200"/>
+            <a:ext cx="3916375" cy="274320"/>
+          </a:xfrm>
+          <a:prstGeom prst="rect">
+            <a:avLst/>
+          </a:prstGeom>
+          <a:noFill/>
+          <a:ln/>
+        </p:spPr>
+        <p:txBody>
+          <a:bodyPr wrap="square" lIns="0" tIns="0" rIns="0" bIns="0" rtlCol="0" anchor="ctr"/>
+          <a:lstStyle/>
+          <a:p>
+            <a:pPr indent="0" marL="0">
+              <a:buNone/>
+            </a:pPr>
+            <a:r>
+              <a:rPr lang="en-US" sz="1200" b="1" spc="200" kern="0" dirty="0">
+                <a:solidFill>
+                  <a:schemeClr val="accent3"/>
+                </a:solidFill>
+              </a:rPr>
+              <a:t>ÖRNEK KOMUT · KENDİ DEPOM</a:t>
+            </a:r>
+            <a:endParaRPr lang="en-US" sz="1200" dirty="0"/>
+          </a:p>
+        </p:txBody>
+      </p:sp>
+      <p:sp>
+        <p:nvSpPr>
+          <p:cNvPr id="7" name="Text 4"/>
+          <p:cNvSpPr txBox="1"/>
+          <p:nvPr/>
+        </p:nvSpPr>
+        <p:spPr>
+          <a:xfrm>
+            <a:off x="548640" y="1965960"/>
+            <a:ext cx="6675120" cy="713232"/>
+          </a:xfrm>
+          <a:prstGeom prst="rect">
+            <a:avLst/>
+          </a:prstGeom>
+          <a:noFill/>
+          <a:ln/>
+        </p:spPr>
+        <p:txBody>
+          <a:bodyPr wrap="square" lIns="0" tIns="0" rIns="0" bIns="0" rtlCol="0" anchor="ctr"/>
+          <a:lstStyle/>
+          <a:p>
+            <a:pPr indent="0" marL="0">
+              <a:buNone/>
+            </a:pPr>
+            <a:r>
+              <a:rPr lang="en-US" sz="1700" b="1" dirty="0">
+                <a:solidFill>
+                  <a:schemeClr val="tx2"/>
+                </a:solidFill>
+              </a:rPr>
+              <a:t>Hesap verisini güncelle</a:t>
+            </a:r>
+            <a:endParaRPr lang="en-US" sz="1700" dirty="0"/>
+          </a:p>
+          <a:p>
+            <a:pPr indent="0" marL="0">
+              <a:buNone/>
+            </a:pPr>
+            <a:r>
+              <a:rPr lang="en-US" sz="1400" dirty="0">
+                <a:solidFill>
+                  <a:schemeClr val="tx1"/>
+                </a:solidFill>
+              </a:rPr>
+              <a:t>Profil verisi çekilir, kaynakla kıyaslanır; her fark tek tek onaylanır</a:t>
+            </a:r>
+            <a:endParaRPr lang="en-US" sz="1700" dirty="0"/>
+          </a:p>
+        </p:txBody>
+      </p:sp>
+      <p:pic>
+        <p:nvPicPr>
+          <p:cNvPr id="8" name="Image 0" descr="preencoded.png">    </p:cNvPr>
+          <p:cNvPicPr>
+            <a:picLocks noChangeAspect="1"/>
+          </p:cNvPicPr>
+          <p:nvPr/>
+        </p:nvPicPr>
+        <p:blipFill>
+          <a:blip r:embed="rId1"/>
+          <a:stretch>
+            <a:fillRect/>
+          </a:stretch>
+        </p:blipFill>
+        <p:spPr>
+          <a:xfrm>
+            <a:off x="7333488" y="2203704"/>
+            <a:ext cx="237744" cy="237744"/>
+          </a:xfrm>
+          <a:prstGeom prst="rect">
+            <a:avLst/>
+          </a:prstGeom>
+        </p:spPr>
+      </p:pic>
+      <p:sp>
+        <p:nvSpPr>
+          <p:cNvPr id="9" name="komut"/>
           <p:cNvSpPr/>
           <p:nvPr/>
         </p:nvSpPr>
         <p:spPr>
           <a:xfrm>
-            <a:off x="548640" y="1691640"/>
-            <a:ext cx="3977640" cy="713232"/>
+            <a:off x="7726680" y="1965960"/>
+            <a:ext cx="3916375" cy="713232"/>
           </a:xfrm>
           <a:prstGeom prst="roundRect">
             <a:avLst>
@@ -6286,14 +6810,14 @@
       </p:sp>
       <p:sp>
         <p:nvSpPr>
-          <p:cNvPr id="6" name="Text 3"/>
+          <p:cNvPr id="10" name="Text 6"/>
           <p:cNvSpPr txBox="1"/>
           <p:nvPr/>
         </p:nvSpPr>
         <p:spPr>
           <a:xfrm>
-            <a:off x="731520" y="1691640"/>
-            <a:ext cx="3657600" cy="713232"/>
+            <a:off x="7909560" y="1965960"/>
+            <a:ext cx="3642055" cy="713232"/>
           </a:xfrm>
           <a:prstGeom prst="rect">
             <a:avLst/>
@@ -6325,14 +6849,14 @@
       </p:sp>
       <p:sp>
         <p:nvSpPr>
-          <p:cNvPr id="7" name="Text 4"/>
+          <p:cNvPr id="11" name="Text 7"/>
           <p:cNvSpPr txBox="1"/>
           <p:nvPr/>
         </p:nvSpPr>
         <p:spPr>
           <a:xfrm>
-            <a:off x="4800600" y="1691640"/>
-            <a:ext cx="6842455" cy="713232"/>
+            <a:off x="548640" y="2788920"/>
+            <a:ext cx="6675120" cy="713232"/>
           </a:xfrm>
           <a:prstGeom prst="rect">
             <a:avLst/>
@@ -6348,27 +6872,65 @@
               <a:buNone/>
             </a:pPr>
             <a:r>
-              <a:rPr lang="en-US" sz="1500" dirty="0">
+              <a:rPr lang="en-US" sz="1700" b="1" dirty="0">
+                <a:solidFill>
+                  <a:schemeClr val="tx2"/>
+                </a:solidFill>
+              </a:rPr>
+              <a:t>CV'leri kaynakla eşitle</a:t>
+            </a:r>
+            <a:endParaRPr lang="en-US" sz="1700" dirty="0"/>
+          </a:p>
+          <a:p>
+            <a:pPr indent="0" marL="0">
+              <a:buNone/>
+            </a:pPr>
+            <a:r>
+              <a:rPr lang="en-US" sz="1400" dirty="0">
                 <a:solidFill>
                   <a:schemeClr val="tx1"/>
                 </a:solidFill>
               </a:rPr>
-              <a:t>fetch_latest_data.py GitHub, Hugging Face, Medium, ORCID ve LinkedIn verisini çeker; ajan kıyaslar, madde madde onay ister</a:t>
-            </a:r>
-            <a:endParaRPr lang="en-US" sz="1500" dirty="0"/>
-          </a:p>
-        </p:txBody>
-      </p:sp>
-      <p:sp>
-        <p:nvSpPr>
-          <p:cNvPr id="8" name="komut"/>
+              <a:t>Kaynak dosya CV'lerle karşılaştırılır; yalnızca ilgili CV değişir</a:t>
+            </a:r>
+            <a:endParaRPr lang="en-US" sz="1700" dirty="0"/>
+          </a:p>
+        </p:txBody>
+      </p:sp>
+      <p:pic>
+        <p:nvPicPr>
+          <p:cNvPr id="12" name="Image 1" descr="preencoded.png">    </p:cNvPr>
+          <p:cNvPicPr>
+            <a:picLocks noChangeAspect="1"/>
+          </p:cNvPicPr>
+          <p:nvPr/>
+        </p:nvPicPr>
+        <p:blipFill>
+          <a:blip r:embed="rId2"/>
+          <a:stretch>
+            <a:fillRect/>
+          </a:stretch>
+        </p:blipFill>
+        <p:spPr>
+          <a:xfrm>
+            <a:off x="7333488" y="3026664"/>
+            <a:ext cx="237744" cy="237744"/>
+          </a:xfrm>
+          <a:prstGeom prst="rect">
+            <a:avLst/>
+          </a:prstGeom>
+        </p:spPr>
+      </p:pic>
+      <p:sp>
+        <p:nvSpPr>
+          <p:cNvPr id="13" name="komut"/>
           <p:cNvSpPr/>
           <p:nvPr/>
         </p:nvSpPr>
         <p:spPr>
           <a:xfrm>
-            <a:off x="548640" y="2578608"/>
-            <a:ext cx="3977640" cy="713232"/>
+            <a:off x="7726680" y="2788920"/>
+            <a:ext cx="3916375" cy="713232"/>
           </a:xfrm>
           <a:prstGeom prst="roundRect">
             <a:avLst>
@@ -6383,14 +6945,14 @@
       </p:sp>
       <p:sp>
         <p:nvSpPr>
-          <p:cNvPr id="9" name="Text 6"/>
+          <p:cNvPr id="14" name="Text 9"/>
           <p:cNvSpPr txBox="1"/>
           <p:nvPr/>
         </p:nvSpPr>
         <p:spPr>
           <a:xfrm>
-            <a:off x="731520" y="2578608"/>
-            <a:ext cx="3657600" cy="713232"/>
+            <a:off x="7909560" y="2788920"/>
+            <a:ext cx="3642055" cy="713232"/>
           </a:xfrm>
           <a:prstGeom prst="rect">
             <a:avLst/>
@@ -6422,14 +6984,14 @@
       </p:sp>
       <p:sp>
         <p:nvSpPr>
-          <p:cNvPr id="10" name="Text 7"/>
+          <p:cNvPr id="15" name="Text 10"/>
           <p:cNvSpPr txBox="1"/>
           <p:nvPr/>
         </p:nvSpPr>
         <p:spPr>
           <a:xfrm>
-            <a:off x="4800600" y="2578608"/>
-            <a:ext cx="6842455" cy="713232"/>
+            <a:off x="548640" y="3611880"/>
+            <a:ext cx="6675120" cy="713232"/>
           </a:xfrm>
           <a:prstGeom prst="rect">
             <a:avLst/>
@@ -6445,27 +7007,65 @@
               <a:buNone/>
             </a:pPr>
             <a:r>
-              <a:rPr lang="en-US" sz="1500" dirty="0">
+              <a:rPr lang="en-US" sz="1700" b="1" dirty="0">
+                <a:solidFill>
+                  <a:schemeClr val="tx2"/>
+                </a:solidFill>
+              </a:rPr>
+              <a:t>İlanı eşleştir</a:t>
+            </a:r>
+            <a:endParaRPr lang="en-US" sz="1700" dirty="0"/>
+          </a:p>
+          <a:p>
+            <a:pPr indent="0" marL="0">
+              <a:buNone/>
+            </a:pPr>
+            <a:r>
+              <a:rPr lang="en-US" sz="1400" dirty="0">
                 <a:solidFill>
                   <a:schemeClr val="tx1"/>
                 </a:solidFill>
               </a:rPr>
-              <a:t>info/*.yml ile kök ve alan CV'lerini karşılaştırır; ilgisiz alana dokunmaz</a:t>
-            </a:r>
-            <a:endParaRPr lang="en-US" sz="1500" dirty="0"/>
-          </a:p>
-        </p:txBody>
-      </p:sp>
-      <p:sp>
-        <p:nvSpPr>
-          <p:cNvPr id="11" name="komut"/>
+              <a:t>İlan metni analiz edilir; en uygun CV seçilir ya da yeni CV önerilir</a:t>
+            </a:r>
+            <a:endParaRPr lang="en-US" sz="1700" dirty="0"/>
+          </a:p>
+        </p:txBody>
+      </p:sp>
+      <p:pic>
+        <p:nvPicPr>
+          <p:cNvPr id="16" name="Image 2" descr="preencoded.png">    </p:cNvPr>
+          <p:cNvPicPr>
+            <a:picLocks noChangeAspect="1"/>
+          </p:cNvPicPr>
+          <p:nvPr/>
+        </p:nvPicPr>
+        <p:blipFill>
+          <a:blip r:embed="rId3"/>
+          <a:stretch>
+            <a:fillRect/>
+          </a:stretch>
+        </p:blipFill>
+        <p:spPr>
+          <a:xfrm>
+            <a:off x="7333488" y="3849624"/>
+            <a:ext cx="237744" cy="237744"/>
+          </a:xfrm>
+          <a:prstGeom prst="rect">
+            <a:avLst/>
+          </a:prstGeom>
+        </p:spPr>
+      </p:pic>
+      <p:sp>
+        <p:nvSpPr>
+          <p:cNvPr id="17" name="komut"/>
           <p:cNvSpPr/>
           <p:nvPr/>
         </p:nvSpPr>
         <p:spPr>
           <a:xfrm>
-            <a:off x="548640" y="3465576"/>
-            <a:ext cx="3977640" cy="713232"/>
+            <a:off x="7726680" y="3611880"/>
+            <a:ext cx="3916375" cy="713232"/>
           </a:xfrm>
           <a:prstGeom prst="roundRect">
             <a:avLst>
@@ -6480,14 +7080,14 @@
       </p:sp>
       <p:sp>
         <p:nvSpPr>
-          <p:cNvPr id="12" name="Text 9"/>
+          <p:cNvPr id="18" name="Text 12"/>
           <p:cNvSpPr txBox="1"/>
           <p:nvPr/>
         </p:nvSpPr>
         <p:spPr>
           <a:xfrm>
-            <a:off x="731520" y="3465576"/>
-            <a:ext cx="3657600" cy="713232"/>
+            <a:off x="7909560" y="3611880"/>
+            <a:ext cx="3642055" cy="713232"/>
           </a:xfrm>
           <a:prstGeom prst="rect">
             <a:avLst/>
@@ -6519,14 +7119,14 @@
       </p:sp>
       <p:sp>
         <p:nvSpPr>
-          <p:cNvPr id="13" name="Text 10"/>
+          <p:cNvPr id="19" name="Text 13"/>
           <p:cNvSpPr txBox="1"/>
           <p:nvPr/>
         </p:nvSpPr>
         <p:spPr>
           <a:xfrm>
-            <a:off x="4800600" y="3465576"/>
-            <a:ext cx="6842455" cy="713232"/>
+            <a:off x="548640" y="4434840"/>
+            <a:ext cx="6675120" cy="713232"/>
           </a:xfrm>
           <a:prstGeom prst="rect">
             <a:avLst/>
@@ -6542,27 +7142,65 @@
               <a:buNone/>
             </a:pPr>
             <a:r>
-              <a:rPr lang="en-US" sz="1500" dirty="0">
+              <a:rPr lang="en-US" sz="1700" b="1" dirty="0">
+                <a:solidFill>
+                  <a:schemeClr val="tx2"/>
+                </a:solidFill>
+              </a:rPr>
+              <a:t>İlan ara, CV hazırla</a:t>
+            </a:r>
+            <a:endParaRPr lang="en-US" sz="1700" dirty="0"/>
+          </a:p>
+          <a:p>
+            <a:pPr indent="0" marL="0">
+              <a:buNone/>
+            </a:pPr>
+            <a:r>
+              <a:rPr lang="en-US" sz="1400" dirty="0">
                 <a:solidFill>
                   <a:schemeClr val="tx1"/>
                 </a:solidFill>
               </a:rPr>
-              <a:t>İlan metnini analiz eder; en uygun CV'yi seçer ya da yeni paket önerir</a:t>
-            </a:r>
-            <a:endParaRPr lang="en-US" sz="1500" dirty="0"/>
-          </a:p>
-        </p:txBody>
-      </p:sp>
-      <p:sp>
-        <p:nvSpPr>
-          <p:cNvPr id="14" name="komut"/>
+              <a:t>İlanlar taranır; kapalı ve başvurulmuş olanlar elenir, paket hazırlanır</a:t>
+            </a:r>
+            <a:endParaRPr lang="en-US" sz="1700" dirty="0"/>
+          </a:p>
+        </p:txBody>
+      </p:sp>
+      <p:pic>
+        <p:nvPicPr>
+          <p:cNvPr id="20" name="Image 3" descr="preencoded.png">    </p:cNvPr>
+          <p:cNvPicPr>
+            <a:picLocks noChangeAspect="1"/>
+          </p:cNvPicPr>
+          <p:nvPr/>
+        </p:nvPicPr>
+        <p:blipFill>
+          <a:blip r:embed="rId4"/>
+          <a:stretch>
+            <a:fillRect/>
+          </a:stretch>
+        </p:blipFill>
+        <p:spPr>
+          <a:xfrm>
+            <a:off x="7333488" y="4672584"/>
+            <a:ext cx="237744" cy="237744"/>
+          </a:xfrm>
+          <a:prstGeom prst="rect">
+            <a:avLst/>
+          </a:prstGeom>
+        </p:spPr>
+      </p:pic>
+      <p:sp>
+        <p:nvSpPr>
+          <p:cNvPr id="21" name="komut"/>
           <p:cNvSpPr/>
           <p:nvPr/>
         </p:nvSpPr>
         <p:spPr>
           <a:xfrm>
-            <a:off x="548640" y="4352544"/>
-            <a:ext cx="3977640" cy="713232"/>
+            <a:off x="7726680" y="4434840"/>
+            <a:ext cx="3916375" cy="713232"/>
           </a:xfrm>
           <a:prstGeom prst="roundRect">
             <a:avLst>
@@ -6577,14 +7215,14 @@
       </p:sp>
       <p:sp>
         <p:nvSpPr>
-          <p:cNvPr id="15" name="Text 12"/>
+          <p:cNvPr id="22" name="Text 15"/>
           <p:cNvSpPr txBox="1"/>
           <p:nvPr/>
         </p:nvSpPr>
         <p:spPr>
           <a:xfrm>
-            <a:off x="731520" y="4352544"/>
-            <a:ext cx="3657600" cy="713232"/>
+            <a:off x="7909560" y="4434840"/>
+            <a:ext cx="3642055" cy="713232"/>
           </a:xfrm>
           <a:prstGeom prst="rect">
             <a:avLst/>
@@ -6616,14 +7254,14 @@
       </p:sp>
       <p:sp>
         <p:nvSpPr>
-          <p:cNvPr id="16" name="Text 13"/>
+          <p:cNvPr id="23" name="Text 16"/>
           <p:cNvSpPr txBox="1"/>
           <p:nvPr/>
         </p:nvSpPr>
         <p:spPr>
           <a:xfrm>
-            <a:off x="4800600" y="4352544"/>
-            <a:ext cx="6842455" cy="713232"/>
+            <a:off x="548640" y="5257800"/>
+            <a:ext cx="6675120" cy="713232"/>
           </a:xfrm>
           <a:prstGeom prst="rect">
             <a:avLst/>
@@ -6639,27 +7277,65 @@
               <a:buNone/>
             </a:pPr>
             <a:r>
-              <a:rPr lang="en-US" sz="1500" dirty="0">
+              <a:rPr lang="en-US" sz="1700" b="1" dirty="0">
+                <a:solidFill>
+                  <a:schemeClr val="tx2"/>
+                </a:solidFill>
+              </a:rPr>
+              <a:t>Eski ilanları temizle</a:t>
+            </a:r>
+            <a:endParaRPr lang="en-US" sz="1700" dirty="0"/>
+          </a:p>
+          <a:p>
+            <a:pPr indent="0" marL="0">
+              <a:buNone/>
+            </a:pPr>
+            <a:r>
+              <a:rPr lang="en-US" sz="1400" dirty="0">
                 <a:solidFill>
                   <a:schemeClr val="tx1"/>
                 </a:solidFill>
               </a:rPr>
-              <a:t>LinkedIn öncelikli tarar, kapalı ve başvurulmuş ilanları eler, paket hazırlar</a:t>
-            </a:r>
-            <a:endParaRPr lang="en-US" sz="1500" dirty="0"/>
-          </a:p>
-        </p:txBody>
-      </p:sp>
-      <p:sp>
-        <p:nvSpPr>
-          <p:cNvPr id="17" name="komut"/>
+              <a:t>Silinecekler önce listelenir; açık onaydan sonra silinir</a:t>
+            </a:r>
+            <a:endParaRPr lang="en-US" sz="1700" dirty="0"/>
+          </a:p>
+        </p:txBody>
+      </p:sp>
+      <p:pic>
+        <p:nvPicPr>
+          <p:cNvPr id="24" name="Image 4" descr="preencoded.png">    </p:cNvPr>
+          <p:cNvPicPr>
+            <a:picLocks noChangeAspect="1"/>
+          </p:cNvPicPr>
+          <p:nvPr/>
+        </p:nvPicPr>
+        <p:blipFill>
+          <a:blip r:embed="rId5"/>
+          <a:stretch>
+            <a:fillRect/>
+          </a:stretch>
+        </p:blipFill>
+        <p:spPr>
+          <a:xfrm>
+            <a:off x="7333488" y="5495544"/>
+            <a:ext cx="237744" cy="237744"/>
+          </a:xfrm>
+          <a:prstGeom prst="rect">
+            <a:avLst/>
+          </a:prstGeom>
+        </p:spPr>
+      </p:pic>
+      <p:sp>
+        <p:nvSpPr>
+          <p:cNvPr id="25" name="komut"/>
           <p:cNvSpPr/>
           <p:nvPr/>
         </p:nvSpPr>
         <p:spPr>
           <a:xfrm>
-            <a:off x="548640" y="5239512"/>
-            <a:ext cx="3977640" cy="713232"/>
+            <a:off x="7726680" y="5257800"/>
+            <a:ext cx="3916375" cy="713232"/>
           </a:xfrm>
           <a:prstGeom prst="roundRect">
             <a:avLst>
@@ -6674,14 +7350,14 @@
       </p:sp>
       <p:sp>
         <p:nvSpPr>
-          <p:cNvPr id="18" name="Text 15"/>
+          <p:cNvPr id="26" name="Text 18"/>
           <p:cNvSpPr txBox="1"/>
           <p:nvPr/>
         </p:nvSpPr>
         <p:spPr>
           <a:xfrm>
-            <a:off x="731520" y="5239512"/>
-            <a:ext cx="3657600" cy="713232"/>
+            <a:off x="7909560" y="5257800"/>
+            <a:ext cx="3642055" cy="713232"/>
           </a:xfrm>
           <a:prstGeom prst="rect">
             <a:avLst/>
@@ -6708,42 +7384,6 @@
               <a:t>eski ilanları temizle</a:t>
             </a:r>
             <a:endParaRPr lang="en-US" sz="1400" dirty="0"/>
-          </a:p>
-        </p:txBody>
-      </p:sp>
-      <p:sp>
-        <p:nvSpPr>
-          <p:cNvPr id="19" name="Text 16"/>
-          <p:cNvSpPr txBox="1"/>
-          <p:nvPr/>
-        </p:nvSpPr>
-        <p:spPr>
-          <a:xfrm>
-            <a:off x="4800600" y="5239512"/>
-            <a:ext cx="6842455" cy="713232"/>
-          </a:xfrm>
-          <a:prstGeom prst="rect">
-            <a:avLst/>
-          </a:prstGeom>
-          <a:noFill/>
-          <a:ln/>
-        </p:spPr>
-        <p:txBody>
-          <a:bodyPr wrap="square" lIns="0" tIns="0" rIns="0" bIns="0" rtlCol="0" anchor="ctr"/>
-          <a:lstStyle/>
-          <a:p>
-            <a:pPr indent="0" marL="0">
-              <a:buNone/>
-            </a:pPr>
-            <a:r>
-              <a:rPr lang="en-US" sz="1500" dirty="0">
-                <a:solidFill>
-                  <a:schemeClr val="tx1"/>
-                </a:solidFill>
-              </a:rPr>
-              <a:t>clean_old_jobs.py --dry-run ile listeler; tablo ve açık onaydan sonra siler</a:t>
-            </a:r>
-            <a:endParaRPr lang="en-US" sz="1500" dirty="0"/>
           </a:p>
         </p:txBody>
       </p:sp>
@@ -6887,7 +7527,7 @@
                   <a:schemeClr val="tx2"/>
                 </a:solidFill>
               </a:rPr>
-              <a:t>Bir İlan Paketinin Anatomisi</a:t>
+              <a:t>Her Başvurunun Kaydı Tutulmalı</a:t>
             </a:r>
             <a:endParaRPr lang="en-US" sz="3400" dirty="0"/>
           </a:p>
@@ -6895,272 +7535,27 @@
       </p:sp>
       <p:sp>
         <p:nvSpPr>
-          <p:cNvPr id="5" name="kod-kutusu"/>
+          <p:cNvPr id="5" name="ikon-daire"/>
           <p:cNvSpPr/>
           <p:nvPr/>
         </p:nvSpPr>
         <p:spPr>
           <a:xfrm>
-            <a:off x="548640" y="1691640"/>
-            <a:ext cx="5989320" cy="2377440"/>
-          </a:xfrm>
-          <a:prstGeom prst="roundRect">
-            <a:avLst>
-              <a:gd name="adj" fmla="val 3077"/>
-            </a:avLst>
+            <a:off x="548640" y="1828800"/>
+            <a:ext cx="566928" cy="566928"/>
+          </a:xfrm>
+          <a:prstGeom prst="ellipse">
+            <a:avLst/>
           </a:prstGeom>
           <a:solidFill>
-            <a:schemeClr val="tx2"/>
-          </a:solidFill>
-          <a:ln/>
-        </p:spPr>
-      </p:sp>
-      <p:sp>
-        <p:nvSpPr>
-          <p:cNvPr id="6" name="Text 3"/>
-          <p:cNvSpPr txBox="1"/>
-          <p:nvPr/>
-        </p:nvSpPr>
-        <p:spPr>
-          <a:xfrm>
-            <a:off x="822960" y="1920240"/>
-            <a:ext cx="5440680" cy="1920240"/>
-          </a:xfrm>
-          <a:prstGeom prst="rect">
-            <a:avLst/>
-          </a:prstGeom>
-          <a:noFill/>
-          <a:ln/>
-        </p:spPr>
-        <p:txBody>
-          <a:bodyPr wrap="square" lIns="0" tIns="0" rIns="0" bIns="0" rtlCol="0" anchor="t"/>
-          <a:lstStyle/>
-          <a:p>
-            <a:pPr indent="0" marL="0">
-              <a:buNone/>
-            </a:pPr>
-            <a:r>
-              <a:rPr lang="en-US" sz="1500" dirty="0">
-                <a:solidFill>
-                  <a:schemeClr val="bg1"/>
-                </a:solidFill>
-                <a:latin typeface="Courier New" pitchFamily="34" charset="0"/>
-                <a:ea typeface="Courier New" pitchFamily="34" charset="-122"/>
-                <a:cs typeface="Courier New" pitchFamily="34" charset="-120"/>
-              </a:rPr>
-              <a:t>ilana_ozel_cvler/</a:t>
-            </a:r>
-            <a:endParaRPr lang="en-US" sz="1500" dirty="0"/>
-          </a:p>
-          <a:p>
-            <a:pPr indent="0" marL="0">
-              <a:buNone/>
-            </a:pPr>
-            <a:r>
-              <a:rPr lang="en-US" sz="1500" dirty="0">
-                <a:solidFill>
-                  <a:schemeClr val="bg1"/>
-                </a:solidFill>
-                <a:latin typeface="Courier New" pitchFamily="34" charset="0"/>
-                <a:ea typeface="Courier New" pitchFamily="34" charset="-122"/>
-                <a:cs typeface="Courier New" pitchFamily="34" charset="-120"/>
-              </a:rPr>
-              <a:t>└── anzera_ai_engineer/</a:t>
-            </a:r>
-            <a:endParaRPr lang="en-US" sz="1500" dirty="0"/>
-          </a:p>
-          <a:p>
-            <a:pPr indent="0" marL="0">
-              <a:buNone/>
-            </a:pPr>
-            <a:r>
-              <a:rPr lang="en-US" sz="1500" dirty="0">
-                <a:solidFill>
-                  <a:schemeClr val="bg1"/>
-                </a:solidFill>
-                <a:latin typeface="Courier New" pitchFamily="34" charset="0"/>
-                <a:ea typeface="Courier New" pitchFamily="34" charset="-122"/>
-                <a:cs typeface="Courier New" pitchFamily="34" charset="-120"/>
-              </a:rPr>
-              <a:t>    ├── IS_ILANI.md</a:t>
-            </a:r>
-            <a:endParaRPr lang="en-US" sz="1500" dirty="0"/>
-          </a:p>
-          <a:p>
-            <a:pPr indent="0" marL="0">
-              <a:buNone/>
-            </a:pPr>
-            <a:r>
-              <a:rPr lang="en-US" sz="1500" dirty="0">
-                <a:solidFill>
-                  <a:schemeClr val="bg1"/>
-                </a:solidFill>
-                <a:latin typeface="Courier New" pitchFamily="34" charset="0"/>
-                <a:ea typeface="Courier New" pitchFamily="34" charset="-122"/>
-                <a:cs typeface="Courier New" pitchFamily="34" charset="-120"/>
-              </a:rPr>
-              <a:t>    │   ham ilan metni + bağlantı</a:t>
-            </a:r>
-            <a:endParaRPr lang="en-US" sz="1500" dirty="0"/>
-          </a:p>
-          <a:p>
-            <a:pPr indent="0" marL="0">
-              <a:buNone/>
-            </a:pPr>
-            <a:r>
-              <a:rPr lang="en-US" sz="1500" dirty="0">
-                <a:solidFill>
-                  <a:schemeClr val="bg1"/>
-                </a:solidFill>
-                <a:latin typeface="Courier New" pitchFamily="34" charset="0"/>
-                <a:ea typeface="Courier New" pitchFamily="34" charset="-122"/>
-                <a:cs typeface="Courier New" pitchFamily="34" charset="-120"/>
-              </a:rPr>
-              <a:t>    └── ILAN_NOTLARI.md</a:t>
-            </a:r>
-            <a:endParaRPr lang="en-US" sz="1500" dirty="0"/>
-          </a:p>
-          <a:p>
-            <a:pPr indent="0" marL="0">
-              <a:buNone/>
-            </a:pPr>
-            <a:r>
-              <a:rPr lang="en-US" sz="1500" dirty="0">
-                <a:solidFill>
-                  <a:schemeClr val="bg1"/>
-                </a:solidFill>
-                <a:latin typeface="Courier New" pitchFamily="34" charset="0"/>
-                <a:ea typeface="Courier New" pitchFamily="34" charset="-122"/>
-                <a:cs typeface="Courier New" pitchFamily="34" charset="-120"/>
-              </a:rPr>
-              <a:t>        eşleşme + tek CV önerisi</a:t>
-            </a:r>
-            <a:endParaRPr lang="en-US" sz="1500" dirty="0"/>
-          </a:p>
-        </p:txBody>
-      </p:sp>
-      <p:sp>
-        <p:nvSpPr>
-          <p:cNvPr id="7" name="Text 4"/>
-          <p:cNvSpPr txBox="1"/>
-          <p:nvPr/>
-        </p:nvSpPr>
-        <p:spPr>
-          <a:xfrm>
-            <a:off x="548640" y="4343400"/>
-            <a:ext cx="5989320" cy="822960"/>
-          </a:xfrm>
-          <a:prstGeom prst="rect">
-            <a:avLst/>
-          </a:prstGeom>
-          <a:noFill/>
-          <a:ln/>
-        </p:spPr>
-        <p:txBody>
-          <a:bodyPr wrap="square" lIns="0" tIns="0" rIns="0" bIns="0" rtlCol="0" anchor="ctr"/>
-          <a:lstStyle/>
-          <a:p>
-            <a:pPr indent="0" marL="0">
-              <a:buNone/>
-            </a:pPr>
-            <a:r>
-              <a:rPr lang="en-US" sz="4000" b="1" dirty="0">
-                <a:solidFill>
-                  <a:schemeClr val="accent3"/>
-                </a:solidFill>
-                <a:latin typeface="Cambria" pitchFamily="34" charset="0"/>
-                <a:ea typeface="Cambria" pitchFamily="34" charset="-122"/>
-                <a:cs typeface="Cambria" pitchFamily="34" charset="-120"/>
-              </a:rPr>
-              <a:t>64</a:t>
-            </a:r>
-            <a:pPr indent="0" marL="0">
-              <a:buNone/>
-            </a:pPr>
-            <a:r>
-              <a:rPr lang="en-US" sz="1600" dirty="0">
-                <a:solidFill>
-                  <a:schemeClr val="tx1"/>
-                </a:solidFill>
-              </a:rPr>
-              <a:t>  ilan paketi  ·  </a:t>
-            </a:r>
-            <a:pPr indent="0" marL="0">
-              <a:buNone/>
-            </a:pPr>
-            <a:r>
-              <a:rPr lang="en-US" sz="4000" b="1" dirty="0">
-                <a:solidFill>
-                  <a:schemeClr val="accent3"/>
-                </a:solidFill>
-                <a:latin typeface="Cambria" pitchFamily="34" charset="0"/>
-                <a:ea typeface="Cambria" pitchFamily="34" charset="-122"/>
-                <a:cs typeface="Cambria" pitchFamily="34" charset="-120"/>
-              </a:rPr>
-              <a:t>17</a:t>
-            </a:r>
-            <a:pPr indent="0" marL="0">
-              <a:buNone/>
-            </a:pPr>
-            <a:r>
-              <a:rPr lang="en-US" sz="1600" dirty="0">
-                <a:solidFill>
-                  <a:schemeClr val="tx1"/>
-                </a:solidFill>
-              </a:rPr>
-              <a:t>  pakette ilana özel CV</a:t>
-            </a:r>
-            <a:endParaRPr lang="en-US" sz="4000" dirty="0"/>
-          </a:p>
-        </p:txBody>
-      </p:sp>
-      <p:sp>
-        <p:nvSpPr>
-          <p:cNvPr id="8" name="kart"/>
-          <p:cNvSpPr/>
-          <p:nvPr/>
-        </p:nvSpPr>
-        <p:spPr>
-          <a:xfrm>
-            <a:off x="6903720" y="1691640"/>
-            <a:ext cx="4739335" cy="1783080"/>
-          </a:xfrm>
-          <a:prstGeom prst="roundRect">
-            <a:avLst>
-              <a:gd name="adj" fmla="val 4103"/>
-            </a:avLst>
-          </a:prstGeom>
-          <a:solidFill>
-            <a:schemeClr val="accent5">
-              <a:alpha val="12000"/>
-            </a:schemeClr>
-          </a:solidFill>
-          <a:ln/>
-        </p:spPr>
-      </p:sp>
-      <p:sp>
-        <p:nvSpPr>
-          <p:cNvPr id="9" name="ikon-daire"/>
-          <p:cNvSpPr/>
-          <p:nvPr/>
-        </p:nvSpPr>
-        <p:spPr>
-          <a:xfrm>
-            <a:off x="7178040" y="1965960"/>
-            <a:ext cx="548640" cy="548640"/>
-          </a:xfrm>
-          <a:prstGeom prst="ellipse">
-            <a:avLst/>
-          </a:prstGeom>
-          <a:solidFill>
-            <a:schemeClr val="accent5"/>
+            <a:schemeClr val="accent1"/>
           </a:solidFill>
           <a:ln/>
         </p:spPr>
       </p:sp>
       <p:pic>
         <p:nvPicPr>
-          <p:cNvPr id="10" name="ikon" descr="preencoded.png">    </p:cNvPr>
+          <p:cNvPr id="6" name="ikon" descr="preencoded.png">    </p:cNvPr>
           <p:cNvPicPr>
             <a:picLocks noChangeAspect="1"/>
           </p:cNvPicPr>
@@ -7174,8 +7569,8 @@
         </p:blipFill>
         <p:spPr>
           <a:xfrm>
-            <a:off x="7315200" y="2103120"/>
-            <a:ext cx="274320" cy="274320"/>
+            <a:off x="690372" y="1970532"/>
+            <a:ext cx="283464" cy="283464"/>
           </a:xfrm>
           <a:prstGeom prst="rect">
             <a:avLst/>
@@ -7184,14 +7579,14 @@
       </p:pic>
       <p:sp>
         <p:nvSpPr>
-          <p:cNvPr id="11" name="Text 7"/>
+          <p:cNvPr id="7" name="Text 3"/>
           <p:cNvSpPr txBox="1"/>
           <p:nvPr/>
         </p:nvSpPr>
         <p:spPr>
           <a:xfrm>
-            <a:off x="7955280" y="1920240"/>
-            <a:ext cx="3459175" cy="1371600"/>
+            <a:off x="1344168" y="1783080"/>
+            <a:ext cx="4873752" cy="914400"/>
           </a:xfrm>
           <a:prstGeom prst="rect">
             <a:avLst/>
@@ -7205,7 +7600,7 @@
           <a:p>
             <a:pPr indent="0" marL="0">
               <a:spcAft>
-                <a:spcPts val="400"/>
+                <a:spcPts val="200"/>
               </a:spcAft>
               <a:buNone/>
             </a:pPr>
@@ -7215,14 +7610,14 @@
                   <a:schemeClr val="tx2"/>
                 </a:solidFill>
               </a:rPr>
-              <a:t>Uygun ve güncel CV var</a:t>
+              <a:t>İlan metni saklanır</a:t>
             </a:r>
             <a:endParaRPr lang="en-US" sz="1800" dirty="0"/>
           </a:p>
           <a:p>
             <a:pPr indent="0" marL="0">
               <a:spcAft>
-                <a:spcPts val="400"/>
+                <a:spcPts val="200"/>
               </a:spcAft>
               <a:buNone/>
             </a:pPr>
@@ -7232,7 +7627,7 @@
                   <a:schemeClr val="tx1"/>
                 </a:solidFill>
               </a:rPr>
-              <a:t>genel_cvler/llm yeterli; yeni .tex ve .pdf üretilmedi (Anzera, AI Engineer)</a:t>
+              <a:t>İlan yayından kalksa da neye başvurulduğu bilinir</a:t>
             </a:r>
             <a:endParaRPr lang="en-US" sz="1800" dirty="0"/>
           </a:p>
@@ -7240,51 +7635,27 @@
       </p:sp>
       <p:sp>
         <p:nvSpPr>
-          <p:cNvPr id="12" name="kart"/>
+          <p:cNvPr id="8" name="ikon-daire"/>
           <p:cNvSpPr/>
           <p:nvPr/>
         </p:nvSpPr>
         <p:spPr>
           <a:xfrm>
-            <a:off x="6903720" y="3703320"/>
-            <a:ext cx="4739335" cy="1783080"/>
-          </a:xfrm>
-          <a:prstGeom prst="roundRect">
-            <a:avLst>
-              <a:gd name="adj" fmla="val 4103"/>
-            </a:avLst>
+            <a:off x="548640" y="2852928"/>
+            <a:ext cx="566928" cy="566928"/>
+          </a:xfrm>
+          <a:prstGeom prst="ellipse">
+            <a:avLst/>
           </a:prstGeom>
           <a:solidFill>
-            <a:schemeClr val="accent2">
-              <a:alpha val="12000"/>
-            </a:schemeClr>
-          </a:solidFill>
-          <a:ln/>
-        </p:spPr>
-      </p:sp>
-      <p:sp>
-        <p:nvSpPr>
-          <p:cNvPr id="13" name="ikon-daire"/>
-          <p:cNvSpPr/>
-          <p:nvPr/>
-        </p:nvSpPr>
-        <p:spPr>
-          <a:xfrm>
-            <a:off x="7178040" y="3977640"/>
-            <a:ext cx="548640" cy="548640"/>
-          </a:xfrm>
-          <a:prstGeom prst="ellipse">
-            <a:avLst/>
-          </a:prstGeom>
-          <a:solidFill>
-            <a:schemeClr val="accent2"/>
+            <a:schemeClr val="accent1"/>
           </a:solidFill>
           <a:ln/>
         </p:spPr>
       </p:sp>
       <p:pic>
         <p:nvPicPr>
-          <p:cNvPr id="14" name="ikon" descr="preencoded.png">    </p:cNvPr>
+          <p:cNvPr id="9" name="ikon" descr="preencoded.png">    </p:cNvPr>
           <p:cNvPicPr>
             <a:picLocks noChangeAspect="1"/>
           </p:cNvPicPr>
@@ -7298,8 +7669,8 @@
         </p:blipFill>
         <p:spPr>
           <a:xfrm>
-            <a:off x="7315200" y="4114800"/>
-            <a:ext cx="274320" cy="274320"/>
+            <a:off x="690372" y="2994660"/>
+            <a:ext cx="283464" cy="283464"/>
           </a:xfrm>
           <a:prstGeom prst="rect">
             <a:avLst/>
@@ -7308,14 +7679,14 @@
       </p:pic>
       <p:sp>
         <p:nvSpPr>
-          <p:cNvPr id="15" name="Text 10"/>
+          <p:cNvPr id="10" name="Text 5"/>
           <p:cNvSpPr txBox="1"/>
           <p:nvPr/>
         </p:nvSpPr>
         <p:spPr>
           <a:xfrm>
-            <a:off x="7955280" y="3931920"/>
-            <a:ext cx="3459175" cy="1371600"/>
+            <a:off x="1344168" y="2807208"/>
+            <a:ext cx="4873752" cy="914400"/>
           </a:xfrm>
           <a:prstGeom prst="rect">
             <a:avLst/>
@@ -7329,7 +7700,7 @@
           <a:p>
             <a:pPr indent="0" marL="0">
               <a:spcAft>
-                <a:spcPts val="400"/>
+                <a:spcPts val="200"/>
               </a:spcAft>
               <a:buNone/>
             </a:pPr>
@@ -7339,14 +7710,14 @@
                   <a:schemeClr val="tx2"/>
                 </a:solidFill>
               </a:rPr>
-              <a:t>Uygun CV yok ya da eski</a:t>
+              <a:t>Eşleşme notu tutulur</a:t>
             </a:r>
             <a:endParaRPr lang="en-US" sz="1800" dirty="0"/>
           </a:p>
           <a:p>
             <a:pPr indent="0" marL="0">
               <a:spcAft>
-                <a:spcPts val="400"/>
+                <a:spcPts val="200"/>
               </a:spcAft>
               <a:buNone/>
             </a:pPr>
@@ -7356,9 +7727,497 @@
                   <a:schemeClr val="tx1"/>
                 </a:solidFill>
               </a:rPr>
-              <a:t>info/ verisinden ilana özel TR/EN .tex ve .pdf üretilir</a:t>
+              <a:t>Hangi CV seçildi ve neden seçildi</a:t>
             </a:r>
             <a:endParaRPr lang="en-US" sz="1800" dirty="0"/>
+          </a:p>
+        </p:txBody>
+      </p:sp>
+      <p:sp>
+        <p:nvSpPr>
+          <p:cNvPr id="11" name="ikon-daire"/>
+          <p:cNvSpPr/>
+          <p:nvPr/>
+        </p:nvSpPr>
+        <p:spPr>
+          <a:xfrm>
+            <a:off x="548640" y="3877056"/>
+            <a:ext cx="566928" cy="566928"/>
+          </a:xfrm>
+          <a:prstGeom prst="ellipse">
+            <a:avLst/>
+          </a:prstGeom>
+          <a:solidFill>
+            <a:schemeClr val="accent5"/>
+          </a:solidFill>
+          <a:ln/>
+        </p:spPr>
+      </p:sp>
+      <p:pic>
+        <p:nvPicPr>
+          <p:cNvPr id="12" name="ikon" descr="preencoded.png">    </p:cNvPr>
+          <p:cNvPicPr>
+            <a:picLocks noChangeAspect="1"/>
+          </p:cNvPicPr>
+          <p:nvPr/>
+        </p:nvPicPr>
+        <p:blipFill>
+          <a:blip r:embed="rId3"/>
+          <a:stretch>
+            <a:fillRect/>
+          </a:stretch>
+        </p:blipFill>
+        <p:spPr>
+          <a:xfrm>
+            <a:off x="690372" y="4018788"/>
+            <a:ext cx="283464" cy="283464"/>
+          </a:xfrm>
+          <a:prstGeom prst="rect">
+            <a:avLst/>
+          </a:prstGeom>
+        </p:spPr>
+      </p:pic>
+      <p:sp>
+        <p:nvSpPr>
+          <p:cNvPr id="13" name="Text 7"/>
+          <p:cNvSpPr txBox="1"/>
+          <p:nvPr/>
+        </p:nvSpPr>
+        <p:spPr>
+          <a:xfrm>
+            <a:off x="1344168" y="3831336"/>
+            <a:ext cx="4873752" cy="914400"/>
+          </a:xfrm>
+          <a:prstGeom prst="rect">
+            <a:avLst/>
+          </a:prstGeom>
+          <a:noFill/>
+          <a:ln/>
+        </p:spPr>
+        <p:txBody>
+          <a:bodyPr wrap="square" lIns="0" tIns="0" rIns="0" bIns="0" rtlCol="0" anchor="t"/>
+          <a:lstStyle/>
+          <a:p>
+            <a:pPr indent="0" marL="0">
+              <a:spcAft>
+                <a:spcPts val="200"/>
+              </a:spcAft>
+              <a:buNone/>
+            </a:pPr>
+            <a:r>
+              <a:rPr lang="en-US" sz="1800" b="1" dirty="0">
+                <a:solidFill>
+                  <a:schemeClr val="tx2"/>
+                </a:solidFill>
+              </a:rPr>
+              <a:t>Önce mevcut CV denenir</a:t>
+            </a:r>
+            <a:endParaRPr lang="en-US" sz="1800" dirty="0"/>
+          </a:p>
+          <a:p>
+            <a:pPr indent="0" marL="0">
+              <a:spcAft>
+                <a:spcPts val="200"/>
+              </a:spcAft>
+              <a:buNone/>
+            </a:pPr>
+            <a:r>
+              <a:rPr lang="en-US" sz="1500" dirty="0">
+                <a:solidFill>
+                  <a:schemeClr val="tx1"/>
+                </a:solidFill>
+              </a:rPr>
+              <a:t>Uygun ve güncel CV varsa yenisi oluşturulmaz</a:t>
+            </a:r>
+            <a:endParaRPr lang="en-US" sz="1800" dirty="0"/>
+          </a:p>
+        </p:txBody>
+      </p:sp>
+      <p:sp>
+        <p:nvSpPr>
+          <p:cNvPr id="14" name="ikon-daire"/>
+          <p:cNvSpPr/>
+          <p:nvPr/>
+        </p:nvSpPr>
+        <p:spPr>
+          <a:xfrm>
+            <a:off x="548640" y="4901184"/>
+            <a:ext cx="566928" cy="566928"/>
+          </a:xfrm>
+          <a:prstGeom prst="ellipse">
+            <a:avLst/>
+          </a:prstGeom>
+          <a:solidFill>
+            <a:schemeClr val="accent2"/>
+          </a:solidFill>
+          <a:ln/>
+        </p:spPr>
+      </p:sp>
+      <p:pic>
+        <p:nvPicPr>
+          <p:cNvPr id="15" name="ikon" descr="preencoded.png">    </p:cNvPr>
+          <p:cNvPicPr>
+            <a:picLocks noChangeAspect="1"/>
+          </p:cNvPicPr>
+          <p:nvPr/>
+        </p:nvPicPr>
+        <p:blipFill>
+          <a:blip r:embed="rId4"/>
+          <a:stretch>
+            <a:fillRect/>
+          </a:stretch>
+        </p:blipFill>
+        <p:spPr>
+          <a:xfrm>
+            <a:off x="690372" y="5042916"/>
+            <a:ext cx="283464" cy="283464"/>
+          </a:xfrm>
+          <a:prstGeom prst="rect">
+            <a:avLst/>
+          </a:prstGeom>
+        </p:spPr>
+      </p:pic>
+      <p:sp>
+        <p:nvSpPr>
+          <p:cNvPr id="16" name="Text 9"/>
+          <p:cNvSpPr txBox="1"/>
+          <p:nvPr/>
+        </p:nvSpPr>
+        <p:spPr>
+          <a:xfrm>
+            <a:off x="1344168" y="4855464"/>
+            <a:ext cx="4873752" cy="914400"/>
+          </a:xfrm>
+          <a:prstGeom prst="rect">
+            <a:avLst/>
+          </a:prstGeom>
+          <a:noFill/>
+          <a:ln/>
+        </p:spPr>
+        <p:txBody>
+          <a:bodyPr wrap="square" lIns="0" tIns="0" rIns="0" bIns="0" rtlCol="0" anchor="t"/>
+          <a:lstStyle/>
+          <a:p>
+            <a:pPr indent="0" marL="0">
+              <a:spcAft>
+                <a:spcPts val="200"/>
+              </a:spcAft>
+              <a:buNone/>
+            </a:pPr>
+            <a:r>
+              <a:rPr lang="en-US" sz="1800" b="1" dirty="0">
+                <a:solidFill>
+                  <a:schemeClr val="tx2"/>
+                </a:solidFill>
+              </a:rPr>
+              <a:t>Gerekirse ilana özel CV</a:t>
+            </a:r>
+            <a:endParaRPr lang="en-US" sz="1800" dirty="0"/>
+          </a:p>
+          <a:p>
+            <a:pPr indent="0" marL="0">
+              <a:spcAft>
+                <a:spcPts val="200"/>
+              </a:spcAft>
+              <a:buNone/>
+            </a:pPr>
+            <a:r>
+              <a:rPr lang="en-US" sz="1500" dirty="0">
+                <a:solidFill>
+                  <a:schemeClr val="tx1"/>
+                </a:solidFill>
+              </a:rPr>
+              <a:t>Kaynaktan türetilir; elle kopyalanmaz</a:t>
+            </a:r>
+            <a:endParaRPr lang="en-US" sz="1800" dirty="0"/>
+          </a:p>
+        </p:txBody>
+      </p:sp>
+      <p:sp>
+        <p:nvSpPr>
+          <p:cNvPr id="17" name="Text 10"/>
+          <p:cNvSpPr txBox="1"/>
+          <p:nvPr/>
+        </p:nvSpPr>
+        <p:spPr>
+          <a:xfrm>
+            <a:off x="6583680" y="1600200"/>
+            <a:ext cx="5059375" cy="274320"/>
+          </a:xfrm>
+          <a:prstGeom prst="rect">
+            <a:avLst/>
+          </a:prstGeom>
+          <a:noFill/>
+          <a:ln/>
+        </p:spPr>
+        <p:txBody>
+          <a:bodyPr wrap="square" lIns="0" tIns="0" rIns="0" bIns="0" rtlCol="0" anchor="ctr"/>
+          <a:lstStyle/>
+          <a:p>
+            <a:pPr indent="0" marL="0">
+              <a:buNone/>
+            </a:pPr>
+            <a:r>
+              <a:rPr lang="en-US" sz="1200" b="1" spc="200" kern="0" dirty="0">
+                <a:solidFill>
+                  <a:schemeClr val="accent3"/>
+                </a:solidFill>
+              </a:rPr>
+              <a:t>ÖRNEK UYGULAMA · İLAN PAKETİ</a:t>
+            </a:r>
+            <a:endParaRPr lang="en-US" sz="1200" dirty="0"/>
+          </a:p>
+        </p:txBody>
+      </p:sp>
+      <p:sp>
+        <p:nvSpPr>
+          <p:cNvPr id="18" name="kod-kutusu"/>
+          <p:cNvSpPr/>
+          <p:nvPr/>
+        </p:nvSpPr>
+        <p:spPr>
+          <a:xfrm>
+            <a:off x="6583680" y="1965960"/>
+            <a:ext cx="5059375" cy="1965960"/>
+          </a:xfrm>
+          <a:prstGeom prst="roundRect">
+            <a:avLst>
+              <a:gd name="adj" fmla="val 3721"/>
+            </a:avLst>
+          </a:prstGeom>
+          <a:solidFill>
+            <a:schemeClr val="tx2"/>
+          </a:solidFill>
+          <a:ln/>
+        </p:spPr>
+      </p:sp>
+      <p:sp>
+        <p:nvSpPr>
+          <p:cNvPr id="19" name="Text 12"/>
+          <p:cNvSpPr txBox="1"/>
+          <p:nvPr/>
+        </p:nvSpPr>
+        <p:spPr>
+          <a:xfrm>
+            <a:off x="6858000" y="2194560"/>
+            <a:ext cx="4510735" cy="1508760"/>
+          </a:xfrm>
+          <a:prstGeom prst="rect">
+            <a:avLst/>
+          </a:prstGeom>
+          <a:noFill/>
+          <a:ln/>
+        </p:spPr>
+        <p:txBody>
+          <a:bodyPr wrap="square" lIns="0" tIns="0" rIns="0" bIns="0" rtlCol="0" anchor="t"/>
+          <a:lstStyle/>
+          <a:p>
+            <a:pPr indent="0" marL="0">
+              <a:buNone/>
+            </a:pPr>
+            <a:r>
+              <a:rPr lang="en-US" sz="1500" dirty="0">
+                <a:solidFill>
+                  <a:schemeClr val="bg1"/>
+                </a:solidFill>
+                <a:latin typeface="Courier New" pitchFamily="34" charset="0"/>
+                <a:ea typeface="Courier New" pitchFamily="34" charset="-122"/>
+                <a:cs typeface="Courier New" pitchFamily="34" charset="-120"/>
+              </a:rPr>
+              <a:t>ilana_ozel_cvler/</a:t>
+            </a:r>
+            <a:endParaRPr lang="en-US" sz="1500" dirty="0"/>
+          </a:p>
+          <a:p>
+            <a:pPr indent="0" marL="0">
+              <a:buNone/>
+            </a:pPr>
+            <a:r>
+              <a:rPr lang="en-US" sz="1500" dirty="0">
+                <a:solidFill>
+                  <a:schemeClr val="bg1"/>
+                </a:solidFill>
+                <a:latin typeface="Courier New" pitchFamily="34" charset="0"/>
+                <a:ea typeface="Courier New" pitchFamily="34" charset="-122"/>
+                <a:cs typeface="Courier New" pitchFamily="34" charset="-120"/>
+              </a:rPr>
+              <a:t>└── anzera_ai_engineer/</a:t>
+            </a:r>
+            <a:endParaRPr lang="en-US" sz="1500" dirty="0"/>
+          </a:p>
+          <a:p>
+            <a:pPr indent="0" marL="0">
+              <a:buNone/>
+            </a:pPr>
+            <a:r>
+              <a:rPr lang="en-US" sz="1500" dirty="0">
+                <a:solidFill>
+                  <a:schemeClr val="bg1"/>
+                </a:solidFill>
+                <a:latin typeface="Courier New" pitchFamily="34" charset="0"/>
+                <a:ea typeface="Courier New" pitchFamily="34" charset="-122"/>
+                <a:cs typeface="Courier New" pitchFamily="34" charset="-120"/>
+              </a:rPr>
+              <a:t>    ├── IS_ILANI.md</a:t>
+            </a:r>
+            <a:endParaRPr lang="en-US" sz="1500" dirty="0"/>
+          </a:p>
+          <a:p>
+            <a:pPr indent="0" marL="0">
+              <a:buNone/>
+            </a:pPr>
+            <a:r>
+              <a:rPr lang="en-US" sz="1500" dirty="0">
+                <a:solidFill>
+                  <a:schemeClr val="bg1"/>
+                </a:solidFill>
+                <a:latin typeface="Courier New" pitchFamily="34" charset="0"/>
+                <a:ea typeface="Courier New" pitchFamily="34" charset="-122"/>
+                <a:cs typeface="Courier New" pitchFamily="34" charset="-120"/>
+              </a:rPr>
+              <a:t>    │   ham ilan metni + bağlantı</a:t>
+            </a:r>
+            <a:endParaRPr lang="en-US" sz="1500" dirty="0"/>
+          </a:p>
+          <a:p>
+            <a:pPr indent="0" marL="0">
+              <a:buNone/>
+            </a:pPr>
+            <a:r>
+              <a:rPr lang="en-US" sz="1500" dirty="0">
+                <a:solidFill>
+                  <a:schemeClr val="bg1"/>
+                </a:solidFill>
+                <a:latin typeface="Courier New" pitchFamily="34" charset="0"/>
+                <a:ea typeface="Courier New" pitchFamily="34" charset="-122"/>
+                <a:cs typeface="Courier New" pitchFamily="34" charset="-120"/>
+              </a:rPr>
+              <a:t>    └── ILAN_NOTLARI.md</a:t>
+            </a:r>
+            <a:endParaRPr lang="en-US" sz="1500" dirty="0"/>
+          </a:p>
+          <a:p>
+            <a:pPr indent="0" marL="0">
+              <a:buNone/>
+            </a:pPr>
+            <a:r>
+              <a:rPr lang="en-US" sz="1500" dirty="0">
+                <a:solidFill>
+                  <a:schemeClr val="bg1"/>
+                </a:solidFill>
+                <a:latin typeface="Courier New" pitchFamily="34" charset="0"/>
+                <a:ea typeface="Courier New" pitchFamily="34" charset="-122"/>
+                <a:cs typeface="Courier New" pitchFamily="34" charset="-120"/>
+              </a:rPr>
+              <a:t>        eşleşme + tek CV önerisi</a:t>
+            </a:r>
+            <a:endParaRPr lang="en-US" sz="1500" dirty="0"/>
+          </a:p>
+        </p:txBody>
+      </p:sp>
+      <p:sp>
+        <p:nvSpPr>
+          <p:cNvPr id="20" name="Text 13"/>
+          <p:cNvSpPr txBox="1"/>
+          <p:nvPr/>
+        </p:nvSpPr>
+        <p:spPr>
+          <a:xfrm>
+            <a:off x="6583680" y="4206240"/>
+            <a:ext cx="2529688" cy="1188720"/>
+          </a:xfrm>
+          <a:prstGeom prst="rect">
+            <a:avLst/>
+          </a:prstGeom>
+          <a:noFill/>
+          <a:ln/>
+        </p:spPr>
+        <p:txBody>
+          <a:bodyPr wrap="square" lIns="0" tIns="0" rIns="0" bIns="0" rtlCol="0" anchor="t"/>
+          <a:lstStyle/>
+          <a:p>
+            <a:pPr algn="ctr" indent="0" marL="0">
+              <a:buNone/>
+            </a:pPr>
+            <a:r>
+              <a:rPr lang="en-US" sz="4000" b="1" dirty="0">
+                <a:solidFill>
+                  <a:schemeClr val="accent3"/>
+                </a:solidFill>
+                <a:latin typeface="Cambria" pitchFamily="34" charset="0"/>
+                <a:ea typeface="Cambria" pitchFamily="34" charset="-122"/>
+                <a:cs typeface="Cambria" pitchFamily="34" charset="-120"/>
+              </a:rPr>
+              <a:t>64</a:t>
+            </a:r>
+            <a:endParaRPr lang="en-US" sz="4000" dirty="0"/>
+          </a:p>
+          <a:p>
+            <a:pPr algn="ctr" indent="0" marL="0">
+              <a:buNone/>
+            </a:pPr>
+            <a:r>
+              <a:rPr lang="en-US" sz="1500" dirty="0">
+                <a:solidFill>
+                  <a:schemeClr val="tx1"/>
+                </a:solidFill>
+              </a:rPr>
+              <a:t>ilan paketi</a:t>
+            </a:r>
+            <a:endParaRPr lang="en-US" sz="4000" dirty="0"/>
+          </a:p>
+        </p:txBody>
+      </p:sp>
+      <p:sp>
+        <p:nvSpPr>
+          <p:cNvPr id="21" name="Text 14"/>
+          <p:cNvSpPr txBox="1"/>
+          <p:nvPr/>
+        </p:nvSpPr>
+        <p:spPr>
+          <a:xfrm>
+            <a:off x="9113368" y="4206240"/>
+            <a:ext cx="2529688" cy="1188720"/>
+          </a:xfrm>
+          <a:prstGeom prst="rect">
+            <a:avLst/>
+          </a:prstGeom>
+          <a:noFill/>
+          <a:ln/>
+        </p:spPr>
+        <p:txBody>
+          <a:bodyPr wrap="square" lIns="0" tIns="0" rIns="0" bIns="0" rtlCol="0" anchor="t"/>
+          <a:lstStyle/>
+          <a:p>
+            <a:pPr algn="ctr" indent="0" marL="0">
+              <a:buNone/>
+            </a:pPr>
+            <a:r>
+              <a:rPr lang="en-US" sz="4000" b="1" dirty="0">
+                <a:solidFill>
+                  <a:schemeClr val="accent3"/>
+                </a:solidFill>
+                <a:latin typeface="Cambria" pitchFamily="34" charset="0"/>
+                <a:ea typeface="Cambria" pitchFamily="34" charset="-122"/>
+                <a:cs typeface="Cambria" pitchFamily="34" charset="-120"/>
+              </a:rPr>
+              <a:t>17</a:t>
+            </a:r>
+            <a:endParaRPr lang="en-US" sz="4000" dirty="0"/>
+          </a:p>
+          <a:p>
+            <a:pPr algn="ctr" indent="0" marL="0">
+              <a:buNone/>
+            </a:pPr>
+            <a:r>
+              <a:rPr lang="en-US" sz="1500" dirty="0">
+                <a:solidFill>
+                  <a:schemeClr val="tx1"/>
+                </a:solidFill>
+              </a:rPr>
+              <a:t>pakette ilana özel CV</a:t>
+            </a:r>
+            <a:endParaRPr lang="en-US" sz="4000" dirty="0"/>
           </a:p>
         </p:txBody>
       </p:sp>
@@ -7898,7 +8757,7 @@
       </p:sp>
       <p:pic>
         <p:nvPicPr>
-          <p:cNvPr id="18" name="Image 3" descr="/tmp/claude-1000/-home-kayra-Desktop-github-repolarim-kurslar/6b167384-22ac-40e1-8a64-b99aeff95692/scratchpad/deck/img/yildiz.png">    </p:cNvPr>
+          <p:cNvPr id="18" name="Image 3" descr="/tmp/claude-1000/-home-kayra-Desktop-github-repolarim-kurslar/7c51a3db-9362-42b2-874a-4dd707c7318f/scratchpad/deck/img/yildiz.png">    </p:cNvPr>
           <p:cNvPicPr>
             <a:picLocks noChangeAspect="1"/>
           </p:cNvPicPr>
@@ -11397,7 +12256,7 @@
                             <a:schemeClr val="tx1"/>
                           </a:solidFill>
                         </a:rPr>
-                        <a:t>Ajan</a:t>
+                        <a:t>Eylemci</a:t>
                       </a:r>
                       <a:endParaRPr lang="en-US" sz="1400" dirty="0"/>
                     </a:p>
@@ -11458,7 +12317,7 @@
                             <a:schemeClr val="tx1"/>
                           </a:solidFill>
                         </a:rPr>
-                        <a:t>CLI ajanı: ilan tarar, 1-5 puanlar, CV uyarlar, takip eder</a:t>
+                        <a:t>CLI eylemcisi: ilan tarar, 1-5 puanlar, CV uyarlar, takip eder</a:t>
                       </a:r>
                       <a:endParaRPr lang="en-US" sz="1400" dirty="0"/>
                     </a:p>
@@ -11643,7 +12502,7 @@
                             <a:schemeClr val="tx1"/>
                           </a:solidFill>
                         </a:rPr>
-                        <a:t>Ajan</a:t>
+                        <a:t>Eylemci</a:t>
                       </a:r>
                       <a:endParaRPr lang="en-US" sz="1400" dirty="0"/>
                     </a:p>
@@ -11889,7 +12748,7 @@
                             <a:schemeClr val="accent4"/>
                           </a:solidFill>
                         </a:rPr>
-                        <a:t>Ajan</a:t>
+                        <a:t>Eylemci</a:t>
                       </a:r>
                       <a:endParaRPr lang="en-US" sz="1400" dirty="0"/>
                     </a:p>
@@ -12063,42 +12922,6 @@
           </a:graphicData>
         </a:graphic>
       </p:graphicFrame>
-      <p:sp>
-        <p:nvSpPr>
-          <p:cNvPr id="6" name="Text 2"/>
-          <p:cNvSpPr txBox="1"/>
-          <p:nvPr/>
-        </p:nvSpPr>
-        <p:spPr>
-          <a:xfrm>
-            <a:off x="548640" y="5943600"/>
-            <a:ext cx="11094415" cy="274320"/>
-          </a:xfrm>
-          <a:prstGeom prst="rect">
-            <a:avLst/>
-          </a:prstGeom>
-          <a:noFill/>
-          <a:ln/>
-        </p:spPr>
-        <p:txBody>
-          <a:bodyPr wrap="square" lIns="0" tIns="0" rIns="0" bIns="0" rtlCol="0" anchor="ctr"/>
-          <a:lstStyle/>
-          <a:p>
-            <a:pPr indent="0" marL="0">
-              <a:buNone/>
-            </a:pPr>
-            <a:r>
-              <a:rPr lang="en-US" sz="1200" i="1" dirty="0">
-                <a:solidFill>
-                  <a:schemeClr val="tx1"/>
-                </a:solidFill>
-              </a:rPr>
-              <a:t>Ayrıntılar ve bağlantılar: sunum/kaynaklar.md</a:t>
-            </a:r>
-            <a:endParaRPr lang="en-US" sz="1200" dirty="0"/>
-          </a:p>
-        </p:txBody>
-      </p:sp>
       <p:sp>
         <p:nvSpPr>
           <p:cNvPr id="25" name="Slide Number Placeholder 0"/>
@@ -13758,7 +14581,7 @@
                   <a:schemeClr val="tx1"/>
                 </a:solidFill>
               </a:rPr>
-              <a:t>Tek kaynak, Git, LaTeX ve ajan kuralları</a:t>
+              <a:t>Tek kaynak, sürüm kontrolü ve eylemci kuralları</a:t>
             </a:r>
             <a:endParaRPr lang="en-US" sz="4400" dirty="0"/>
           </a:p>
@@ -14588,7 +15411,7 @@
                   <a:schemeClr val="tx1"/>
                 </a:solidFill>
               </a:rPr>
-              <a:t>RenderCV veya LaTeX + Git + ajan (career-ops, ai-job-search ya da kendi AGENTS.md dosyan)</a:t>
+              <a:t>RenderCV veya LaTeX + Git + eylemci (career-ops, ai-job-search ya da kendi AGENTS.md dosyan)</a:t>
             </a:r>
             <a:endParaRPr lang="en-US" sz="1900" dirty="0"/>
           </a:p>
@@ -14817,7 +15640,7 @@
                   <a:schemeClr val="tx2"/>
                 </a:solidFill>
               </a:rPr>
-              <a:t>Halüsinasyon</a:t>
+              <a:t>Uydurma</a:t>
             </a:r>
             <a:endParaRPr lang="en-US" sz="1800" dirty="0"/>
           </a:p>
@@ -15256,7 +16079,7 @@
                   <a:schemeClr val="bg2"/>
                 </a:solidFill>
               </a:rPr>
-              <a:t>Ajan önerir, siz onaylarsınız.</a:t>
+              <a:t>Eylemci önerir, siz onaylarsınız.</a:t>
             </a:r>
             <a:endParaRPr lang="en-US" sz="2400" dirty="0"/>
           </a:p>
@@ -16308,37 +17131,6 @@
                   <a:schemeClr val="bg2"/>
                 </a:solidFill>
               </a:rPr>
-              <a:t>Araç listesi: </a:t>
-            </a:r>
-            <a:pPr indent="0" marL="0">
-              <a:spcAft>
-                <a:spcPts val="600"/>
-              </a:spcAft>
-              <a:buNone/>
-            </a:pPr>
-            <a:r>
-              <a:rPr lang="en-US" sz="1600" dirty="0">
-                <a:solidFill>
-                  <a:schemeClr val="bg2"/>
-                </a:solidFill>
-              </a:rPr>
-              <a:t>sunum/kaynaklar.md</a:t>
-            </a:r>
-            <a:endParaRPr lang="en-US" sz="1600" dirty="0"/>
-          </a:p>
-          <a:p>
-            <a:pPr indent="0" marL="0">
-              <a:spcAft>
-                <a:spcPts val="600"/>
-              </a:spcAft>
-              <a:buNone/>
-            </a:pPr>
-            <a:r>
-              <a:rPr lang="en-US" sz="1600" b="1" dirty="0">
-                <a:solidFill>
-                  <a:schemeClr val="bg2"/>
-                </a:solidFill>
-              </a:rPr>
               <a:t>GitHub: </a:t>
             </a:r>
             <a:pPr indent="0" marL="0">
@@ -16841,7 +17633,7 @@
                   <a:schemeClr val="tx1"/>
                 </a:solidFill>
               </a:rPr>
-              <a:t>Açık kaynak iş arama ajanları</a:t>
+              <a:t>Açık kaynak iş arama eylemcileri</a:t>
             </a:r>
             <a:endParaRPr lang="en-US" sz="1700" dirty="0"/>
           </a:p>
@@ -16899,7 +17691,7 @@
                   <a:schemeClr val="bg1"/>
                 </a:solidFill>
               </a:rPr>
-              <a:t>Fark yaratan araç değil; doğru, ölçülebilir ve ilana uygun içerik.</a:t>
+              <a:t>Farkı oluşturan araç değil; doğru, ölçülebilir ve ilana uygun içerik.</a:t>
             </a:r>
             <a:endParaRPr lang="en-US" sz="1800" dirty="0"/>
           </a:p>
@@ -18618,42 +19410,6 @@
       </p:sp>
       <p:sp>
         <p:nvSpPr>
-          <p:cNvPr id="36" name="Text 24"/>
-          <p:cNvSpPr txBox="1"/>
-          <p:nvPr/>
-        </p:nvSpPr>
-        <p:spPr>
-          <a:xfrm>
-            <a:off x="548640" y="5943600"/>
-            <a:ext cx="11094415" cy="274320"/>
-          </a:xfrm>
-          <a:prstGeom prst="rect">
-            <a:avLst/>
-          </a:prstGeom>
-          <a:noFill/>
-          <a:ln/>
-        </p:spPr>
-        <p:txBody>
-          <a:bodyPr wrap="square" lIns="0" tIns="0" rIns="0" bIns="0" rtlCol="0" anchor="ctr"/>
-          <a:lstStyle/>
-          <a:p>
-            <a:pPr indent="0" marL="0">
-              <a:buNone/>
-            </a:pPr>
-            <a:r>
-              <a:rPr lang="en-US" sz="1200" i="1" dirty="0">
-                <a:solidFill>
-                  <a:schemeClr val="tx1"/>
-                </a:solidFill>
-              </a:rPr>
-              <a:t>Kaynak: cv/RULES.md · kurallar dosyada yaşar; insan da ajan da aynı dosyayı okur</a:t>
-            </a:r>
-            <a:endParaRPr lang="en-US" sz="1200" dirty="0"/>
-          </a:p>
-        </p:txBody>
-      </p:sp>
-      <p:sp>
-        <p:nvSpPr>
           <p:cNvPr id="25" name="Slide Number Placeholder 0"/>
           <p:cNvSpPr>
             <a:spLocks noGrp="1"/>
@@ -20283,7 +21039,7 @@
                   <a:schemeClr val="tx2"/>
                 </a:solidFill>
               </a:rPr>
-              <a:t>Halüsinasyon freni</a:t>
+              <a:t>Uydurma freni</a:t>
             </a:r>
             <a:endParaRPr lang="en-US" sz="1800" dirty="0"/>
           </a:p>
@@ -20649,7 +21405,7 @@
                   <a:schemeClr val="tx2"/>
                 </a:solidFill>
               </a:rPr>
-              <a:t>Problem: Tek CV Her İlana Uymaz</a:t>
+              <a:t>Sorun: Tek CV Her İlana Uymaz</a:t>
             </a:r>
             <a:endParaRPr lang="en-US" sz="3400" dirty="0"/>
           </a:p>
@@ -20663,7 +21419,43 @@
         </p:nvSpPr>
         <p:spPr>
           <a:xfrm>
-            <a:off x="548640" y="1645920"/>
+            <a:off x="548640" y="1600200"/>
+            <a:ext cx="5486400" cy="274320"/>
+          </a:xfrm>
+          <a:prstGeom prst="rect">
+            <a:avLst/>
+          </a:prstGeom>
+          <a:noFill/>
+          <a:ln/>
+        </p:spPr>
+        <p:txBody>
+          <a:bodyPr wrap="square" lIns="0" tIns="0" rIns="0" bIns="0" rtlCol="0" anchor="ctr"/>
+          <a:lstStyle/>
+          <a:p>
+            <a:pPr indent="0" marL="0">
+              <a:buNone/>
+            </a:pPr>
+            <a:r>
+              <a:rPr lang="en-US" sz="1200" b="1" spc="200" kern="0" dirty="0">
+                <a:solidFill>
+                  <a:schemeClr val="accent3"/>
+                </a:solidFill>
+              </a:rPr>
+              <a:t>ÖRNEK · KENDİ CV DEPOM</a:t>
+            </a:r>
+            <a:endParaRPr lang="en-US" sz="1200" dirty="0"/>
+          </a:p>
+        </p:txBody>
+      </p:sp>
+      <p:sp>
+        <p:nvSpPr>
+          <p:cNvPr id="6" name="Text 3"/>
+          <p:cNvSpPr txBox="1"/>
+          <p:nvPr/>
+        </p:nvSpPr>
+        <p:spPr>
+          <a:xfrm>
+            <a:off x="548640" y="1874520"/>
             <a:ext cx="1005840" cy="1371600"/>
           </a:xfrm>
           <a:prstGeom prst="rect">
@@ -20710,49 +21502,49 @@
       </p:sp>
       <p:sp>
         <p:nvSpPr>
-          <p:cNvPr id="6" name="Text 3"/>
-          <p:cNvSpPr txBox="1"/>
-          <p:nvPr/>
-        </p:nvSpPr>
-        <p:spPr>
-          <a:xfrm>
-            <a:off x="1554480" y="1691640"/>
-            <a:ext cx="640080" cy="822960"/>
-          </a:xfrm>
-          <a:prstGeom prst="rect">
-            <a:avLst/>
-          </a:prstGeom>
-          <a:noFill/>
-          <a:ln/>
-        </p:spPr>
-        <p:txBody>
-          <a:bodyPr wrap="square" lIns="0" tIns="0" rIns="0" bIns="0" rtlCol="0" anchor="ctr"/>
-          <a:lstStyle/>
-          <a:p>
-            <a:pPr algn="ctr" indent="0" marL="0">
-              <a:buNone/>
-            </a:pPr>
-            <a:r>
-              <a:rPr lang="en-US" sz="3600" b="1" dirty="0">
-                <a:solidFill>
-                  <a:schemeClr val="accent2"/>
-                </a:solidFill>
-              </a:rPr>
-              <a:t>×</a:t>
-            </a:r>
-            <a:endParaRPr lang="en-US" sz="3600" dirty="0"/>
-          </a:p>
-        </p:txBody>
-      </p:sp>
-      <p:sp>
-        <p:nvSpPr>
           <p:cNvPr id="7" name="Text 4"/>
           <p:cNvSpPr txBox="1"/>
           <p:nvPr/>
         </p:nvSpPr>
         <p:spPr>
           <a:xfrm>
-            <a:off x="2194560" y="1645920"/>
+            <a:off x="1554480" y="1920240"/>
+            <a:ext cx="640080" cy="822960"/>
+          </a:xfrm>
+          <a:prstGeom prst="rect">
+            <a:avLst/>
+          </a:prstGeom>
+          <a:noFill/>
+          <a:ln/>
+        </p:spPr>
+        <p:txBody>
+          <a:bodyPr wrap="square" lIns="0" tIns="0" rIns="0" bIns="0" rtlCol="0" anchor="ctr"/>
+          <a:lstStyle/>
+          <a:p>
+            <a:pPr algn="ctr" indent="0" marL="0">
+              <a:buNone/>
+            </a:pPr>
+            <a:r>
+              <a:rPr lang="en-US" sz="3600" b="1" dirty="0">
+                <a:solidFill>
+                  <a:schemeClr val="accent2"/>
+                </a:solidFill>
+              </a:rPr>
+              <a:t>×</a:t>
+            </a:r>
+            <a:endParaRPr lang="en-US" sz="3600" dirty="0"/>
+          </a:p>
+        </p:txBody>
+      </p:sp>
+      <p:sp>
+        <p:nvSpPr>
+          <p:cNvPr id="8" name="Text 5"/>
+          <p:cNvSpPr txBox="1"/>
+          <p:nvPr/>
+        </p:nvSpPr>
+        <p:spPr>
+          <a:xfrm>
+            <a:off x="2194560" y="1874520"/>
             <a:ext cx="1005840" cy="1371600"/>
           </a:xfrm>
           <a:prstGeom prst="rect">
@@ -20799,49 +21591,49 @@
       </p:sp>
       <p:sp>
         <p:nvSpPr>
-          <p:cNvPr id="8" name="Text 5"/>
-          <p:cNvSpPr txBox="1"/>
-          <p:nvPr/>
-        </p:nvSpPr>
-        <p:spPr>
-          <a:xfrm>
-            <a:off x="3200400" y="1691640"/>
-            <a:ext cx="640080" cy="822960"/>
-          </a:xfrm>
-          <a:prstGeom prst="rect">
-            <a:avLst/>
-          </a:prstGeom>
-          <a:noFill/>
-          <a:ln/>
-        </p:spPr>
-        <p:txBody>
-          <a:bodyPr wrap="square" lIns="0" tIns="0" rIns="0" bIns="0" rtlCol="0" anchor="ctr"/>
-          <a:lstStyle/>
-          <a:p>
-            <a:pPr algn="ctr" indent="0" marL="0">
-              <a:buNone/>
-            </a:pPr>
-            <a:r>
-              <a:rPr lang="en-US" sz="3600" b="1" dirty="0">
-                <a:solidFill>
-                  <a:schemeClr val="accent2"/>
-                </a:solidFill>
-              </a:rPr>
-              <a:t>+</a:t>
-            </a:r>
-            <a:endParaRPr lang="en-US" sz="3600" dirty="0"/>
-          </a:p>
-        </p:txBody>
-      </p:sp>
-      <p:sp>
-        <p:nvSpPr>
           <p:cNvPr id="9" name="Text 6"/>
           <p:cNvSpPr txBox="1"/>
           <p:nvPr/>
         </p:nvSpPr>
         <p:spPr>
           <a:xfrm>
-            <a:off x="3840480" y="1645920"/>
+            <a:off x="3200400" y="1920240"/>
+            <a:ext cx="640080" cy="822960"/>
+          </a:xfrm>
+          <a:prstGeom prst="rect">
+            <a:avLst/>
+          </a:prstGeom>
+          <a:noFill/>
+          <a:ln/>
+        </p:spPr>
+        <p:txBody>
+          <a:bodyPr wrap="square" lIns="0" tIns="0" rIns="0" bIns="0" rtlCol="0" anchor="ctr"/>
+          <a:lstStyle/>
+          <a:p>
+            <a:pPr algn="ctr" indent="0" marL="0">
+              <a:buNone/>
+            </a:pPr>
+            <a:r>
+              <a:rPr lang="en-US" sz="3600" b="1" dirty="0">
+                <a:solidFill>
+                  <a:schemeClr val="accent2"/>
+                </a:solidFill>
+              </a:rPr>
+              <a:t>+</a:t>
+            </a:r>
+            <a:endParaRPr lang="en-US" sz="3600" dirty="0"/>
+          </a:p>
+        </p:txBody>
+      </p:sp>
+      <p:sp>
+        <p:nvSpPr>
+          <p:cNvPr id="10" name="Text 7"/>
+          <p:cNvSpPr txBox="1"/>
+          <p:nvPr/>
+        </p:nvSpPr>
+        <p:spPr>
+          <a:xfrm>
+            <a:off x="3840480" y="1874520"/>
             <a:ext cx="1737360" cy="1371600"/>
           </a:xfrm>
           <a:prstGeom prst="rect">
@@ -20888,49 +21680,49 @@
       </p:sp>
       <p:sp>
         <p:nvSpPr>
-          <p:cNvPr id="10" name="Text 7"/>
-          <p:cNvSpPr txBox="1"/>
-          <p:nvPr/>
-        </p:nvSpPr>
-        <p:spPr>
-          <a:xfrm>
-            <a:off x="5577840" y="1691640"/>
-            <a:ext cx="640080" cy="822960"/>
-          </a:xfrm>
-          <a:prstGeom prst="rect">
-            <a:avLst/>
-          </a:prstGeom>
-          <a:noFill/>
-          <a:ln/>
-        </p:spPr>
-        <p:txBody>
-          <a:bodyPr wrap="square" lIns="0" tIns="0" rIns="0" bIns="0" rtlCol="0" anchor="ctr"/>
-          <a:lstStyle/>
-          <a:p>
-            <a:pPr algn="ctr" indent="0" marL="0">
-              <a:buNone/>
-            </a:pPr>
-            <a:r>
-              <a:rPr lang="en-US" sz="3600" b="1" dirty="0">
-                <a:solidFill>
-                  <a:schemeClr val="accent2"/>
-                </a:solidFill>
-              </a:rPr>
-              <a:t>=</a:t>
-            </a:r>
-            <a:endParaRPr lang="en-US" sz="3600" dirty="0"/>
-          </a:p>
-        </p:txBody>
-      </p:sp>
-      <p:sp>
-        <p:nvSpPr>
           <p:cNvPr id="11" name="Text 8"/>
           <p:cNvSpPr txBox="1"/>
           <p:nvPr/>
         </p:nvSpPr>
         <p:spPr>
           <a:xfrm>
-            <a:off x="6217920" y="1691640"/>
+            <a:off x="5577840" y="1920240"/>
+            <a:ext cx="640080" cy="822960"/>
+          </a:xfrm>
+          <a:prstGeom prst="rect">
+            <a:avLst/>
+          </a:prstGeom>
+          <a:noFill/>
+          <a:ln/>
+        </p:spPr>
+        <p:txBody>
+          <a:bodyPr wrap="square" lIns="0" tIns="0" rIns="0" bIns="0" rtlCol="0" anchor="ctr"/>
+          <a:lstStyle/>
+          <a:p>
+            <a:pPr algn="ctr" indent="0" marL="0">
+              <a:buNone/>
+            </a:pPr>
+            <a:r>
+              <a:rPr lang="en-US" sz="3600" b="1" dirty="0">
+                <a:solidFill>
+                  <a:schemeClr val="accent2"/>
+                </a:solidFill>
+              </a:rPr>
+              <a:t>=</a:t>
+            </a:r>
+            <a:endParaRPr lang="en-US" sz="3600" dirty="0"/>
+          </a:p>
+        </p:txBody>
+      </p:sp>
+      <p:sp>
+        <p:nvSpPr>
+          <p:cNvPr id="12" name="Text 9"/>
+          <p:cNvSpPr txBox="1"/>
+          <p:nvPr/>
+        </p:nvSpPr>
+        <p:spPr>
+          <a:xfrm>
+            <a:off x="6217920" y="1920240"/>
             <a:ext cx="3657600" cy="822960"/>
           </a:xfrm>
           <a:prstGeom prst="rect">
@@ -20960,13 +21752,13 @@
       </p:sp>
       <p:sp>
         <p:nvSpPr>
-          <p:cNvPr id="12" name="ikon-daire"/>
+          <p:cNvPr id="13" name="ikon-daire"/>
           <p:cNvSpPr/>
           <p:nvPr/>
         </p:nvSpPr>
         <p:spPr>
           <a:xfrm>
-            <a:off x="548640" y="3200400"/>
+            <a:off x="548640" y="3337560"/>
             <a:ext cx="457200" cy="457200"/>
           </a:xfrm>
           <a:prstGeom prst="ellipse">
@@ -20980,7 +21772,7 @@
       </p:sp>
       <p:pic>
         <p:nvPicPr>
-          <p:cNvPr id="13" name="ikon" descr="preencoded.png">    </p:cNvPr>
+          <p:cNvPr id="14" name="ikon" descr="preencoded.png">    </p:cNvPr>
           <p:cNvPicPr>
             <a:picLocks noChangeAspect="1"/>
           </p:cNvPicPr>
@@ -20994,7 +21786,7 @@
         </p:blipFill>
         <p:spPr>
           <a:xfrm>
-            <a:off x="662940" y="3314700"/>
+            <a:off x="662940" y="3451860"/>
             <a:ext cx="228600" cy="228600"/>
           </a:xfrm>
           <a:prstGeom prst="rect">
@@ -21004,13 +21796,13 @@
       </p:pic>
       <p:sp>
         <p:nvSpPr>
-          <p:cNvPr id="14" name="Text 10"/>
+          <p:cNvPr id="15" name="Text 11"/>
           <p:cNvSpPr txBox="1"/>
           <p:nvPr/>
         </p:nvSpPr>
         <p:spPr>
           <a:xfrm>
-            <a:off x="1234440" y="3154680"/>
+            <a:off x="1234440" y="3291840"/>
             <a:ext cx="10408615" cy="548640"/>
           </a:xfrm>
           <a:prstGeom prst="rect">
@@ -21043,13 +21835,13 @@
       </p:sp>
       <p:sp>
         <p:nvSpPr>
-          <p:cNvPr id="15" name="ikon-daire"/>
+          <p:cNvPr id="16" name="ikon-daire"/>
           <p:cNvSpPr/>
           <p:nvPr/>
         </p:nvSpPr>
         <p:spPr>
           <a:xfrm>
-            <a:off x="548640" y="3886200"/>
+            <a:off x="548640" y="3995928"/>
             <a:ext cx="457200" cy="457200"/>
           </a:xfrm>
           <a:prstGeom prst="ellipse">
@@ -21063,7 +21855,7 @@
       </p:sp>
       <p:pic>
         <p:nvPicPr>
-          <p:cNvPr id="16" name="ikon" descr="preencoded.png">    </p:cNvPr>
+          <p:cNvPr id="17" name="ikon" descr="preencoded.png">    </p:cNvPr>
           <p:cNvPicPr>
             <a:picLocks noChangeAspect="1"/>
           </p:cNvPicPr>
@@ -21077,7 +21869,7 @@
         </p:blipFill>
         <p:spPr>
           <a:xfrm>
-            <a:off x="662940" y="4000500"/>
+            <a:off x="662940" y="4110228"/>
             <a:ext cx="228600" cy="228600"/>
           </a:xfrm>
           <a:prstGeom prst="rect">
@@ -21087,13 +21879,13 @@
       </p:pic>
       <p:sp>
         <p:nvSpPr>
-          <p:cNvPr id="17" name="Text 12"/>
+          <p:cNvPr id="18" name="Text 13"/>
           <p:cNvSpPr txBox="1"/>
           <p:nvPr/>
         </p:nvSpPr>
         <p:spPr>
           <a:xfrm>
-            <a:off x="1234440" y="3840480"/>
+            <a:off x="1234440" y="3950208"/>
             <a:ext cx="10408615" cy="548640"/>
           </a:xfrm>
           <a:prstGeom prst="rect">
@@ -21126,13 +21918,13 @@
       </p:sp>
       <p:sp>
         <p:nvSpPr>
-          <p:cNvPr id="18" name="ikon-daire"/>
+          <p:cNvPr id="19" name="ikon-daire"/>
           <p:cNvSpPr/>
           <p:nvPr/>
         </p:nvSpPr>
         <p:spPr>
           <a:xfrm>
-            <a:off x="548640" y="4572000"/>
+            <a:off x="548640" y="4654296"/>
             <a:ext cx="457200" cy="457200"/>
           </a:xfrm>
           <a:prstGeom prst="ellipse">
@@ -21146,7 +21938,7 @@
       </p:sp>
       <p:pic>
         <p:nvPicPr>
-          <p:cNvPr id="19" name="ikon" descr="preencoded.png">    </p:cNvPr>
+          <p:cNvPr id="20" name="ikon" descr="preencoded.png">    </p:cNvPr>
           <p:cNvPicPr>
             <a:picLocks noChangeAspect="1"/>
           </p:cNvPicPr>
@@ -21160,7 +21952,7 @@
         </p:blipFill>
         <p:spPr>
           <a:xfrm>
-            <a:off x="662940" y="4686300"/>
+            <a:off x="662940" y="4768596"/>
             <a:ext cx="228600" cy="228600"/>
           </a:xfrm>
           <a:prstGeom prst="rect">
@@ -21170,13 +21962,13 @@
       </p:pic>
       <p:sp>
         <p:nvSpPr>
-          <p:cNvPr id="20" name="Text 14"/>
+          <p:cNvPr id="21" name="Text 15"/>
           <p:cNvSpPr txBox="1"/>
           <p:nvPr/>
         </p:nvSpPr>
         <p:spPr>
           <a:xfrm>
-            <a:off x="1234440" y="4526280"/>
+            <a:off x="1234440" y="4608576"/>
             <a:ext cx="10408615" cy="548640"/>
           </a:xfrm>
           <a:prstGeom prst="rect">
@@ -21209,7 +22001,7 @@
       </p:sp>
       <p:sp>
         <p:nvSpPr>
-          <p:cNvPr id="21" name="ana-mesaj"/>
+          <p:cNvPr id="22" name="ana-mesaj"/>
           <p:cNvSpPr/>
           <p:nvPr/>
         </p:nvSpPr>
@@ -21231,7 +22023,7 @@
       </p:sp>
       <p:sp>
         <p:nvSpPr>
-          <p:cNvPr id="22" name="Text 16"/>
+          <p:cNvPr id="23" name="Text 17"/>
           <p:cNvSpPr txBox="1"/>
           <p:nvPr/>
         </p:nvSpPr>
@@ -21259,7 +22051,7 @@
                   <a:schemeClr val="bg1"/>
                 </a:solidFill>
               </a:rPr>
-              <a:t>Çözüm: tek doğruluk kaynağı + derleme + sürüm kontrolü + ajan otomasyonu</a:t>
+              <a:t>Çözüm: tek doğruluk kaynağı + derleme + sürüm kontrolü + eylemci otomasyonu</a:t>
             </a:r>
             <a:endParaRPr lang="en-US" sz="1800" dirty="0"/>
           </a:p>

</xml_diff>

<commit_message>
özellik: garip tercümeleri düzelt
</commit_message>
<xml_diff>
--- a/sunum/sunum.pptx
+++ b/sunum/sunum.pptx
@@ -129,14 +129,14 @@
   <p:extLst>
     <p:ext uri="{521415D9-36F7-43E2-AB2F-B90AF26B5E84}">
       <p14:sectionLst xmlns:p14="http://schemas.microsoft.com/office/powerpoint/2010/main">
-        <p14:section name="Giriş" id="{ee9b3bca-2b03-d076-d714-be39e5f7ee1d}">
+        <p14:section name="Giriş" id="{c1270a4b-c83e-e5f9-6a83-6c7ff95fa36f}">
           <p14:sldIdLst>
             <p14:sldId id="256"/>
             <p14:sldId id="257"/>
             <p14:sldId id="258"/>
           </p14:sldIdLst>
         </p14:section>
-        <p14:section name="01 · CV ve ATS" id="{2009220d-faf7-8c73-2ce1-d87b7f1a6569}">
+        <p14:section name="01 · CV ve ATS" id="{465693c9-9553-0be2-cd8e-c19ac53575ea}">
           <p14:sldIdLst>
             <p14:sldId id="259"/>
             <p14:sldId id="260"/>
@@ -145,7 +145,7 @@
             <p14:sldId id="263"/>
           </p14:sldIdLst>
         </p14:section>
-        <p14:section name="02 · CV'yi Kod Gibi Yönetmek" id="{f6208505-112c-57c5-0eb7-87276fe58fb8}">
+        <p14:section name="02 · CV'yi Kod Gibi Yönetmek" id="{81a31969-1ff0-b51d-b8a9-b7f3fa32efa1}">
           <p14:sldIdLst>
             <p14:sldId id="264"/>
             <p14:sldId id="265"/>
@@ -155,21 +155,21 @@
             <p14:sldId id="269"/>
           </p14:sldIdLst>
         </p14:section>
-        <p14:section name="03 · İlan Bulma" id="{90646348-341a-a340-fb1a-81df035fc787}">
+        <p14:section name="03 · İlan Bulma" id="{28c88824-5be1-7eba-72bd-0f94aa8fcc9c}">
           <p14:sldIdLst>
             <p14:sldId id="270"/>
             <p14:sldId id="271"/>
             <p14:sldId id="272"/>
           </p14:sldIdLst>
         </p14:section>
-        <p14:section name="04 · Araç Haritası" id="{3e728ace-ff7b-3eb0-bbeb-a6e8cb7aef1a}">
+        <p14:section name="04 · Araç Haritası" id="{f020b0bb-e919-dc9f-cd3a-970e6f3446ac}">
           <p14:sldIdLst>
             <p14:sldId id="273"/>
             <p14:sldId id="274"/>
             <p14:sldId id="275"/>
           </p14:sldIdLst>
         </p14:section>
-        <p14:section name="Kapanış" id="{ac3a448e-ed97-e703-1155-d2c89a135680}">
+        <p14:section name="Kapanış" id="{4a7fa4af-2db5-9f12-87bc-d0d0a5f7854c}">
           <p14:sldIdLst>
             <p14:sldId id="276"/>
             <p14:sldId id="277"/>
@@ -668,7 +668,7 @@
           <a:p>
             <a:r>
               <a:rPr lang="en-US" dirty="0"/>
-              <a:t>Genel akış soldan sağa. Tüm bilgiler tek bir kaynak dosyada durur. Alan CV'leri ve ilana özel CV'ler bu kaynaktan türetilir. Derleme adımı ATS uyumlu PDF oluşturur. Her şey Git'te sürümlenir. Kutuların altındaki yollar kendi depomdaki karşılıkları: info klasöründeki YAML dosyaları, genel_cvler, ilana_ozel_cvler ve Docker içinde LaTeX derleyen build.sh. Alttaki sayılar bu yapının bende nasıl büyüdüğünü gösteriyor.</a:t>
+              <a:t>Genel akış soldan sağa. Tüm bilgiler tek bir kaynak dosyada durur. Alan CV'leri ve ilana özel CV'ler bu kaynaktan türetilir. Derleme adımı ATS uyumlu PDF oluşturur. Her değişiklik Git ile izlenir. Kutuların altındaki yollar kendi depomdaki karşılıkları: info klasöründeki YAML dosyaları, genel_cvler, ilana_ozel_cvler ve Docker içinde LaTeX derleyen build.sh. Alttaki sayılar bu yapının bende nasıl büyüdüğünü gösteriyor.</a:t>
             </a:r>
             <a:endParaRPr lang="en-US" dirty="0"/>
           </a:p>
@@ -756,7 +756,7 @@
           <a:p>
             <a:r>
               <a:rPr lang="en-US" dirty="0"/>
-              <a:t>İlke şu: her bilgi tek bir yerde durur, CV'ler bu kaynaktan türetilir. Kaynak YAML ya da JSON olabilir. Soldaki örnek kendi depomdaki projects.yml dosyasından. Her proje tek bir kayıt; Türkçe ve İngilizce aynı kayıtta duruyor, böylece iki dil birbirinden kopamıyor. Tarih aralığını eylemci reponun ilk ve son commit'inden hesaplıyor. Etiketler hangi alan CV'sine gireceğini belirliyor.</a:t>
+              <a:t>İlke şu: her bilgi tek bir yerde durur, CV'ler bu kaynaktan türetilir. Kaynak YAML ya da JSON olabilir. Soldaki örnek kendi depomdaki projects.yml dosyasından. Her proje tek bir kayıt; Türkçe ve İngilizce aynı kayıtta duruyor, böylece iki dil hep uyumlu kalıyor. Tarih aralığını eylemci deponun ilk ve son commit tarihinden hesaplıyor. Etiketler hangi alan CV'sine gireceğini belirliyor.</a:t>
             </a:r>
             <a:endParaRPr lang="en-US" dirty="0"/>
           </a:p>
@@ -1196,7 +1196,7 @@
           <a:p>
             <a:r>
               <a:rPr lang="en-US" dirty="0"/>
-              <a:t>Zaman en değerli kaynak. Kapalı ilana ya da daha önce başvurduğunuz ilana zaman harcamayın. Eylemcim önce ilanın aktif olup olmadığına, sonra depoda veya LinkedIn'de 'Applied' etiketi olup olmadığına bakıyor. İlan metnini LinkedIn'in herkese açık endpoint'inden curl ile çekiyor. Bunu düşük hacimde ve kişisel kullanım için yapın.</a:t>
+              <a:t>Zaman en değerli kaynak. Kapalı ilana ya da daha önce başvurduğunuz ilana zaman harcamayın. Eylemcim önce ilanın açık olup olmadığına, sonra depoda veya LinkedIn'de 'Applied' etiketi olup olmadığına bakıyor. İlan metnini LinkedIn'in herkese açık sayfasından curl ile çekiyor. Bunu yalnızca kişisel kullanım için ve az sayıda istekle yapın.</a:t>
             </a:r>
             <a:endParaRPr lang="en-US" dirty="0"/>
           </a:p>
@@ -1372,7 +1372,7 @@
           <a:p>
             <a:r>
               <a:rPr lang="en-US" dirty="0"/>
-              <a:t>Hepsi ücretsiz ve açık kaynak. Üstteki beşi CV aracı: Reactive Resume tarayıcıda çalışan bir editör, RenderCV YAML'dan PDF üretiyor, OpenResume'un ayrıştırıcısı ATS testi için çok kullanışlı. Alttaki üçü iş arama eylemcisi: career-ops ve ai-job-search Claude Code gibi CLI eylemcileriyle çalışıyor, benim sistemime çok benzer. ApplyPilot otomatik başvuru yapıyor; dikkatli kullanın, platform koşullarını ihlal edebilir.</a:t>
+              <a:t>Hepsi ücretsiz ve açık kaynak. Üstteki beşi CV aracı: Reactive Resume tarayıcıda çalışan bir CV düzenleyici, RenderCV YAML'dan PDF üretiyor, OpenResume'un ayrıştırıcısı ATS testi için çok kullanışlı. Alttaki üçü iş arama eylemcisi: career-ops ve ai-job-search Claude Code gibi terminal eylemcileriyle çalışıyor, benim sistemime çok benzer. ApplyPilot otomatik başvuru yapıyor; dikkatli kullanın, platform koşullarını ihlal edebilir.</a:t>
             </a:r>
             <a:endParaRPr lang="en-US" dirty="0"/>
           </a:p>
@@ -1460,7 +1460,7 @@
           <a:p>
             <a:r>
               <a:rPr lang="en-US" dirty="0"/>
-              <a:t>Bu servislerin çoğunda işe yarar bir ücretsiz katman var. Ücretli plana geçmeden önce ücretsiz katmanı deneyin. Fiyatlar sık değişir; buradaki değerler Ekim 2026 itibarıyla.</a:t>
+              <a:t>Bu servislerin çoğunun işe yarar bir ücretsiz sürümü var. Ücretli plana geçmeden önce ücretsiz sürümü deneyin. Fiyatlar sık değişir; buradaki değerler Ekim 2026 itibarıyla.</a:t>
             </a:r>
             <a:endParaRPr lang="en-US" dirty="0"/>
           </a:p>
@@ -1812,7 +1812,7 @@
           <a:p>
             <a:r>
               <a:rPr lang="en-US" dirty="0"/>
-              <a:t>Beş adımlık bir yol haritası. İlk adım en önemlisi: tüm deneyim ve projelerinizi tek bir dosyada toplayın. Gerisi bu kaynaktan türer. Sonra şablon, alan CV'leri, ilan başına uyarlama ve takip rutini gelir.</a:t>
+              <a:t>Beş adımlık bir yol haritası. İlk adım en önemlisi: tüm deneyim ve projelerinizi tek bir dosyada toplayın. Gerisi bu kaynaktan türer. Sonra şablon, alan CV'leri, her ilan için uyarlama ve takip rutini gelir.</a:t>
             </a:r>
             <a:endParaRPr lang="en-US" dirty="0"/>
           </a:p>
@@ -2076,7 +2076,7 @@
           <a:p>
             <a:r>
               <a:rPr lang="en-US" dirty="0"/>
-              <a:t>ATS, yani Applicant Tracking System, CV'yi önce metne çevirip alanlara böler. Sonra ilandaki anahtar kelimeleri arar ve adayları sıralar. Son kararı insan verir ama önce ATS'nin sizi doğru okuması gerekir. Kendi PDF'inizi OpenResume'un ayrıştırıcısıyla test edebilirsiniz.</a:t>
+              <a:t>ATS, yani Applicant Tracking System, CV'yi önce metne çevirip alanlara böler. Sonra ilandaki anahtar kelimeleri arar ve adayları sıralar. Son kararı insan verir ama önce ATS'nin sizi doğru okuması gerekir. Kendi PDF'inizi OpenResume'un ayrıştırıcısıyla deneyebilirsiniz.</a:t>
             </a:r>
             <a:endParaRPr lang="en-US" dirty="0"/>
           </a:p>
@@ -2252,7 +2252,7 @@
           <a:p>
             <a:r>
               <a:rPr lang="en-US" dirty="0"/>
-              <a:t>Formül basit: aktif fiil, ne yaptığınız, hangi teknolojiyle yaptığınız ve ölçülebilir sonuç. Buradaki örnek kurgusal; formülü göstermek için. Kendi maddelerinizde yalnızca gerçekten ölçtüğünüz sayıları kullanın.</a:t>
+              <a:t>Formül basit: güçlü bir fiil, ne yaptığınız, hangi teknolojiyle yaptığınız ve ölçülebilir sonuç. Buradaki örnek kurgusal; formülü göstermek için. Kendi maddelerinizde yalnızca gerçekten ölçtüğünüz sayıları kullanın.</a:t>
             </a:r>
             <a:endParaRPr lang="en-US" dirty="0"/>
           </a:p>
@@ -2428,7 +2428,7 @@
           <a:p>
             <a:r>
               <a:rPr lang="en-US" dirty="0"/>
-              <a:t>Bu prompt üç iş yapıyor: ilan ile CV arasındaki boşluğu buluyor, maddeyi formüle göre yeniden yazıyor ve en önemlisi modelin bilgi uydurmasını engelliyor. Üçüncü satırı asla atlamayın.</a:t>
+              <a:t>Bu prompt üç iş yapıyor: ilanda olup CV'de olmayanları buluyor, maddeyi formüle göre yeniden yazıyor ve en önemlisi modelin bilgi uydurmasını engelliyor. Üçüncü satırı asla atlamayın.</a:t>
             </a:r>
             <a:endParaRPr lang="en-US" dirty="0"/>
           </a:p>
@@ -4464,7 +4464,7 @@
                   <a:schemeClr val="tx2"/>
                 </a:solidFill>
               </a:rPr>
-              <a:t>Git ile sürümlenir · Kurallar eylemcilere dosyada verilir</a:t>
+              <a:t>Sürümler Git ile izlenir · Eylemci kuralları dosyada yazılıdır</a:t>
             </a:r>
             <a:endParaRPr lang="en-US" sz="1600" dirty="0"/>
           </a:p>
@@ -5339,7 +5339,7 @@
                   <a:schemeClr val="tx1"/>
                 </a:solidFill>
               </a:rPr>
-              <a:t>TR ve EN birbirinden kopmaz</a:t>
+              <a:t>Türkçe ve İngilizce hep uyumlu kalır</a:t>
             </a:r>
             <a:endParaRPr lang="en-US" sz="1800" dirty="0"/>
           </a:p>
@@ -5422,7 +5422,7 @@
                   <a:schemeClr val="tx2"/>
                 </a:solidFill>
               </a:rPr>
-              <a:t>Etiketler eşler</a:t>
+              <a:t>Etiketle eşleştirme</a:t>
             </a:r>
             <a:endParaRPr lang="en-US" sz="1800" dirty="0"/>
           </a:p>
@@ -5439,7 +5439,7 @@
                   <a:schemeClr val="tx1"/>
                 </a:solidFill>
               </a:rPr>
-              <a:t>Kaydın hangi CV'ye gireceğini belirler</a:t>
+              <a:t>Kayıt, etiketine göre ilgili CV'lere girer</a:t>
             </a:r>
             <a:endParaRPr lang="en-US" sz="1800" dirty="0"/>
           </a:p>
@@ -5522,7 +5522,7 @@
                   <a:schemeClr val="tx2"/>
                 </a:solidFill>
               </a:rPr>
-              <a:t>Tarih kanıttan gelir</a:t>
+              <a:t>Tarihler kanıta dayanır</a:t>
             </a:r>
             <a:endParaRPr lang="en-US" sz="1800" dirty="0"/>
           </a:p>
@@ -5539,7 +5539,7 @@
                   <a:schemeClr val="tx1"/>
                 </a:solidFill>
               </a:rPr>
-              <a:t>Örn. reponun ilk ve son commit'i</a:t>
+              <a:t>Örn. deponun ilk ve son commit tarihi</a:t>
             </a:r>
             <a:endParaRPr lang="en-US" sz="1800" dirty="0"/>
           </a:p>
@@ -5790,7 +5790,7 @@
                   <a:schemeClr val="tx2"/>
                 </a:solidFill>
               </a:rPr>
-              <a:t>Diller eşzamanlı</a:t>
+              <a:t>Diller birlikte güncellenir</a:t>
             </a:r>
             <a:endParaRPr lang="en-US" sz="1800" dirty="0"/>
           </a:p>
@@ -5807,7 +5807,7 @@
                   <a:schemeClr val="tx1"/>
                 </a:solidFill>
               </a:rPr>
-              <a:t>Her değişiklik tüm dillere anlamca eşit yansır</a:t>
+              <a:t>Her değişiklik tüm dillere aynı anlamla yansır</a:t>
             </a:r>
             <a:endParaRPr lang="en-US" sz="1800" dirty="0"/>
           </a:p>
@@ -5912,7 +5912,7 @@
                   <a:schemeClr val="tx2"/>
                 </a:solidFill>
               </a:rPr>
-              <a:t>Sıfır uydurma</a:t>
+              <a:t>Uydurma yok</a:t>
             </a:r>
             <a:endParaRPr lang="en-US" sz="1800" dirty="0"/>
           </a:p>
@@ -5929,7 +5929,7 @@
                   <a:schemeClr val="tx1"/>
                 </a:solidFill>
               </a:rPr>
-              <a:t>Gerçek olmayan bilgi yazılmaz; ilan canlı doğrulanır</a:t>
+              <a:t>Gerçek olmayan bilgi yazılmaz; ilan kaynağından doğrulanır</a:t>
             </a:r>
             <a:endParaRPr lang="en-US" sz="1800" dirty="0"/>
           </a:p>
@@ -6156,7 +6156,7 @@
                   <a:schemeClr val="tx2"/>
                 </a:solidFill>
               </a:rPr>
-              <a:t>Başvuru anı korunur</a:t>
+              <a:t>Gönderilen CV değişmez</a:t>
             </a:r>
             <a:endParaRPr lang="en-US" sz="1800" dirty="0"/>
           </a:p>
@@ -6173,7 +6173,7 @@
                   <a:schemeClr val="tx1"/>
                 </a:solidFill>
               </a:rPr>
-              <a:t>Gönderilen CV sonradan değiştirilmez</a:t>
+              <a:t>Başvurudan sonra paket olduğu gibi saklanır</a:t>
             </a:r>
             <a:endParaRPr lang="en-US" sz="1800" dirty="0"/>
           </a:p>
@@ -6278,7 +6278,7 @@
                   <a:schemeClr val="tx2"/>
                 </a:solidFill>
               </a:rPr>
-              <a:t>Kalite kapısı</a:t>
+              <a:t>Kalite kontrolü</a:t>
             </a:r>
             <a:endParaRPr lang="en-US" sz="1800" dirty="0"/>
           </a:p>
@@ -6295,7 +6295,7 @@
                   <a:schemeClr val="tx1"/>
                 </a:solidFill>
               </a:rPr>
-              <a:t>Taşma kontrolü, sayfa sayfa görsel kontrol, ATS metin çıkarımı</a:t>
+              <a:t>Taşan satır, sayfa sayfa görsel inceleme ve ATS metin testi</a:t>
             </a:r>
             <a:endParaRPr lang="en-US" sz="1800" dirty="0"/>
           </a:p>
@@ -7012,7 +7012,7 @@
                   <a:schemeClr val="tx2"/>
                 </a:solidFill>
               </a:rPr>
-              <a:t>İlanı eşleştir</a:t>
+              <a:t>İlana uygun CV seç</a:t>
             </a:r>
             <a:endParaRPr lang="en-US" sz="1700" dirty="0"/>
           </a:p>
@@ -7026,7 +7026,7 @@
                   <a:schemeClr val="tx1"/>
                 </a:solidFill>
               </a:rPr>
-              <a:t>İlan metni analiz edilir; en uygun CV seçilir ya da yeni CV önerilir</a:t>
+              <a:t>İlan metni incelenir; en uygun CV seçilir ya da yeni CV önerilir</a:t>
             </a:r>
             <a:endParaRPr lang="en-US" sz="1700" dirty="0"/>
           </a:p>
@@ -8483,7 +8483,7 @@
                   <a:schemeClr val="tx1"/>
                 </a:solidFill>
               </a:rPr>
-              <a:t>İş uyarıları, YZ destekli iş arama</a:t>
+              <a:t>İlan bildirimleri, YZ destekli iş arama</a:t>
             </a:r>
             <a:endParaRPr lang="en-US" sz="1900" dirty="0"/>
           </a:p>
@@ -9139,7 +9139,7 @@
                   <a:schemeClr val="tx2"/>
                 </a:solidFill>
               </a:rPr>
-              <a:t>Aktif mi?</a:t>
+              <a:t>İlan açık mı?</a:t>
             </a:r>
             <a:endParaRPr lang="en-US" sz="1900" dirty="0"/>
           </a:p>
@@ -9153,7 +9153,7 @@
                   <a:schemeClr val="tx1"/>
                 </a:solidFill>
               </a:rPr>
-              <a:t>"Başvuru kabul etmiyor" uyarısı varsa veya Başvur butonu yoksa ele</a:t>
+              <a:t>"Başvuru kabul etmiyor" uyarısı varsa ya da Başvur düğmesi yoksa ele</a:t>
             </a:r>
             <a:endParaRPr lang="en-US" sz="1900" dirty="0"/>
           </a:p>
@@ -9365,7 +9365,7 @@
                   <a:schemeClr val="tx1"/>
                 </a:solidFill>
               </a:rPr>
-              <a:t>LinkedIn guest endpoint + curl ile IS_ILANI.md</a:t>
+              <a:t>LinkedIn'in herkese açık sayfasından curl ile IS_ILANI.md dosyasına</a:t>
             </a:r>
             <a:endParaRPr lang="en-US" sz="1900" dirty="0"/>
           </a:p>
@@ -9741,7 +9741,7 @@
                   <a:schemeClr val="tx1"/>
                 </a:solidFill>
               </a:rPr>
-              <a:t>Kişisel kullanım, düşük hacim. Platform kullanım koşullarına uyun.</a:t>
+              <a:t>Yalnızca kişisel kullanım ve az sayıda istek. Platformun kullanım koşullarına uyun.</a:t>
             </a:r>
             <a:endParaRPr lang="en-US" sz="1500" dirty="0"/>
           </a:p>
@@ -9887,7 +9887,7 @@
                   <a:schemeClr val="tx2"/>
                 </a:solidFill>
               </a:rPr>
-              <a:t>Gizli Pazar: Doğrudan İletişim</a:t>
+              <a:t>Doğrudan İletişim: İlansız İşler</a:t>
             </a:r>
             <a:endParaRPr lang="en-US" sz="3400" dirty="0"/>
           </a:p>
@@ -11087,7 +11087,7 @@
                             <a:schemeClr val="tx1"/>
                           </a:solidFill>
                         </a:rPr>
-                        <a:t>Tarayıcıda CV editörü; self-host, JSON, YZ desteği</a:t>
+                        <a:t>Tarayıcıda CV düzenleyici; kendi sunucuna kurulur, YZ desteği</a:t>
                       </a:r>
                       <a:endParaRPr lang="en-US" sz="1400" dirty="0"/>
                     </a:p>
@@ -11579,7 +11579,7 @@
                             <a:schemeClr val="tx1"/>
                           </a:solidFill>
                         </a:rPr>
-                        <a:t>Standart CV şeması ve CLI</a:t>
+                        <a:t>Standart CV şeması ve komut satırı aracı</a:t>
                       </a:r>
                       <a:endParaRPr lang="en-US" sz="1400" dirty="0"/>
                     </a:p>
@@ -12317,7 +12317,7 @@
                             <a:schemeClr val="tx1"/>
                           </a:solidFill>
                         </a:rPr>
-                        <a:t>CLI eylemcisi: ilan tarar, 1-5 puanlar, CV uyarlar, takip eder</a:t>
+                        <a:t>Terminal eylemcisi: ilan tarar, 1-5 puanlar, CV uyarlar, takip eder</a:t>
                       </a:r>
                       <a:endParaRPr lang="en-US" sz="1400" dirty="0"/>
                     </a:p>
@@ -12563,7 +12563,7 @@
                             <a:schemeClr val="tx1"/>
                           </a:solidFill>
                         </a:rPr>
-                        <a:t>Claude Code ile ilan değerlendirme, CV, ön yazı, mülakat</a:t>
+                        <a:t>Claude Code ile ilan değerlendirme, CV, ön yazı, mülakat hazırlığı</a:t>
                       </a:r>
                       <a:endParaRPr lang="en-US" sz="1400" dirty="0"/>
                     </a:p>
@@ -13062,7 +13062,7 @@
                   <a:schemeClr val="tx2"/>
                 </a:solidFill>
               </a:rPr>
-              <a:t>Ücretli ve Freemium Servisler</a:t>
+              <a:t>Ücretli Servisler ve Ücretsiz Sürümleri</a:t>
             </a:r>
             <a:endParaRPr lang="en-US" sz="3400" dirty="0"/>
           </a:p>
@@ -13726,7 +13726,7 @@
                             <a:schemeClr val="tx1"/>
                           </a:solidFill>
                         </a:rPr>
-                        <a:t>1 CV, 3 PDF</a:t>
+                        <a:t>1 CV, 3 PDF indirme</a:t>
                       </a:r>
                       <a:endParaRPr lang="en-US" sz="1600" dirty="0"/>
                     </a:p>
@@ -14239,7 +14239,7 @@
                   <a:schemeClr val="tx1"/>
                 </a:solidFill>
               </a:rPr>
-              <a:t>Genel LLM'ler (ChatGPT, Claude, Gemini): ücretsiz katman mevcut. Fiyatlar Ekim 2026 itibarıyla; değişebilir.</a:t>
+              <a:t>Genel LLM'lerin (ChatGPT, Claude, Gemini) ücretsiz sürümleri var. Fiyatlar Ekim 2026 itibarıyladır; değişebilir.</a:t>
             </a:r>
             <a:endParaRPr lang="en-US" sz="1400" dirty="0"/>
           </a:p>
@@ -15167,7 +15167,7 @@
                   <a:schemeClr val="tx1"/>
                 </a:solidFill>
               </a:rPr>
-              <a:t>OpenResume ayrıştırıcı, Jobscan ücretsiz taramaları</a:t>
+              <a:t>OpenResume ayrıştırıcısı, Jobscan'in ücretsiz taramaları</a:t>
             </a:r>
             <a:endParaRPr lang="en-US" sz="1900" dirty="0"/>
           </a:p>
@@ -15289,7 +15289,7 @@
                   <a:schemeClr val="tx1"/>
                 </a:solidFill>
               </a:rPr>
-              <a:t>Huntr veya Teal ücretsiz katmanı</a:t>
+              <a:t>Huntr ya da Teal'ın ücretsiz sürümü</a:t>
             </a:r>
             <a:endParaRPr lang="en-US" sz="1900" dirty="0"/>
           </a:p>
@@ -15757,7 +15757,7 @@
                   <a:schemeClr val="tx1"/>
                 </a:solidFill>
               </a:rPr>
-              <a:t>Telefon, adres, kimlik bilgisini bulut LLM'e yükleme; maskele veya yerel model kullan</a:t>
+              <a:t>Telefon, adres ve kimlik bilgisini bulut LLM'lere yükleme; gizle ya da yerel model kullan</a:t>
             </a:r>
             <a:endParaRPr lang="en-US" sz="1800" dirty="0"/>
           </a:p>
@@ -15957,7 +15957,7 @@
                   <a:schemeClr val="tx1"/>
                 </a:solidFill>
               </a:rPr>
-              <a:t>Kalıp ifadeler, abartılı sıfatlar; kendi sesini koru</a:t>
+              <a:t>Kalıp ifadeler, abartılı sıfatlar; kendi üslubunu koru</a:t>
             </a:r>
             <a:endParaRPr lang="en-US" sz="1800" dirty="0"/>
           </a:p>
@@ -16711,7 +16711,7 @@
                   <a:schemeClr val="tx2"/>
                 </a:solidFill>
               </a:rPr>
-              <a:t>İlan başına</a:t>
+              <a:t>Her ilan için</a:t>
             </a:r>
             <a:endParaRPr lang="en-US" sz="1900" dirty="0"/>
           </a:p>
@@ -16728,7 +16728,7 @@
                   <a:schemeClr val="tx1"/>
                 </a:solidFill>
               </a:rPr>
-              <a:t>LLM ile boşluk analizi, uyarlama, insan kontrolü</a:t>
+              <a:t>LLM ile eksik tespiti, uyarlama, insan kontrolü</a:t>
             </a:r>
             <a:endParaRPr lang="en-US" sz="1900" dirty="0"/>
           </a:p>
@@ -16848,7 +16848,7 @@
                   <a:schemeClr val="tx1"/>
                 </a:solidFill>
               </a:rPr>
-              <a:t>Başvuru takibi, ilan uyarıları, eski ilan temizliği</a:t>
+              <a:t>Başvuru takibi, ilan bildirimleri, eski ilan temizliği</a:t>
             </a:r>
             <a:endParaRPr lang="en-US" sz="1900" dirty="0"/>
           </a:p>
@@ -17691,7 +17691,7 @@
                   <a:schemeClr val="bg1"/>
                 </a:solidFill>
               </a:rPr>
-              <a:t>Farkı oluşturan araç değil; doğru, ölçülebilir ve ilana uygun içerik.</a:t>
+              <a:t>Farkı araç değil; doğru, ölçülebilir ve ilana uygun içerik belirler.</a:t>
             </a:r>
             <a:endParaRPr lang="en-US" sz="1800" dirty="0"/>
           </a:p>
@@ -18389,7 +18389,7 @@
                   <a:schemeClr val="tx1"/>
                 </a:solidFill>
               </a:rPr>
-              <a:t>Son kararı insan verir. Kendi PDF'inizi OpenResume ayrıştırıcısıyla test edin: ATS'nin gördüğü metni görürsünüz.</a:t>
+              <a:t>Son kararı insan verir. Kendi PDF'inizi OpenResume ayrıştırıcısıyla deneyin: ATS'nin gördüğü metni siz de görürsünüz.</a:t>
             </a:r>
             <a:endParaRPr lang="en-US" sz="1600" dirty="0"/>
           </a:p>
@@ -18927,7 +18927,7 @@
                   <a:schemeClr val="tx2"/>
                 </a:solidFill>
               </a:rPr>
-              <a:t>Ters kronolojik sıra</a:t>
+              <a:t>Yeniden eskiye sıralama</a:t>
             </a:r>
             <a:endParaRPr lang="en-US" sz="1700" dirty="0"/>
           </a:p>
@@ -19606,7 +19606,7 @@
                   <a:schemeClr val="bg1"/>
                 </a:solidFill>
               </a:rPr>
-              <a:t>Aktif fiil</a:t>
+              <a:t>Güçlü fiil</a:t>
             </a:r>
             <a:endParaRPr lang="en-US" sz="1800" dirty="0"/>
           </a:p>
@@ -20839,7 +20839,7 @@
                   <a:schemeClr val="tx2"/>
                 </a:solidFill>
               </a:rPr>
-              <a:t>Boşluk analizi</a:t>
+              <a:t>Eksikleri bulma</a:t>
             </a:r>
             <a:endParaRPr lang="en-US" sz="1800" dirty="0"/>
           </a:p>
@@ -20856,7 +20856,7 @@
                   <a:schemeClr val="tx1"/>
                 </a:solidFill>
               </a:rPr>
-              <a:t>İlanda olup CV'de olmayanı bul</a:t>
+              <a:t>İlanda olup CV'de olmayanı listele</a:t>
             </a:r>
             <a:endParaRPr lang="en-US" sz="1800" dirty="0"/>
           </a:p>
@@ -20939,7 +20939,7 @@
                   <a:schemeClr val="tx2"/>
                 </a:solidFill>
               </a:rPr>
-              <a:t>Biçim</a:t>
+              <a:t>Yeniden yazma</a:t>
             </a:r>
             <a:endParaRPr lang="en-US" sz="1800" dirty="0"/>
           </a:p>
@@ -20956,7 +20956,7 @@
                   <a:schemeClr val="tx1"/>
                 </a:solidFill>
               </a:rPr>
-              <a:t>Aktif fiil + iş + sonuç</a:t>
+              <a:t>Güçlü fiil + iş + sonuç biçiminde</a:t>
             </a:r>
             <a:endParaRPr lang="en-US" sz="1800" dirty="0"/>
           </a:p>
@@ -21039,7 +21039,7 @@
                   <a:schemeClr val="tx2"/>
                 </a:solidFill>
               </a:rPr>
-              <a:t>Uydurma freni</a:t>
+              <a:t>Uydurmayı engelleme</a:t>
             </a:r>
             <a:endParaRPr lang="en-US" sz="1800" dirty="0"/>
           </a:p>
@@ -21056,7 +21056,7 @@
                   <a:schemeClr val="tx1"/>
                 </a:solidFill>
               </a:rPr>
-              <a:t>Olmayan bilgiyi ekletme</a:t>
+              <a:t>CV'de olmayan bilgi eklenmez</a:t>
             </a:r>
             <a:endParaRPr lang="en-US" sz="1800" dirty="0"/>
           </a:p>
@@ -21191,7 +21191,7 @@
                 <a:ea typeface="Courier New" pitchFamily="34" charset="-122"/>
                 <a:cs typeface="Courier New" pitchFamily="34" charset="-120"/>
               </a:rPr>
-              <a:t>2) Maddeyi "aktif fiil + iş + sonuç"</a:t>
+              <a:t>2) Maddeyi "güçlü fiil + iş + sonuç"</a:t>
             </a:r>
             <a:endParaRPr lang="en-US" sz="1600" dirty="0"/>
           </a:p>
@@ -22051,7 +22051,7 @@
                   <a:schemeClr val="bg1"/>
                 </a:solidFill>
               </a:rPr>
-              <a:t>Çözüm: tek doğruluk kaynağı + derleme + sürüm kontrolü + eylemci otomasyonu</a:t>
+              <a:t>Çözüm: tek doğruluk kaynağı + derleme + sürüm kontrolü + eylemciyle otomasyon</a:t>
             </a:r>
             <a:endParaRPr lang="en-US" sz="1800" dirty="0"/>
           </a:p>

</xml_diff>